<commit_message>
Redraw brand cycle slide as 4-step loop with growing rings
Co-Authored-By: Claude Sonnet 5.5 <noreply@anthropic.com>
Claude-Session: https://claude.ai/code/session_01MxdMxhi7qZAPC9aBAhtpWC
</commit_message>
<xml_diff>
--- a/kyoiku-jisshu/共育実習_図解.pptx
+++ b/kyoiku-jisshu/共育実習_図解.pptx
@@ -8746,17 +8746,533 @@
       </p:sp>
       <p:sp>
         <p:nvSpPr>
-          <p:cNvPr id="6" name="中央円"/>
+          <p:cNvPr id="6" name="矢印_1から2"/>
           <p:cNvSpPr/>
           <p:nvPr/>
         </p:nvSpPr>
         <p:spPr>
           <a:xfrm>
-            <a:off x="5137553" y="2339736"/>
-            <a:ext cx="1916892" cy="1916892"/>
+            <a:off x="4228439" y="1677280"/>
+            <a:ext cx="3735121" cy="451033"/>
+          </a:xfrm>
+          <a:prstGeom prst="rightArrow">
+            <a:avLst>
+              <a:gd name="adj1" fmla="val 50000"/>
+              <a:gd name="adj2" fmla="val 55000"/>
+            </a:avLst>
+          </a:prstGeom>
+          <a:solidFill>
+            <a:srgbClr val="3FB39D"/>
+          </a:solidFill>
+          <a:ln>
+            <a:noFill/>
+          </a:ln>
+          <a:effectLst/>
+        </p:spPr>
+        <p:style>
+          <a:lnRef idx="1">
+            <a:schemeClr val="accent1"/>
+          </a:lnRef>
+          <a:fillRef idx="3">
+            <a:schemeClr val="accent1"/>
+          </a:fillRef>
+          <a:effectRef idx="0">
+            <a:schemeClr val="accent1"/>
+          </a:effectRef>
+          <a:fontRef idx="minor">
+            <a:schemeClr val="lt1"/>
+          </a:fontRef>
+        </p:style>
+        <p:txBody>
+          <a:bodyPr rtlCol="0" anchor="ctr"/>
+          <a:lstStyle/>
+          <a:p>
+            <a:pPr algn="ctr"/>
+          </a:p>
+        </p:txBody>
+      </p:sp>
+      <p:sp>
+        <p:nvSpPr>
+          <p:cNvPr id="7" name="矢印_2から3"/>
+          <p:cNvSpPr/>
+          <p:nvPr/>
+        </p:nvSpPr>
+        <p:spPr>
+          <a:xfrm>
+            <a:off x="9711315" y="2579347"/>
+            <a:ext cx="394654" cy="944351"/>
+          </a:xfrm>
+          <a:prstGeom prst="downArrow">
+            <a:avLst>
+              <a:gd name="adj1" fmla="val 50000"/>
+              <a:gd name="adj2" fmla="val 55000"/>
+            </a:avLst>
+          </a:prstGeom>
+          <a:solidFill>
+            <a:srgbClr val="86D6C4"/>
+          </a:solidFill>
+          <a:ln>
+            <a:noFill/>
+          </a:ln>
+          <a:effectLst/>
+        </p:spPr>
+        <p:style>
+          <a:lnRef idx="1">
+            <a:schemeClr val="accent1"/>
+          </a:lnRef>
+          <a:fillRef idx="3">
+            <a:schemeClr val="accent1"/>
+          </a:fillRef>
+          <a:effectRef idx="0">
+            <a:schemeClr val="accent1"/>
+          </a:effectRef>
+          <a:fontRef idx="minor">
+            <a:schemeClr val="lt1"/>
+          </a:fontRef>
+        </p:style>
+        <p:txBody>
+          <a:bodyPr rtlCol="0" anchor="ctr"/>
+          <a:lstStyle/>
+          <a:p>
+            <a:pPr algn="ctr"/>
+          </a:p>
+        </p:txBody>
+      </p:sp>
+      <p:sp>
+        <p:nvSpPr>
+          <p:cNvPr id="8" name="矢印_3から4"/>
+          <p:cNvSpPr/>
+          <p:nvPr/>
+        </p:nvSpPr>
+        <p:spPr>
+          <a:xfrm>
+            <a:off x="4228439" y="4045206"/>
+            <a:ext cx="3735121" cy="451033"/>
+          </a:xfrm>
+          <a:prstGeom prst="leftArrow">
+            <a:avLst>
+              <a:gd name="adj1" fmla="val 50000"/>
+              <a:gd name="adj2" fmla="val 55000"/>
+            </a:avLst>
+          </a:prstGeom>
+          <a:solidFill>
+            <a:srgbClr val="F28C3C"/>
+          </a:solidFill>
+          <a:ln>
+            <a:noFill/>
+          </a:ln>
+          <a:effectLst/>
+        </p:spPr>
+        <p:style>
+          <a:lnRef idx="1">
+            <a:schemeClr val="accent1"/>
+          </a:lnRef>
+          <a:fillRef idx="3">
+            <a:schemeClr val="accent1"/>
+          </a:fillRef>
+          <a:effectRef idx="0">
+            <a:schemeClr val="accent1"/>
+          </a:effectRef>
+          <a:fontRef idx="minor">
+            <a:schemeClr val="lt1"/>
+          </a:fontRef>
+        </p:style>
+        <p:txBody>
+          <a:bodyPr rtlCol="0" anchor="ctr"/>
+          <a:lstStyle/>
+          <a:p>
+            <a:pPr algn="ctr"/>
+          </a:p>
+        </p:txBody>
+      </p:sp>
+      <p:sp>
+        <p:nvSpPr>
+          <p:cNvPr id="9" name="矢印_4から1"/>
+          <p:cNvSpPr/>
+          <p:nvPr/>
+        </p:nvSpPr>
+        <p:spPr>
+          <a:xfrm>
+            <a:off x="2086030" y="2579347"/>
+            <a:ext cx="394654" cy="944351"/>
+          </a:xfrm>
+          <a:prstGeom prst="upArrow">
+            <a:avLst>
+              <a:gd name="adj1" fmla="val 50000"/>
+              <a:gd name="adj2" fmla="val 55000"/>
+            </a:avLst>
+          </a:prstGeom>
+          <a:solidFill>
+            <a:srgbClr val="2E9E8A"/>
+          </a:solidFill>
+          <a:ln>
+            <a:noFill/>
+          </a:ln>
+          <a:effectLst/>
+        </p:spPr>
+        <p:style>
+          <a:lnRef idx="1">
+            <a:schemeClr val="accent1"/>
+          </a:lnRef>
+          <a:fillRef idx="3">
+            <a:schemeClr val="accent1"/>
+          </a:fillRef>
+          <a:effectRef idx="0">
+            <a:schemeClr val="accent1"/>
+          </a:effectRef>
+          <a:fontRef idx="minor">
+            <a:schemeClr val="lt1"/>
+          </a:fontRef>
+        </p:style>
+        <p:txBody>
+          <a:bodyPr rtlCol="0" anchor="ctr"/>
+          <a:lstStyle/>
+          <a:p>
+            <a:pPr algn="ctr"/>
+          </a:p>
+        </p:txBody>
+      </p:sp>
+      <p:sp>
+        <p:nvSpPr>
+          <p:cNvPr id="10" name="循環ラベル"/>
+          <p:cNvSpPr txBox="1"/>
+          <p:nvPr/>
+        </p:nvSpPr>
+        <p:spPr>
+          <a:xfrm>
+            <a:off x="2621632" y="2917623"/>
+            <a:ext cx="3241803" cy="211421"/>
+          </a:xfrm>
+          <a:prstGeom prst="rect">
+            <a:avLst/>
+          </a:prstGeom>
+          <a:noFill/>
+        </p:spPr>
+        <p:txBody>
+          <a:bodyPr wrap="square" lIns="0" rIns="0" tIns="0" bIns="0" anchor="t">
+            <a:spAutoFit/>
+          </a:bodyPr>
+          <a:lstStyle/>
+          <a:p>
+            <a:pPr algn="l"/>
+            <a:r>
+              <a:rPr sz="1165" b="1">
+                <a:solidFill>
+                  <a:srgbClr val="1F7D6C"/>
+                </a:solidFill>
+                <a:latin typeface="游ゴシック"/>
+                <a:ea typeface="游ゴシック"/>
+                <a:cs typeface="游ゴシック"/>
+              </a:rPr>
+              <a:t>次の共育実習につながる</a:t>
+            </a:r>
+          </a:p>
+        </p:txBody>
+      </p:sp>
+      <p:sp>
+        <p:nvSpPr>
+          <p:cNvPr id="11" name="広がる輪"/>
+          <p:cNvSpPr/>
+          <p:nvPr/>
+        </p:nvSpPr>
+        <p:spPr>
+          <a:xfrm>
+            <a:off x="5306691" y="2156504"/>
+            <a:ext cx="1578617" cy="1578617"/>
           </a:xfrm>
           <a:prstGeom prst="ellipse">
             <a:avLst/>
+          </a:prstGeom>
+          <a:solidFill>
+            <a:srgbClr val="D3EEE4"/>
+          </a:solidFill>
+          <a:ln>
+            <a:noFill/>
+          </a:ln>
+          <a:effectLst/>
+        </p:spPr>
+        <p:style>
+          <a:lnRef idx="1">
+            <a:schemeClr val="accent1"/>
+          </a:lnRef>
+          <a:fillRef idx="3">
+            <a:schemeClr val="accent1"/>
+          </a:fillRef>
+          <a:effectRef idx="0">
+            <a:schemeClr val="accent1"/>
+          </a:effectRef>
+          <a:fontRef idx="minor">
+            <a:schemeClr val="lt1"/>
+          </a:fontRef>
+        </p:style>
+        <p:txBody>
+          <a:bodyPr rtlCol="0" anchor="ctr"/>
+          <a:lstStyle/>
+          <a:p>
+            <a:pPr algn="ctr"/>
+          </a:p>
+        </p:txBody>
+      </p:sp>
+      <p:sp>
+        <p:nvSpPr>
+          <p:cNvPr id="12" name="広がる輪"/>
+          <p:cNvSpPr/>
+          <p:nvPr/>
+        </p:nvSpPr>
+        <p:spPr>
+          <a:xfrm>
+            <a:off x="5489923" y="2339736"/>
+            <a:ext cx="1212152" cy="1212152"/>
+          </a:xfrm>
+          <a:prstGeom prst="ellipse">
+            <a:avLst/>
+          </a:prstGeom>
+          <a:solidFill>
+            <a:srgbClr val="A9E0D0"/>
+          </a:solidFill>
+          <a:ln>
+            <a:noFill/>
+          </a:ln>
+          <a:effectLst/>
+        </p:spPr>
+        <p:style>
+          <a:lnRef idx="1">
+            <a:schemeClr val="accent1"/>
+          </a:lnRef>
+          <a:fillRef idx="3">
+            <a:schemeClr val="accent1"/>
+          </a:fillRef>
+          <a:effectRef idx="0">
+            <a:schemeClr val="accent1"/>
+          </a:effectRef>
+          <a:fontRef idx="minor">
+            <a:schemeClr val="lt1"/>
+          </a:fontRef>
+        </p:style>
+        <p:txBody>
+          <a:bodyPr rtlCol="0" anchor="ctr"/>
+          <a:lstStyle/>
+          <a:p>
+            <a:pPr algn="ctr"/>
+          </a:p>
+        </p:txBody>
+      </p:sp>
+      <p:sp>
+        <p:nvSpPr>
+          <p:cNvPr id="13" name="広がる輪"/>
+          <p:cNvSpPr/>
+          <p:nvPr/>
+        </p:nvSpPr>
+        <p:spPr>
+          <a:xfrm>
+            <a:off x="5673156" y="2522968"/>
+            <a:ext cx="845687" cy="845687"/>
+          </a:xfrm>
+          <a:prstGeom prst="ellipse">
+            <a:avLst/>
+          </a:prstGeom>
+          <a:solidFill>
+            <a:srgbClr val="54C5AF"/>
+          </a:solidFill>
+          <a:ln>
+            <a:noFill/>
+          </a:ln>
+          <a:effectLst/>
+        </p:spPr>
+        <p:style>
+          <a:lnRef idx="1">
+            <a:schemeClr val="accent1"/>
+          </a:lnRef>
+          <a:fillRef idx="3">
+            <a:schemeClr val="accent1"/>
+          </a:fillRef>
+          <a:effectRef idx="0">
+            <a:schemeClr val="accent1"/>
+          </a:effectRef>
+          <a:fontRef idx="minor">
+            <a:schemeClr val="lt1"/>
+          </a:fontRef>
+        </p:style>
+        <p:txBody>
+          <a:bodyPr rtlCol="0" anchor="ctr"/>
+          <a:lstStyle/>
+          <a:p>
+            <a:pPr algn="ctr"/>
+          </a:p>
+        </p:txBody>
+      </p:sp>
+      <p:sp>
+        <p:nvSpPr>
+          <p:cNvPr id="14" name="中央1"/>
+          <p:cNvSpPr txBox="1"/>
+          <p:nvPr/>
+        </p:nvSpPr>
+        <p:spPr>
+          <a:xfrm>
+            <a:off x="5616776" y="2706201"/>
+            <a:ext cx="958446" cy="239611"/>
+          </a:xfrm>
+          <a:prstGeom prst="rect">
+            <a:avLst/>
+          </a:prstGeom>
+          <a:noFill/>
+        </p:spPr>
+        <p:txBody>
+          <a:bodyPr wrap="square" lIns="0" rIns="0" tIns="0" bIns="0" anchor="ctr">
+            <a:spAutoFit/>
+          </a:bodyPr>
+          <a:lstStyle/>
+          <a:p>
+            <a:pPr algn="ctr"/>
+            <a:r>
+              <a:rPr sz="1331" b="1">
+                <a:solidFill>
+                  <a:srgbClr val="FFFFFF"/>
+                </a:solidFill>
+                <a:latin typeface="游ゴシック"/>
+                <a:ea typeface="游ゴシック"/>
+                <a:cs typeface="游ゴシック"/>
+              </a:rPr>
+              <a:t>実習</a:t>
+            </a:r>
+          </a:p>
+        </p:txBody>
+      </p:sp>
+      <p:sp>
+        <p:nvSpPr>
+          <p:cNvPr id="15" name="中央2"/>
+          <p:cNvSpPr txBox="1"/>
+          <p:nvPr/>
+        </p:nvSpPr>
+        <p:spPr>
+          <a:xfrm>
+            <a:off x="5616776" y="2917623"/>
+            <a:ext cx="958446" cy="239611"/>
+          </a:xfrm>
+          <a:prstGeom prst="rect">
+            <a:avLst/>
+          </a:prstGeom>
+          <a:noFill/>
+        </p:spPr>
+        <p:txBody>
+          <a:bodyPr wrap="square" lIns="0" rIns="0" tIns="0" bIns="0" anchor="ctr">
+            <a:spAutoFit/>
+          </a:bodyPr>
+          <a:lstStyle/>
+          <a:p>
+            <a:pPr algn="ctr"/>
+            <a:r>
+              <a:rPr sz="1331" b="1">
+                <a:solidFill>
+                  <a:srgbClr val="FFFFFF"/>
+                </a:solidFill>
+                <a:latin typeface="游ゴシック"/>
+                <a:ea typeface="游ゴシック"/>
+                <a:cs typeface="游ゴシック"/>
+              </a:rPr>
+              <a:t>ブランド</a:t>
+            </a:r>
+          </a:p>
+        </p:txBody>
+      </p:sp>
+      <p:sp>
+        <p:nvSpPr>
+          <p:cNvPr id="16" name="帯"/>
+          <p:cNvSpPr/>
+          <p:nvPr/>
+        </p:nvSpPr>
+        <p:spPr>
+          <a:xfrm>
+            <a:off x="5461734" y="3763310"/>
+            <a:ext cx="1268531" cy="239611"/>
+          </a:xfrm>
+          <a:prstGeom prst="roundRect">
+            <a:avLst>
+              <a:gd name="adj" fmla="val 50000"/>
+            </a:avLst>
+          </a:prstGeom>
+          <a:solidFill>
+            <a:srgbClr val="F28C3C"/>
+          </a:solidFill>
+          <a:ln>
+            <a:noFill/>
+          </a:ln>
+          <a:effectLst/>
+        </p:spPr>
+        <p:style>
+          <a:lnRef idx="1">
+            <a:schemeClr val="accent1"/>
+          </a:lnRef>
+          <a:fillRef idx="3">
+            <a:schemeClr val="accent1"/>
+          </a:fillRef>
+          <a:effectRef idx="0">
+            <a:schemeClr val="accent1"/>
+          </a:effectRef>
+          <a:fontRef idx="minor">
+            <a:schemeClr val="lt1"/>
+          </a:fontRef>
+        </p:style>
+        <p:txBody>
+          <a:bodyPr rtlCol="0" anchor="ctr"/>
+          <a:lstStyle/>
+          <a:p>
+            <a:pPr algn="ctr"/>
+          </a:p>
+        </p:txBody>
+      </p:sp>
+      <p:sp>
+        <p:nvSpPr>
+          <p:cNvPr id="17" name="帯文字"/>
+          <p:cNvSpPr txBox="1"/>
+          <p:nvPr/>
+        </p:nvSpPr>
+        <p:spPr>
+          <a:xfrm>
+            <a:off x="5461734" y="3763310"/>
+            <a:ext cx="1268531" cy="239611"/>
+          </a:xfrm>
+          <a:prstGeom prst="rect">
+            <a:avLst/>
+          </a:prstGeom>
+          <a:noFill/>
+        </p:spPr>
+        <p:txBody>
+          <a:bodyPr wrap="square" lIns="0" rIns="0" tIns="0" bIns="0" anchor="ctr">
+            <a:spAutoFit/>
+          </a:bodyPr>
+          <a:lstStyle/>
+          <a:p>
+            <a:pPr algn="ctr"/>
+            <a:r>
+              <a:rPr sz="1054" b="1">
+                <a:solidFill>
+                  <a:srgbClr val="FFFFFF"/>
+                </a:solidFill>
+                <a:latin typeface="游ゴシック"/>
+                <a:ea typeface="游ゴシック"/>
+                <a:cs typeface="游ゴシック"/>
+              </a:rPr>
+              <a:t>回るほど育つ</a:t>
+            </a:r>
+          </a:p>
+        </p:txBody>
+      </p:sp>
+      <p:sp>
+        <p:nvSpPr>
+          <p:cNvPr id="18" name="カード_共育実習を行う"/>
+          <p:cNvSpPr/>
+          <p:nvPr/>
+        </p:nvSpPr>
+        <p:spPr>
+          <a:xfrm>
+            <a:off x="451033" y="1268531"/>
+            <a:ext cx="3664647" cy="1198057"/>
+          </a:xfrm>
+          <a:prstGeom prst="roundRect">
+            <a:avLst>
+              <a:gd name="adj" fmla="val 12000"/>
+            </a:avLst>
           </a:prstGeom>
           <a:solidFill>
             <a:srgbClr val="FFFFFF"/>
@@ -8796,14 +9312,104 @@
       </p:sp>
       <p:sp>
         <p:nvSpPr>
-          <p:cNvPr id="7" name="中央ミニ見出し"/>
+          <p:cNvPr id="19" name="カード色バー"/>
+          <p:cNvSpPr/>
+          <p:nvPr/>
+        </p:nvSpPr>
+        <p:spPr>
+          <a:xfrm>
+            <a:off x="451033" y="1479953"/>
+            <a:ext cx="56379" cy="775213"/>
+          </a:xfrm>
+          <a:prstGeom prst="roundRect">
+            <a:avLst>
+              <a:gd name="adj" fmla="val 50000"/>
+            </a:avLst>
+          </a:prstGeom>
+          <a:solidFill>
+            <a:srgbClr val="3FB39D"/>
+          </a:solidFill>
+          <a:ln>
+            <a:noFill/>
+          </a:ln>
+          <a:effectLst/>
+        </p:spPr>
+        <p:style>
+          <a:lnRef idx="1">
+            <a:schemeClr val="accent1"/>
+          </a:lnRef>
+          <a:fillRef idx="3">
+            <a:schemeClr val="accent1"/>
+          </a:fillRef>
+          <a:effectRef idx="0">
+            <a:schemeClr val="accent1"/>
+          </a:effectRef>
+          <a:fontRef idx="minor">
+            <a:schemeClr val="lt1"/>
+          </a:fontRef>
+        </p:style>
+        <p:txBody>
+          <a:bodyPr rtlCol="0" anchor="ctr"/>
+          <a:lstStyle/>
+          <a:p>
+            <a:pPr algn="ctr"/>
+          </a:p>
+        </p:txBody>
+      </p:sp>
+      <p:sp>
+        <p:nvSpPr>
+          <p:cNvPr id="20" name="番号"/>
+          <p:cNvSpPr/>
+          <p:nvPr/>
+        </p:nvSpPr>
+        <p:spPr>
+          <a:xfrm>
+            <a:off x="676550" y="1451764"/>
+            <a:ext cx="366464" cy="366464"/>
+          </a:xfrm>
+          <a:prstGeom prst="ellipse">
+            <a:avLst/>
+          </a:prstGeom>
+          <a:solidFill>
+            <a:srgbClr val="3FB39D"/>
+          </a:solidFill>
+          <a:ln>
+            <a:noFill/>
+          </a:ln>
+          <a:effectLst/>
+        </p:spPr>
+        <p:style>
+          <a:lnRef idx="1">
+            <a:schemeClr val="accent1"/>
+          </a:lnRef>
+          <a:fillRef idx="3">
+            <a:schemeClr val="accent1"/>
+          </a:fillRef>
+          <a:effectRef idx="0">
+            <a:schemeClr val="accent1"/>
+          </a:effectRef>
+          <a:fontRef idx="minor">
+            <a:schemeClr val="lt1"/>
+          </a:fontRef>
+        </p:style>
+        <p:txBody>
+          <a:bodyPr rtlCol="0" anchor="ctr"/>
+          <a:lstStyle/>
+          <a:p>
+            <a:pPr algn="ctr"/>
+          </a:p>
+        </p:txBody>
+      </p:sp>
+      <p:sp>
+        <p:nvSpPr>
+          <p:cNvPr id="21" name="番号文字1"/>
           <p:cNvSpPr txBox="1"/>
           <p:nvPr/>
         </p:nvSpPr>
         <p:spPr>
           <a:xfrm>
-            <a:off x="5250312" y="2804864"/>
-            <a:ext cx="1691375" cy="225516"/>
+            <a:off x="676550" y="1451764"/>
+            <a:ext cx="366464" cy="366464"/>
           </a:xfrm>
           <a:prstGeom prst="rect">
             <a:avLst/>
@@ -8811,36 +9417,73 @@
           <a:noFill/>
         </p:spPr>
         <p:txBody>
-          <a:bodyPr wrap="square" lIns="0" rIns="0" tIns="0" bIns="0" anchor="t">
+          <a:bodyPr wrap="square" lIns="0" rIns="0" tIns="0" bIns="0" anchor="ctr">
             <a:spAutoFit/>
           </a:bodyPr>
           <a:lstStyle/>
           <a:p>
             <a:pPr algn="ctr"/>
             <a:r>
-              <a:rPr sz="1387" b="1" spc="100">
+              <a:rPr sz="1553" b="1">
                 <a:solidFill>
-                  <a:srgbClr val="2E9E8A"/>
+                  <a:srgbClr val="FFFFFF"/>
                 </a:solidFill>
                 <a:latin typeface="游ゴシック"/>
                 <a:ea typeface="游ゴシック"/>
                 <a:cs typeface="游ゴシック"/>
               </a:rPr>
-              <a:t>実習ブランドが</a:t>
-            </a:r>
-          </a:p>
-        </p:txBody>
-      </p:sp>
-      <p:sp>
-        <p:nvSpPr>
-          <p:cNvPr id="8" name="中央タイトル"/>
+              <a:t>1</a:t>
+            </a:r>
+          </a:p>
+        </p:txBody>
+      </p:sp>
+      <p:sp>
+        <p:nvSpPr>
+          <p:cNvPr id="22" name="要点_共育実習を行う"/>
           <p:cNvSpPr txBox="1"/>
           <p:nvPr/>
         </p:nvSpPr>
         <p:spPr>
           <a:xfrm>
-            <a:off x="5250312" y="3030381"/>
-            <a:ext cx="1691375" cy="465128"/>
+            <a:off x="1169868" y="1479953"/>
+            <a:ext cx="2818959" cy="310085"/>
+          </a:xfrm>
+          <a:prstGeom prst="rect">
+            <a:avLst/>
+          </a:prstGeom>
+          <a:noFill/>
+        </p:spPr>
+        <p:txBody>
+          <a:bodyPr wrap="square" lIns="0" rIns="0" tIns="0" bIns="0" anchor="ctr">
+            <a:spAutoFit/>
+          </a:bodyPr>
+          <a:lstStyle/>
+          <a:p>
+            <a:pPr algn="l"/>
+            <a:r>
+              <a:rPr sz="1775" b="1">
+                <a:solidFill>
+                  <a:srgbClr val="1F7D6C"/>
+                </a:solidFill>
+                <a:latin typeface="游ゴシック"/>
+                <a:ea typeface="游ゴシック"/>
+                <a:cs typeface="游ゴシック"/>
+              </a:rPr>
+              <a:t>共育実習を行う</a:t>
+            </a:r>
+          </a:p>
+        </p:txBody>
+      </p:sp>
+      <p:sp>
+        <p:nvSpPr>
+          <p:cNvPr id="23" name="説明_共育実習を行う"/>
+          <p:cNvSpPr txBox="1"/>
+          <p:nvPr/>
+        </p:nvSpPr>
+        <p:spPr>
+          <a:xfrm>
+            <a:off x="704739" y="1945082"/>
+            <a:ext cx="3312277" cy="422843"/>
           </a:xfrm>
           <a:prstGeom prst="rect">
             <a:avLst/>
@@ -8853,9 +9496,13 @@
           </a:bodyPr>
           <a:lstStyle/>
           <a:p>
-            <a:pPr algn="ctr"/>
-            <a:r>
-              <a:rPr sz="2885" b="1">
+            <a:pPr algn="l">
+              <a:lnSpc>
+                <a:spcPct val="120000"/>
+              </a:lnSpc>
+            </a:pPr>
+            <a:r>
+              <a:rPr sz="1165" b="0">
                 <a:solidFill>
                   <a:srgbClr val="26323A"/>
                 </a:solidFill>
@@ -8863,272 +9510,43 @@
                 <a:ea typeface="游ゴシック"/>
                 <a:cs typeface="游ゴシック"/>
               </a:rPr>
-              <a:t>育つ循環</a:t>
-            </a:r>
-          </a:p>
-        </p:txBody>
-      </p:sp>
-      <p:sp>
-        <p:nvSpPr>
-          <p:cNvPr id="9" name="帯"/>
-          <p:cNvSpPr/>
-          <p:nvPr/>
-        </p:nvSpPr>
-        <p:spPr>
-          <a:xfrm>
-            <a:off x="5461734" y="3580078"/>
-            <a:ext cx="1268531" cy="267801"/>
-          </a:xfrm>
-          <a:prstGeom prst="roundRect">
-            <a:avLst>
-              <a:gd name="adj" fmla="val 50000"/>
-            </a:avLst>
-          </a:prstGeom>
-          <a:solidFill>
-            <a:srgbClr val="F28C3C"/>
-          </a:solidFill>
-          <a:ln>
-            <a:noFill/>
-          </a:ln>
-          <a:effectLst/>
-        </p:spPr>
-        <p:style>
-          <a:lnRef idx="1">
-            <a:schemeClr val="accent1"/>
-          </a:lnRef>
-          <a:fillRef idx="3">
-            <a:schemeClr val="accent1"/>
-          </a:fillRef>
-          <a:effectRef idx="0">
-            <a:schemeClr val="accent1"/>
-          </a:effectRef>
-          <a:fontRef idx="minor">
-            <a:schemeClr val="lt1"/>
-          </a:fontRef>
-        </p:style>
-        <p:txBody>
-          <a:bodyPr rtlCol="0" anchor="ctr"/>
-          <a:lstStyle/>
-          <a:p>
-            <a:pPr algn="ctr"/>
-          </a:p>
-        </p:txBody>
-      </p:sp>
-      <p:sp>
-        <p:nvSpPr>
-          <p:cNvPr id="10" name="帯文字"/>
-          <p:cNvSpPr txBox="1"/>
-          <p:nvPr/>
-        </p:nvSpPr>
-        <p:spPr>
-          <a:xfrm>
-            <a:off x="5461734" y="3580078"/>
-            <a:ext cx="1268531" cy="267801"/>
-          </a:xfrm>
-          <a:prstGeom prst="rect">
-            <a:avLst/>
-          </a:prstGeom>
-          <a:noFill/>
-        </p:spPr>
-        <p:txBody>
-          <a:bodyPr wrap="square" lIns="0" rIns="0" tIns="0" bIns="0" anchor="ctr">
-            <a:spAutoFit/>
-          </a:bodyPr>
-          <a:lstStyle/>
-          <a:p>
-            <a:pPr algn="ctr"/>
-            <a:r>
-              <a:rPr sz="1054" b="1">
+              <a:t>高校・専門学校・大学で</a:t>
+            </a:r>
+          </a:p>
+          <a:p>
+            <a:pPr algn="l">
+              <a:lnSpc>
+                <a:spcPct val="120000"/>
+              </a:lnSpc>
+            </a:pPr>
+            <a:r>
+              <a:rPr sz="1165" b="0">
                 <a:solidFill>
-                  <a:srgbClr val="FFFFFF"/>
+                  <a:srgbClr val="26323A"/>
                 </a:solidFill>
                 <a:latin typeface="游ゴシック"/>
                 <a:ea typeface="游ゴシック"/>
                 <a:cs typeface="游ゴシック"/>
               </a:rPr>
-              <a:t>1に戻って循環</a:t>
-            </a:r>
-          </a:p>
-        </p:txBody>
-      </p:sp>
-      <p:sp>
-        <p:nvSpPr>
-          <p:cNvPr id="11" name="環_共育実習を行う"/>
+              <a:t>共育実習を実施します。</a:t>
+            </a:r>
+          </a:p>
+        </p:txBody>
+      </p:sp>
+      <p:sp>
+        <p:nvSpPr>
+          <p:cNvPr id="24" name="カード_声が集まる"/>
           <p:cNvSpPr/>
           <p:nvPr/>
         </p:nvSpPr>
         <p:spPr>
           <a:xfrm>
-            <a:off x="4334150" y="1536332"/>
-            <a:ext cx="3523699" cy="3523699"/>
-          </a:xfrm>
-          <a:prstGeom prst="blockArc">
-            <a:avLst>
-              <a:gd name="adj1" fmla="val 10980000"/>
-              <a:gd name="adj2" fmla="val 16020000"/>
-              <a:gd name="adj3" fmla="val 17600"/>
-            </a:avLst>
-          </a:prstGeom>
-          <a:solidFill>
-            <a:srgbClr val="3FB39D"/>
-          </a:solidFill>
-          <a:ln>
-            <a:noFill/>
-          </a:ln>
-          <a:effectLst/>
-        </p:spPr>
-        <p:style>
-          <a:lnRef idx="1">
-            <a:schemeClr val="accent1"/>
-          </a:lnRef>
-          <a:fillRef idx="3">
-            <a:schemeClr val="accent1"/>
-          </a:fillRef>
-          <a:effectRef idx="0">
-            <a:schemeClr val="accent1"/>
-          </a:effectRef>
-          <a:fontRef idx="minor">
-            <a:schemeClr val="lt1"/>
-          </a:fontRef>
-        </p:style>
-        <p:txBody>
-          <a:bodyPr rtlCol="0" anchor="ctr"/>
-          <a:lstStyle/>
-          <a:p>
-            <a:pPr algn="ctr"/>
-          </a:p>
-        </p:txBody>
-      </p:sp>
-      <p:sp>
-        <p:nvSpPr>
-          <p:cNvPr id="12" name="環ラベル_共育実習を行う"/>
-          <p:cNvSpPr txBox="1"/>
-          <p:nvPr/>
-        </p:nvSpPr>
-        <p:spPr>
-          <a:xfrm rot="18900000">
-            <a:off x="4505655" y="2130682"/>
-            <a:ext cx="1127583" cy="281895"/>
-          </a:xfrm>
-          <a:prstGeom prst="rect">
-            <a:avLst/>
-          </a:prstGeom>
-          <a:noFill/>
-        </p:spPr>
-        <p:txBody>
-          <a:bodyPr wrap="square" lIns="0" rIns="0" tIns="0" bIns="0" anchor="ctr">
-            <a:spAutoFit/>
-          </a:bodyPr>
-          <a:lstStyle/>
-          <a:p>
-            <a:pPr algn="ctr"/>
-            <a:r>
-              <a:rPr sz="1553" b="1" spc="200">
-                <a:solidFill>
-                  <a:srgbClr val="FFFFFF"/>
-                </a:solidFill>
-                <a:latin typeface="游ゴシック"/>
-                <a:ea typeface="游ゴシック"/>
-                <a:cs typeface="游ゴシック"/>
-              </a:rPr>
-              <a:t>1 実習</a:t>
-            </a:r>
-          </a:p>
-        </p:txBody>
-      </p:sp>
-      <p:cxnSp>
-        <p:nvCxnSpPr>
-          <p:cNvPr id="13" name="接続線_共育実習を行う"/>
-          <p:cNvCxnSpPr/>
-          <p:nvPr/>
-        </p:nvCxnSpPr>
-        <p:spPr>
-          <a:xfrm>
-            <a:off x="3974732" y="2438400"/>
-            <a:ext cx="471333" cy="0"/>
-          </a:xfrm>
-          <a:prstGeom prst="line">
-            <a:avLst/>
-          </a:prstGeom>
-          <a:ln w="22860">
-            <a:solidFill>
-              <a:srgbClr val="3FB39D"/>
-            </a:solidFill>
-          </a:ln>
-        </p:spPr>
-        <p:style>
-          <a:lnRef idx="2">
-            <a:schemeClr val="accent1"/>
-          </a:lnRef>
-          <a:fillRef idx="0">
-            <a:schemeClr val="accent1"/>
-          </a:fillRef>
-          <a:effectRef idx="0">
-            <a:schemeClr val="accent1"/>
-          </a:effectRef>
-          <a:fontRef idx="minor">
-            <a:schemeClr val="tx1"/>
-          </a:fontRef>
-        </p:style>
-      </p:cxnSp>
-      <p:sp>
-        <p:nvSpPr>
-          <p:cNvPr id="14" name="Oval 13"/>
-          <p:cNvSpPr/>
-          <p:nvPr/>
-        </p:nvSpPr>
-        <p:spPr>
-          <a:xfrm>
-            <a:off x="4403781" y="2396115"/>
-            <a:ext cx="84568" cy="84568"/>
-          </a:xfrm>
-          <a:prstGeom prst="ellipse">
-            <a:avLst/>
-          </a:prstGeom>
-          <a:solidFill>
-            <a:srgbClr val="3FB39D"/>
-          </a:solidFill>
-          <a:ln>
-            <a:noFill/>
-          </a:ln>
-          <a:effectLst/>
-        </p:spPr>
-        <p:style>
-          <a:lnRef idx="1">
-            <a:schemeClr val="accent1"/>
-          </a:lnRef>
-          <a:fillRef idx="3">
-            <a:schemeClr val="accent1"/>
-          </a:fillRef>
-          <a:effectRef idx="0">
-            <a:schemeClr val="accent1"/>
-          </a:effectRef>
-          <a:fontRef idx="minor">
-            <a:schemeClr val="lt1"/>
-          </a:fontRef>
-        </p:style>
-        <p:txBody>
-          <a:bodyPr rtlCol="0" anchor="ctr"/>
-          <a:lstStyle/>
-          <a:p>
-            <a:pPr algn="ctr"/>
-          </a:p>
-        </p:txBody>
-      </p:sp>
-      <p:sp>
-        <p:nvSpPr>
-          <p:cNvPr id="15" name="カード_共育実習を行う"/>
-          <p:cNvSpPr/>
-          <p:nvPr/>
-        </p:nvSpPr>
-        <p:spPr>
-          <a:xfrm>
-            <a:off x="451033" y="1874608"/>
-            <a:ext cx="3523699" cy="1127583"/>
+            <a:off x="8076319" y="1268531"/>
+            <a:ext cx="3664647" cy="1198057"/>
           </a:xfrm>
           <a:prstGeom prst="roundRect">
             <a:avLst>
-              <a:gd name="adj" fmla="val 14000"/>
+              <a:gd name="adj" fmla="val 12000"/>
             </a:avLst>
           </a:prstGeom>
           <a:solidFill>
@@ -9169,14 +9587,14 @@
       </p:sp>
       <p:sp>
         <p:nvSpPr>
-          <p:cNvPr id="16" name="カード色バー"/>
+          <p:cNvPr id="25" name="カード色バー"/>
           <p:cNvSpPr/>
           <p:nvPr/>
         </p:nvSpPr>
         <p:spPr>
           <a:xfrm>
-            <a:off x="451033" y="2086030"/>
-            <a:ext cx="56379" cy="704739"/>
+            <a:off x="8076319" y="1479953"/>
+            <a:ext cx="56379" cy="775213"/>
           </a:xfrm>
           <a:prstGeom prst="roundRect">
             <a:avLst>
@@ -9184,7 +9602,7 @@
             </a:avLst>
           </a:prstGeom>
           <a:solidFill>
-            <a:srgbClr val="3FB39D"/>
+            <a:srgbClr val="86D6C4"/>
           </a:solidFill>
           <a:ln>
             <a:noFill/>
@@ -9215,14 +9633,58 @@
       </p:sp>
       <p:sp>
         <p:nvSpPr>
-          <p:cNvPr id="17" name="STEP"/>
+          <p:cNvPr id="26" name="番号"/>
+          <p:cNvSpPr/>
+          <p:nvPr/>
+        </p:nvSpPr>
+        <p:spPr>
+          <a:xfrm>
+            <a:off x="8301835" y="1451764"/>
+            <a:ext cx="366464" cy="366464"/>
+          </a:xfrm>
+          <a:prstGeom prst="ellipse">
+            <a:avLst/>
+          </a:prstGeom>
+          <a:solidFill>
+            <a:srgbClr val="86D6C4"/>
+          </a:solidFill>
+          <a:ln>
+            <a:noFill/>
+          </a:ln>
+          <a:effectLst/>
+        </p:spPr>
+        <p:style>
+          <a:lnRef idx="1">
+            <a:schemeClr val="accent1"/>
+          </a:lnRef>
+          <a:fillRef idx="3">
+            <a:schemeClr val="accent1"/>
+          </a:fillRef>
+          <a:effectRef idx="0">
+            <a:schemeClr val="accent1"/>
+          </a:effectRef>
+          <a:fontRef idx="minor">
+            <a:schemeClr val="lt1"/>
+          </a:fontRef>
+        </p:style>
+        <p:txBody>
+          <a:bodyPr rtlCol="0" anchor="ctr"/>
+          <a:lstStyle/>
+          <a:p>
+            <a:pPr algn="ctr"/>
+          </a:p>
+        </p:txBody>
+      </p:sp>
+      <p:sp>
+        <p:nvSpPr>
+          <p:cNvPr id="27" name="番号文字2"/>
           <p:cNvSpPr txBox="1"/>
           <p:nvPr/>
         </p:nvSpPr>
         <p:spPr>
           <a:xfrm>
-            <a:off x="704739" y="2015556"/>
-            <a:ext cx="3100855" cy="211421"/>
+            <a:off x="8301835" y="1451764"/>
+            <a:ext cx="366464" cy="366464"/>
           </a:xfrm>
           <a:prstGeom prst="rect">
             <a:avLst/>
@@ -9230,36 +9692,36 @@
           <a:noFill/>
         </p:spPr>
         <p:txBody>
-          <a:bodyPr wrap="square" lIns="0" rIns="0" tIns="0" bIns="0" anchor="t">
+          <a:bodyPr wrap="square" lIns="0" rIns="0" tIns="0" bIns="0" anchor="ctr">
             <a:spAutoFit/>
           </a:bodyPr>
           <a:lstStyle/>
           <a:p>
-            <a:pPr algn="l"/>
-            <a:r>
-              <a:rPr sz="998" b="1" spc="200">
+            <a:pPr algn="ctr"/>
+            <a:r>
+              <a:rPr sz="1553" b="1">
                 <a:solidFill>
-                  <a:srgbClr val="5B6B73"/>
+                  <a:srgbClr val="FFFFFF"/>
                 </a:solidFill>
                 <a:latin typeface="游ゴシック"/>
                 <a:ea typeface="游ゴシック"/>
                 <a:cs typeface="游ゴシック"/>
               </a:rPr>
-              <a:t>STEP 1</a:t>
-            </a:r>
-          </a:p>
-        </p:txBody>
-      </p:sp>
-      <p:sp>
-        <p:nvSpPr>
-          <p:cNvPr id="18" name="要点_共育実習を行う"/>
+              <a:t>2</a:t>
+            </a:r>
+          </a:p>
+        </p:txBody>
+      </p:sp>
+      <p:sp>
+        <p:nvSpPr>
+          <p:cNvPr id="28" name="要点_声が集まる"/>
           <p:cNvSpPr txBox="1"/>
           <p:nvPr/>
         </p:nvSpPr>
         <p:spPr>
           <a:xfrm>
-            <a:off x="704739" y="2198788"/>
-            <a:ext cx="3100855" cy="310085"/>
+            <a:off x="8795153" y="1479953"/>
+            <a:ext cx="2818959" cy="310085"/>
           </a:xfrm>
           <a:prstGeom prst="rect">
             <a:avLst/>
@@ -9267,14 +9729,14 @@
           <a:noFill/>
         </p:spPr>
         <p:txBody>
-          <a:bodyPr wrap="square" lIns="0" rIns="0" tIns="0" bIns="0" anchor="t">
+          <a:bodyPr wrap="square" lIns="0" rIns="0" tIns="0" bIns="0" anchor="ctr">
             <a:spAutoFit/>
           </a:bodyPr>
           <a:lstStyle/>
           <a:p>
             <a:pPr algn="l"/>
             <a:r>
-              <a:rPr sz="1720" b="1">
+              <a:rPr sz="1775" b="1">
                 <a:solidFill>
                   <a:srgbClr val="1F7D6C"/>
                 </a:solidFill>
@@ -9282,21 +9744,21 @@
                 <a:ea typeface="游ゴシック"/>
                 <a:cs typeface="游ゴシック"/>
               </a:rPr>
-              <a:t>共育実習を行う</a:t>
-            </a:r>
-          </a:p>
-        </p:txBody>
-      </p:sp>
-      <p:sp>
-        <p:nvSpPr>
-          <p:cNvPr id="19" name="説明_共育実習を行う"/>
+              <a:t>声が集まる</a:t>
+            </a:r>
+          </a:p>
+        </p:txBody>
+      </p:sp>
+      <p:sp>
+        <p:nvSpPr>
+          <p:cNvPr id="29" name="説明_声が集まる"/>
           <p:cNvSpPr txBox="1"/>
           <p:nvPr/>
         </p:nvSpPr>
         <p:spPr>
           <a:xfrm>
-            <a:off x="704739" y="2551158"/>
-            <a:ext cx="3100855" cy="380559"/>
+            <a:off x="8330025" y="1945082"/>
+            <a:ext cx="3312277" cy="422843"/>
           </a:xfrm>
           <a:prstGeom prst="rect">
             <a:avLst/>
@@ -9311,11 +9773,11 @@
           <a:p>
             <a:pPr algn="l">
               <a:lnSpc>
-                <a:spcPct val="115000"/>
+                <a:spcPct val="120000"/>
               </a:lnSpc>
             </a:pPr>
             <a:r>
-              <a:rPr sz="1109" b="0">
+              <a:rPr sz="1165" b="0">
                 <a:solidFill>
                   <a:srgbClr val="26323A"/>
                 </a:solidFill>
@@ -9323,17 +9785,17 @@
                 <a:ea typeface="游ゴシック"/>
                 <a:cs typeface="游ゴシック"/>
               </a:rPr>
-              <a:t>高校・専門学校・大学で</a:t>
+              <a:t>学生・先生・社員・</a:t>
             </a:r>
           </a:p>
           <a:p>
             <a:pPr algn="l">
               <a:lnSpc>
-                <a:spcPct val="115000"/>
+                <a:spcPct val="120000"/>
               </a:lnSpc>
             </a:pPr>
             <a:r>
-              <a:rPr sz="1109" b="0">
+              <a:rPr sz="1165" b="0">
                 <a:solidFill>
                   <a:srgbClr val="26323A"/>
                 </a:solidFill>
@@ -9341,189 +9803,25 @@
                 <a:ea typeface="游ゴシック"/>
                 <a:cs typeface="游ゴシック"/>
               </a:rPr>
-              <a:t>共育実習を実施します。</a:t>
-            </a:r>
-          </a:p>
-        </p:txBody>
-      </p:sp>
-      <p:sp>
-        <p:nvSpPr>
-          <p:cNvPr id="20" name="環_声が集まる"/>
+              <a:t>利用者さんの声が集まります。</a:t>
+            </a:r>
+          </a:p>
+        </p:txBody>
+      </p:sp>
+      <p:sp>
+        <p:nvSpPr>
+          <p:cNvPr id="30" name="カード_実習サイトに載せる"/>
           <p:cNvSpPr/>
           <p:nvPr/>
         </p:nvSpPr>
         <p:spPr>
           <a:xfrm>
-            <a:off x="4334150" y="1536332"/>
-            <a:ext cx="3523699" cy="3523699"/>
-          </a:xfrm>
-          <a:prstGeom prst="blockArc">
-            <a:avLst>
-              <a:gd name="adj1" fmla="val 16380000"/>
-              <a:gd name="adj2" fmla="val 21420000"/>
-              <a:gd name="adj3" fmla="val 17600"/>
-            </a:avLst>
-          </a:prstGeom>
-          <a:solidFill>
-            <a:srgbClr val="86D6C4"/>
-          </a:solidFill>
-          <a:ln>
-            <a:noFill/>
-          </a:ln>
-          <a:effectLst/>
-        </p:spPr>
-        <p:style>
-          <a:lnRef idx="1">
-            <a:schemeClr val="accent1"/>
-          </a:lnRef>
-          <a:fillRef idx="3">
-            <a:schemeClr val="accent1"/>
-          </a:fillRef>
-          <a:effectRef idx="0">
-            <a:schemeClr val="accent1"/>
-          </a:effectRef>
-          <a:fontRef idx="minor">
-            <a:schemeClr val="lt1"/>
-          </a:fontRef>
-        </p:style>
-        <p:txBody>
-          <a:bodyPr rtlCol="0" anchor="ctr"/>
-          <a:lstStyle/>
-          <a:p>
-            <a:pPr algn="ctr"/>
-          </a:p>
-        </p:txBody>
-      </p:sp>
-      <p:sp>
-        <p:nvSpPr>
-          <p:cNvPr id="21" name="環ラベル_声が集まる"/>
-          <p:cNvSpPr txBox="1"/>
-          <p:nvPr/>
-        </p:nvSpPr>
-        <p:spPr>
-          <a:xfrm rot="2700000">
-            <a:off x="6558760" y="2130682"/>
-            <a:ext cx="1127583" cy="281895"/>
-          </a:xfrm>
-          <a:prstGeom prst="rect">
-            <a:avLst/>
-          </a:prstGeom>
-          <a:noFill/>
-        </p:spPr>
-        <p:txBody>
-          <a:bodyPr wrap="square" lIns="0" rIns="0" tIns="0" bIns="0" anchor="ctr">
-            <a:spAutoFit/>
-          </a:bodyPr>
-          <a:lstStyle/>
-          <a:p>
-            <a:pPr algn="ctr"/>
-            <a:r>
-              <a:rPr sz="1553" b="1" spc="200">
-                <a:solidFill>
-                  <a:srgbClr val="FFFFFF"/>
-                </a:solidFill>
-                <a:latin typeface="游ゴシック"/>
-                <a:ea typeface="游ゴシック"/>
-                <a:cs typeface="游ゴシック"/>
-              </a:rPr>
-              <a:t>2 声</a:t>
-            </a:r>
-          </a:p>
-        </p:txBody>
-      </p:sp>
-      <p:cxnSp>
-        <p:nvCxnSpPr>
-          <p:cNvPr id="22" name="接続線_声が集まる"/>
-          <p:cNvCxnSpPr/>
-          <p:nvPr/>
-        </p:nvCxnSpPr>
-        <p:spPr>
-          <a:xfrm flipH="1">
-            <a:off x="7745934" y="2438400"/>
-            <a:ext cx="471333" cy="0"/>
-          </a:xfrm>
-          <a:prstGeom prst="line">
-            <a:avLst/>
-          </a:prstGeom>
-          <a:ln w="22860">
-            <a:solidFill>
-              <a:srgbClr val="86D6C4"/>
-            </a:solidFill>
-          </a:ln>
-        </p:spPr>
-        <p:style>
-          <a:lnRef idx="2">
-            <a:schemeClr val="accent1"/>
-          </a:lnRef>
-          <a:fillRef idx="0">
-            <a:schemeClr val="accent1"/>
-          </a:fillRef>
-          <a:effectRef idx="0">
-            <a:schemeClr val="accent1"/>
-          </a:effectRef>
-          <a:fontRef idx="minor">
-            <a:schemeClr val="tx1"/>
-          </a:fontRef>
-        </p:style>
-      </p:cxnSp>
-      <p:sp>
-        <p:nvSpPr>
-          <p:cNvPr id="23" name="Oval 22"/>
-          <p:cNvSpPr/>
-          <p:nvPr/>
-        </p:nvSpPr>
-        <p:spPr>
-          <a:xfrm>
-            <a:off x="7703649" y="2396115"/>
-            <a:ext cx="84568" cy="84568"/>
-          </a:xfrm>
-          <a:prstGeom prst="ellipse">
-            <a:avLst/>
-          </a:prstGeom>
-          <a:solidFill>
-            <a:srgbClr val="86D6C4"/>
-          </a:solidFill>
-          <a:ln>
-            <a:noFill/>
-          </a:ln>
-          <a:effectLst/>
-        </p:spPr>
-        <p:style>
-          <a:lnRef idx="1">
-            <a:schemeClr val="accent1"/>
-          </a:lnRef>
-          <a:fillRef idx="3">
-            <a:schemeClr val="accent1"/>
-          </a:fillRef>
-          <a:effectRef idx="0">
-            <a:schemeClr val="accent1"/>
-          </a:effectRef>
-          <a:fontRef idx="minor">
-            <a:schemeClr val="lt1"/>
-          </a:fontRef>
-        </p:style>
-        <p:txBody>
-          <a:bodyPr rtlCol="0" anchor="ctr"/>
-          <a:lstStyle/>
-          <a:p>
-            <a:pPr algn="ctr"/>
-          </a:p>
-        </p:txBody>
-      </p:sp>
-      <p:sp>
-        <p:nvSpPr>
-          <p:cNvPr id="24" name="カード_声が集まる"/>
-          <p:cNvSpPr/>
-          <p:nvPr/>
-        </p:nvSpPr>
-        <p:spPr>
-          <a:xfrm>
-            <a:off x="8217267" y="1874608"/>
-            <a:ext cx="3523699" cy="1127583"/>
+            <a:off x="8076319" y="3636457"/>
+            <a:ext cx="3664647" cy="1198057"/>
           </a:xfrm>
           <a:prstGeom prst="roundRect">
             <a:avLst>
-              <a:gd name="adj" fmla="val 14000"/>
+              <a:gd name="adj" fmla="val 12000"/>
             </a:avLst>
           </a:prstGeom>
           <a:solidFill>
@@ -9564,14 +9862,14 @@
       </p:sp>
       <p:sp>
         <p:nvSpPr>
-          <p:cNvPr id="25" name="カード色バー"/>
+          <p:cNvPr id="31" name="カード色バー"/>
           <p:cNvSpPr/>
           <p:nvPr/>
         </p:nvSpPr>
         <p:spPr>
           <a:xfrm>
-            <a:off x="8217267" y="2086030"/>
-            <a:ext cx="56379" cy="704739"/>
+            <a:off x="8076319" y="3847879"/>
+            <a:ext cx="56379" cy="775213"/>
           </a:xfrm>
           <a:prstGeom prst="roundRect">
             <a:avLst>
@@ -9579,7 +9877,7 @@
             </a:avLst>
           </a:prstGeom>
           <a:solidFill>
-            <a:srgbClr val="86D6C4"/>
+            <a:srgbClr val="F28C3C"/>
           </a:solidFill>
           <a:ln>
             <a:noFill/>
@@ -9610,14 +9908,58 @@
       </p:sp>
       <p:sp>
         <p:nvSpPr>
-          <p:cNvPr id="26" name="STEP"/>
+          <p:cNvPr id="32" name="番号"/>
+          <p:cNvSpPr/>
+          <p:nvPr/>
+        </p:nvSpPr>
+        <p:spPr>
+          <a:xfrm>
+            <a:off x="8301835" y="3819690"/>
+            <a:ext cx="366464" cy="366464"/>
+          </a:xfrm>
+          <a:prstGeom prst="ellipse">
+            <a:avLst/>
+          </a:prstGeom>
+          <a:solidFill>
+            <a:srgbClr val="F28C3C"/>
+          </a:solidFill>
+          <a:ln>
+            <a:noFill/>
+          </a:ln>
+          <a:effectLst/>
+        </p:spPr>
+        <p:style>
+          <a:lnRef idx="1">
+            <a:schemeClr val="accent1"/>
+          </a:lnRef>
+          <a:fillRef idx="3">
+            <a:schemeClr val="accent1"/>
+          </a:fillRef>
+          <a:effectRef idx="0">
+            <a:schemeClr val="accent1"/>
+          </a:effectRef>
+          <a:fontRef idx="minor">
+            <a:schemeClr val="lt1"/>
+          </a:fontRef>
+        </p:style>
+        <p:txBody>
+          <a:bodyPr rtlCol="0" anchor="ctr"/>
+          <a:lstStyle/>
+          <a:p>
+            <a:pPr algn="ctr"/>
+          </a:p>
+        </p:txBody>
+      </p:sp>
+      <p:sp>
+        <p:nvSpPr>
+          <p:cNvPr id="33" name="番号文字3"/>
           <p:cNvSpPr txBox="1"/>
           <p:nvPr/>
         </p:nvSpPr>
         <p:spPr>
           <a:xfrm>
-            <a:off x="8470973" y="2015556"/>
-            <a:ext cx="3100855" cy="211421"/>
+            <a:off x="8301835" y="3819690"/>
+            <a:ext cx="366464" cy="366464"/>
           </a:xfrm>
           <a:prstGeom prst="rect">
             <a:avLst/>
@@ -9625,36 +9967,36 @@
           <a:noFill/>
         </p:spPr>
         <p:txBody>
-          <a:bodyPr wrap="square" lIns="0" rIns="0" tIns="0" bIns="0" anchor="t">
+          <a:bodyPr wrap="square" lIns="0" rIns="0" tIns="0" bIns="0" anchor="ctr">
             <a:spAutoFit/>
           </a:bodyPr>
           <a:lstStyle/>
           <a:p>
-            <a:pPr algn="l"/>
-            <a:r>
-              <a:rPr sz="998" b="1" spc="200">
+            <a:pPr algn="ctr"/>
+            <a:r>
+              <a:rPr sz="1553" b="1">
                 <a:solidFill>
-                  <a:srgbClr val="5B6B73"/>
+                  <a:srgbClr val="FFFFFF"/>
                 </a:solidFill>
                 <a:latin typeface="游ゴシック"/>
                 <a:ea typeface="游ゴシック"/>
                 <a:cs typeface="游ゴシック"/>
               </a:rPr>
-              <a:t>STEP 2</a:t>
-            </a:r>
-          </a:p>
-        </p:txBody>
-      </p:sp>
-      <p:sp>
-        <p:nvSpPr>
-          <p:cNvPr id="27" name="要点_声が集まる"/>
+              <a:t>3</a:t>
+            </a:r>
+          </a:p>
+        </p:txBody>
+      </p:sp>
+      <p:sp>
+        <p:nvSpPr>
+          <p:cNvPr id="34" name="要点_実習サイトに載せる"/>
           <p:cNvSpPr txBox="1"/>
           <p:nvPr/>
         </p:nvSpPr>
         <p:spPr>
           <a:xfrm>
-            <a:off x="8470973" y="2198788"/>
-            <a:ext cx="3100855" cy="310085"/>
+            <a:off x="8795153" y="3847879"/>
+            <a:ext cx="2818959" cy="310085"/>
           </a:xfrm>
           <a:prstGeom prst="rect">
             <a:avLst/>
@@ -9662,36 +10004,36 @@
           <a:noFill/>
         </p:spPr>
         <p:txBody>
-          <a:bodyPr wrap="square" lIns="0" rIns="0" tIns="0" bIns="0" anchor="t">
+          <a:bodyPr wrap="square" lIns="0" rIns="0" tIns="0" bIns="0" anchor="ctr">
             <a:spAutoFit/>
           </a:bodyPr>
           <a:lstStyle/>
           <a:p>
             <a:pPr algn="l"/>
             <a:r>
-              <a:rPr sz="1720" b="1">
+              <a:rPr sz="1775" b="1">
                 <a:solidFill>
-                  <a:srgbClr val="1F7D6C"/>
+                  <a:srgbClr val="C8651A"/>
                 </a:solidFill>
                 <a:latin typeface="游ゴシック"/>
                 <a:ea typeface="游ゴシック"/>
                 <a:cs typeface="游ゴシック"/>
               </a:rPr>
-              <a:t>声が集まる</a:t>
-            </a:r>
-          </a:p>
-        </p:txBody>
-      </p:sp>
-      <p:sp>
-        <p:nvSpPr>
-          <p:cNvPr id="28" name="説明_声が集まる"/>
+              <a:t>実習サイトに載せる</a:t>
+            </a:r>
+          </a:p>
+        </p:txBody>
+      </p:sp>
+      <p:sp>
+        <p:nvSpPr>
+          <p:cNvPr id="35" name="説明_実習サイトに載せる"/>
           <p:cNvSpPr txBox="1"/>
           <p:nvPr/>
         </p:nvSpPr>
         <p:spPr>
           <a:xfrm>
-            <a:off x="8470973" y="2551158"/>
-            <a:ext cx="3100855" cy="380559"/>
+            <a:off x="8330025" y="4313008"/>
+            <a:ext cx="3312277" cy="422843"/>
           </a:xfrm>
           <a:prstGeom prst="rect">
             <a:avLst/>
@@ -9706,11 +10048,11 @@
           <a:p>
             <a:pPr algn="l">
               <a:lnSpc>
-                <a:spcPct val="115000"/>
+                <a:spcPct val="120000"/>
               </a:lnSpc>
             </a:pPr>
             <a:r>
-              <a:rPr sz="1109" b="0">
+              <a:rPr sz="1165" b="0">
                 <a:solidFill>
                   <a:srgbClr val="26323A"/>
                 </a:solidFill>
@@ -9718,17 +10060,17 @@
                 <a:ea typeface="游ゴシック"/>
                 <a:cs typeface="游ゴシック"/>
               </a:rPr>
-              <a:t>学生・先生・社員・</a:t>
+              <a:t>プログラム内容と</a:t>
             </a:r>
           </a:p>
           <a:p>
             <a:pPr algn="l">
               <a:lnSpc>
-                <a:spcPct val="115000"/>
+                <a:spcPct val="120000"/>
               </a:lnSpc>
             </a:pPr>
             <a:r>
-              <a:rPr sz="1109" b="0">
+              <a:rPr sz="1165" b="0">
                 <a:solidFill>
                   <a:srgbClr val="26323A"/>
                 </a:solidFill>
@@ -9736,189 +10078,25 @@
                 <a:ea typeface="游ゴシック"/>
                 <a:cs typeface="游ゴシック"/>
               </a:rPr>
-              <a:t>利用者さんの声が集まります。</a:t>
-            </a:r>
-          </a:p>
-        </p:txBody>
-      </p:sp>
-      <p:sp>
-        <p:nvSpPr>
-          <p:cNvPr id="29" name="環_実習サイトに載せる"/>
+              <a:t>口コミを掲載します。</a:t>
+            </a:r>
+          </a:p>
+        </p:txBody>
+      </p:sp>
+      <p:sp>
+        <p:nvSpPr>
+          <p:cNvPr id="36" name="カード_見て、動く"/>
           <p:cNvSpPr/>
           <p:nvPr/>
         </p:nvSpPr>
         <p:spPr>
           <a:xfrm>
-            <a:off x="4334150" y="1536332"/>
-            <a:ext cx="3523699" cy="3523699"/>
-          </a:xfrm>
-          <a:prstGeom prst="blockArc">
-            <a:avLst>
-              <a:gd name="adj1" fmla="val 180000"/>
-              <a:gd name="adj2" fmla="val 5220000"/>
-              <a:gd name="adj3" fmla="val 17600"/>
-            </a:avLst>
-          </a:prstGeom>
-          <a:solidFill>
-            <a:srgbClr val="F28C3C"/>
-          </a:solidFill>
-          <a:ln>
-            <a:noFill/>
-          </a:ln>
-          <a:effectLst/>
-        </p:spPr>
-        <p:style>
-          <a:lnRef idx="1">
-            <a:schemeClr val="accent1"/>
-          </a:lnRef>
-          <a:fillRef idx="3">
-            <a:schemeClr val="accent1"/>
-          </a:fillRef>
-          <a:effectRef idx="0">
-            <a:schemeClr val="accent1"/>
-          </a:effectRef>
-          <a:fontRef idx="minor">
-            <a:schemeClr val="lt1"/>
-          </a:fontRef>
-        </p:style>
-        <p:txBody>
-          <a:bodyPr rtlCol="0" anchor="ctr"/>
-          <a:lstStyle/>
-          <a:p>
-            <a:pPr algn="ctr"/>
-          </a:p>
-        </p:txBody>
-      </p:sp>
-      <p:sp>
-        <p:nvSpPr>
-          <p:cNvPr id="30" name="環ラベル_実習サイトに載せる"/>
-          <p:cNvSpPr txBox="1"/>
-          <p:nvPr/>
-        </p:nvSpPr>
-        <p:spPr>
-          <a:xfrm rot="18900000">
-            <a:off x="6558760" y="4183786"/>
-            <a:ext cx="1127583" cy="281895"/>
-          </a:xfrm>
-          <a:prstGeom prst="rect">
-            <a:avLst/>
-          </a:prstGeom>
-          <a:noFill/>
-        </p:spPr>
-        <p:txBody>
-          <a:bodyPr wrap="square" lIns="0" rIns="0" tIns="0" bIns="0" anchor="ctr">
-            <a:spAutoFit/>
-          </a:bodyPr>
-          <a:lstStyle/>
-          <a:p>
-            <a:pPr algn="ctr"/>
-            <a:r>
-              <a:rPr sz="1553" b="1" spc="200">
-                <a:solidFill>
-                  <a:srgbClr val="FFFFFF"/>
-                </a:solidFill>
-                <a:latin typeface="游ゴシック"/>
-                <a:ea typeface="游ゴシック"/>
-                <a:cs typeface="游ゴシック"/>
-              </a:rPr>
-              <a:t>3 掲載</a:t>
-            </a:r>
-          </a:p>
-        </p:txBody>
-      </p:sp>
-      <p:cxnSp>
-        <p:nvCxnSpPr>
-          <p:cNvPr id="31" name="接続線_実習サイトに載せる"/>
-          <p:cNvCxnSpPr/>
-          <p:nvPr/>
-        </p:nvCxnSpPr>
-        <p:spPr>
-          <a:xfrm flipH="1">
-            <a:off x="7745934" y="4157965"/>
-            <a:ext cx="471333" cy="0"/>
-          </a:xfrm>
-          <a:prstGeom prst="line">
-            <a:avLst/>
-          </a:prstGeom>
-          <a:ln w="22860">
-            <a:solidFill>
-              <a:srgbClr val="F28C3C"/>
-            </a:solidFill>
-          </a:ln>
-        </p:spPr>
-        <p:style>
-          <a:lnRef idx="2">
-            <a:schemeClr val="accent1"/>
-          </a:lnRef>
-          <a:fillRef idx="0">
-            <a:schemeClr val="accent1"/>
-          </a:fillRef>
-          <a:effectRef idx="0">
-            <a:schemeClr val="accent1"/>
-          </a:effectRef>
-          <a:fontRef idx="minor">
-            <a:schemeClr val="tx1"/>
-          </a:fontRef>
-        </p:style>
-      </p:cxnSp>
-      <p:sp>
-        <p:nvSpPr>
-          <p:cNvPr id="32" name="Oval 31"/>
-          <p:cNvSpPr/>
-          <p:nvPr/>
-        </p:nvSpPr>
-        <p:spPr>
-          <a:xfrm>
-            <a:off x="7703649" y="4115680"/>
-            <a:ext cx="84568" cy="84568"/>
-          </a:xfrm>
-          <a:prstGeom prst="ellipse">
-            <a:avLst/>
-          </a:prstGeom>
-          <a:solidFill>
-            <a:srgbClr val="F28C3C"/>
-          </a:solidFill>
-          <a:ln>
-            <a:noFill/>
-          </a:ln>
-          <a:effectLst/>
-        </p:spPr>
-        <p:style>
-          <a:lnRef idx="1">
-            <a:schemeClr val="accent1"/>
-          </a:lnRef>
-          <a:fillRef idx="3">
-            <a:schemeClr val="accent1"/>
-          </a:fillRef>
-          <a:effectRef idx="0">
-            <a:schemeClr val="accent1"/>
-          </a:effectRef>
-          <a:fontRef idx="minor">
-            <a:schemeClr val="lt1"/>
-          </a:fontRef>
-        </p:style>
-        <p:txBody>
-          <a:bodyPr rtlCol="0" anchor="ctr"/>
-          <a:lstStyle/>
-          <a:p>
-            <a:pPr algn="ctr"/>
-          </a:p>
-        </p:txBody>
-      </p:sp>
-      <p:sp>
-        <p:nvSpPr>
-          <p:cNvPr id="33" name="カード_実習サイトに載せる"/>
-          <p:cNvSpPr/>
-          <p:nvPr/>
-        </p:nvSpPr>
-        <p:spPr>
-          <a:xfrm>
-            <a:off x="8217267" y="3594173"/>
-            <a:ext cx="3523699" cy="1127583"/>
+            <a:off x="451033" y="3636457"/>
+            <a:ext cx="3664647" cy="1198057"/>
           </a:xfrm>
           <a:prstGeom prst="roundRect">
             <a:avLst>
-              <a:gd name="adj" fmla="val 14000"/>
+              <a:gd name="adj" fmla="val 12000"/>
             </a:avLst>
           </a:prstGeom>
           <a:solidFill>
@@ -9959,14 +10137,14 @@
       </p:sp>
       <p:sp>
         <p:nvSpPr>
-          <p:cNvPr id="34" name="カード色バー"/>
+          <p:cNvPr id="37" name="カード色バー"/>
           <p:cNvSpPr/>
           <p:nvPr/>
         </p:nvSpPr>
         <p:spPr>
           <a:xfrm>
-            <a:off x="8217267" y="3805595"/>
-            <a:ext cx="56379" cy="704739"/>
+            <a:off x="451033" y="3847879"/>
+            <a:ext cx="56379" cy="775213"/>
           </a:xfrm>
           <a:prstGeom prst="roundRect">
             <a:avLst>
@@ -9974,7 +10152,7 @@
             </a:avLst>
           </a:prstGeom>
           <a:solidFill>
-            <a:srgbClr val="F28C3C"/>
+            <a:srgbClr val="2E9E8A"/>
           </a:solidFill>
           <a:ln>
             <a:noFill/>
@@ -10005,14 +10183,58 @@
       </p:sp>
       <p:sp>
         <p:nvSpPr>
-          <p:cNvPr id="35" name="STEP"/>
+          <p:cNvPr id="38" name="番号"/>
+          <p:cNvSpPr/>
+          <p:nvPr/>
+        </p:nvSpPr>
+        <p:spPr>
+          <a:xfrm>
+            <a:off x="676550" y="3819690"/>
+            <a:ext cx="366464" cy="366464"/>
+          </a:xfrm>
+          <a:prstGeom prst="ellipse">
+            <a:avLst/>
+          </a:prstGeom>
+          <a:solidFill>
+            <a:srgbClr val="2E9E8A"/>
+          </a:solidFill>
+          <a:ln>
+            <a:noFill/>
+          </a:ln>
+          <a:effectLst/>
+        </p:spPr>
+        <p:style>
+          <a:lnRef idx="1">
+            <a:schemeClr val="accent1"/>
+          </a:lnRef>
+          <a:fillRef idx="3">
+            <a:schemeClr val="accent1"/>
+          </a:fillRef>
+          <a:effectRef idx="0">
+            <a:schemeClr val="accent1"/>
+          </a:effectRef>
+          <a:fontRef idx="minor">
+            <a:schemeClr val="lt1"/>
+          </a:fontRef>
+        </p:style>
+        <p:txBody>
+          <a:bodyPr rtlCol="0" anchor="ctr"/>
+          <a:lstStyle/>
+          <a:p>
+            <a:pPr algn="ctr"/>
+          </a:p>
+        </p:txBody>
+      </p:sp>
+      <p:sp>
+        <p:nvSpPr>
+          <p:cNvPr id="39" name="番号文字4"/>
           <p:cNvSpPr txBox="1"/>
           <p:nvPr/>
         </p:nvSpPr>
         <p:spPr>
           <a:xfrm>
-            <a:off x="8470973" y="3735121"/>
-            <a:ext cx="3100855" cy="211421"/>
+            <a:off x="676550" y="3819690"/>
+            <a:ext cx="366464" cy="366464"/>
           </a:xfrm>
           <a:prstGeom prst="rect">
             <a:avLst/>
@@ -10020,36 +10242,36 @@
           <a:noFill/>
         </p:spPr>
         <p:txBody>
-          <a:bodyPr wrap="square" lIns="0" rIns="0" tIns="0" bIns="0" anchor="t">
+          <a:bodyPr wrap="square" lIns="0" rIns="0" tIns="0" bIns="0" anchor="ctr">
             <a:spAutoFit/>
           </a:bodyPr>
           <a:lstStyle/>
           <a:p>
-            <a:pPr algn="l"/>
-            <a:r>
-              <a:rPr sz="998" b="1" spc="200">
+            <a:pPr algn="ctr"/>
+            <a:r>
+              <a:rPr sz="1553" b="1">
                 <a:solidFill>
-                  <a:srgbClr val="5B6B73"/>
+                  <a:srgbClr val="FFFFFF"/>
                 </a:solidFill>
                 <a:latin typeface="游ゴシック"/>
                 <a:ea typeface="游ゴシック"/>
                 <a:cs typeface="游ゴシック"/>
               </a:rPr>
-              <a:t>STEP 3</a:t>
-            </a:r>
-          </a:p>
-        </p:txBody>
-      </p:sp>
-      <p:sp>
-        <p:nvSpPr>
-          <p:cNvPr id="36" name="要点_実習サイトに載せる"/>
+              <a:t>4</a:t>
+            </a:r>
+          </a:p>
+        </p:txBody>
+      </p:sp>
+      <p:sp>
+        <p:nvSpPr>
+          <p:cNvPr id="40" name="要点_見て、動く"/>
           <p:cNvSpPr txBox="1"/>
           <p:nvPr/>
         </p:nvSpPr>
         <p:spPr>
           <a:xfrm>
-            <a:off x="8470973" y="3918353"/>
-            <a:ext cx="3100855" cy="310085"/>
+            <a:off x="1169868" y="3847879"/>
+            <a:ext cx="2818959" cy="310085"/>
           </a:xfrm>
           <a:prstGeom prst="rect">
             <a:avLst/>
@@ -10057,36 +10279,36 @@
           <a:noFill/>
         </p:spPr>
         <p:txBody>
-          <a:bodyPr wrap="square" lIns="0" rIns="0" tIns="0" bIns="0" anchor="t">
+          <a:bodyPr wrap="square" lIns="0" rIns="0" tIns="0" bIns="0" anchor="ctr">
             <a:spAutoFit/>
           </a:bodyPr>
           <a:lstStyle/>
           <a:p>
             <a:pPr algn="l"/>
             <a:r>
-              <a:rPr sz="1720" b="1">
+              <a:rPr sz="1775" b="1">
                 <a:solidFill>
-                  <a:srgbClr val="C8651A"/>
+                  <a:srgbClr val="1F7D6C"/>
                 </a:solidFill>
                 <a:latin typeface="游ゴシック"/>
                 <a:ea typeface="游ゴシック"/>
                 <a:cs typeface="游ゴシック"/>
               </a:rPr>
-              <a:t>実習サイトに載せる</a:t>
-            </a:r>
-          </a:p>
-        </p:txBody>
-      </p:sp>
-      <p:sp>
-        <p:nvSpPr>
-          <p:cNvPr id="37" name="説明_実習サイトに載せる"/>
+              <a:t>見て、動く</a:t>
+            </a:r>
+          </a:p>
+        </p:txBody>
+      </p:sp>
+      <p:sp>
+        <p:nvSpPr>
+          <p:cNvPr id="41" name="説明_見て、動く"/>
           <p:cNvSpPr txBox="1"/>
           <p:nvPr/>
         </p:nvSpPr>
         <p:spPr>
           <a:xfrm>
-            <a:off x="8470973" y="4270723"/>
-            <a:ext cx="3100855" cy="380559"/>
+            <a:off x="704739" y="4313008"/>
+            <a:ext cx="3312277" cy="422843"/>
           </a:xfrm>
           <a:prstGeom prst="rect">
             <a:avLst/>
@@ -10101,11 +10323,11 @@
           <a:p>
             <a:pPr algn="l">
               <a:lnSpc>
-                <a:spcPct val="115000"/>
+                <a:spcPct val="120000"/>
               </a:lnSpc>
             </a:pPr>
             <a:r>
-              <a:rPr sz="1109" b="0">
+              <a:rPr sz="1165" b="0">
                 <a:solidFill>
                   <a:srgbClr val="26323A"/>
                 </a:solidFill>
@@ -10113,17 +10335,17 @@
                 <a:ea typeface="游ゴシック"/>
                 <a:cs typeface="游ゴシック"/>
               </a:rPr>
-              <a:t>プログラム内容と</a:t>
+              <a:t>学校は受け入れを判断し、</a:t>
             </a:r>
           </a:p>
           <a:p>
             <a:pPr algn="l">
               <a:lnSpc>
-                <a:spcPct val="115000"/>
+                <a:spcPct val="120000"/>
               </a:lnSpc>
             </a:pPr>
             <a:r>
-              <a:rPr sz="1109" b="0">
+              <a:rPr sz="1165" b="0">
                 <a:solidFill>
                   <a:srgbClr val="26323A"/>
                 </a:solidFill>
@@ -10131,189 +10353,25 @@
                 <a:ea typeface="游ゴシック"/>
                 <a:cs typeface="游ゴシック"/>
               </a:rPr>
-              <a:t>口コミを掲載します。</a:t>
-            </a:r>
-          </a:p>
-        </p:txBody>
-      </p:sp>
-      <p:sp>
-        <p:nvSpPr>
-          <p:cNvPr id="38" name="環_見て、動く"/>
+              <a:t>次の学生は参加を決めます。</a:t>
+            </a:r>
+          </a:p>
+        </p:txBody>
+      </p:sp>
+      <p:sp>
+        <p:nvSpPr>
+          <p:cNvPr id="42" name="ボックス_サイトに載せるもの"/>
           <p:cNvSpPr/>
           <p:nvPr/>
         </p:nvSpPr>
         <p:spPr>
           <a:xfrm>
-            <a:off x="4334150" y="1536332"/>
-            <a:ext cx="3523699" cy="3523699"/>
-          </a:xfrm>
-          <a:prstGeom prst="blockArc">
-            <a:avLst>
-              <a:gd name="adj1" fmla="val 5580000"/>
-              <a:gd name="adj2" fmla="val 10620000"/>
-              <a:gd name="adj3" fmla="val 17600"/>
-            </a:avLst>
-          </a:prstGeom>
-          <a:solidFill>
-            <a:srgbClr val="2E9E8A"/>
-          </a:solidFill>
-          <a:ln>
-            <a:noFill/>
-          </a:ln>
-          <a:effectLst/>
-        </p:spPr>
-        <p:style>
-          <a:lnRef idx="1">
-            <a:schemeClr val="accent1"/>
-          </a:lnRef>
-          <a:fillRef idx="3">
-            <a:schemeClr val="accent1"/>
-          </a:fillRef>
-          <a:effectRef idx="0">
-            <a:schemeClr val="accent1"/>
-          </a:effectRef>
-          <a:fontRef idx="minor">
-            <a:schemeClr val="lt1"/>
-          </a:fontRef>
-        </p:style>
-        <p:txBody>
-          <a:bodyPr rtlCol="0" anchor="ctr"/>
-          <a:lstStyle/>
-          <a:p>
-            <a:pPr algn="ctr"/>
-          </a:p>
-        </p:txBody>
-      </p:sp>
-      <p:sp>
-        <p:nvSpPr>
-          <p:cNvPr id="39" name="環ラベル_見て、動く"/>
-          <p:cNvSpPr txBox="1"/>
-          <p:nvPr/>
-        </p:nvSpPr>
-        <p:spPr>
-          <a:xfrm rot="2700000">
-            <a:off x="4505655" y="4183786"/>
-            <a:ext cx="1127583" cy="281895"/>
-          </a:xfrm>
-          <a:prstGeom prst="rect">
-            <a:avLst/>
-          </a:prstGeom>
-          <a:noFill/>
-        </p:spPr>
-        <p:txBody>
-          <a:bodyPr wrap="square" lIns="0" rIns="0" tIns="0" bIns="0" anchor="ctr">
-            <a:spAutoFit/>
-          </a:bodyPr>
-          <a:lstStyle/>
-          <a:p>
-            <a:pPr algn="ctr"/>
-            <a:r>
-              <a:rPr sz="1553" b="1" spc="200">
-                <a:solidFill>
-                  <a:srgbClr val="FFFFFF"/>
-                </a:solidFill>
-                <a:latin typeface="游ゴシック"/>
-                <a:ea typeface="游ゴシック"/>
-                <a:cs typeface="游ゴシック"/>
-              </a:rPr>
-              <a:t>4 行動</a:t>
-            </a:r>
-          </a:p>
-        </p:txBody>
-      </p:sp>
-      <p:cxnSp>
-        <p:nvCxnSpPr>
-          <p:cNvPr id="40" name="接続線_見て、動く"/>
-          <p:cNvCxnSpPr/>
-          <p:nvPr/>
-        </p:nvCxnSpPr>
-        <p:spPr>
-          <a:xfrm>
-            <a:off x="3974732" y="4157965"/>
-            <a:ext cx="471333" cy="0"/>
-          </a:xfrm>
-          <a:prstGeom prst="line">
-            <a:avLst/>
-          </a:prstGeom>
-          <a:ln w="22860">
-            <a:solidFill>
-              <a:srgbClr val="2E9E8A"/>
-            </a:solidFill>
-          </a:ln>
-        </p:spPr>
-        <p:style>
-          <a:lnRef idx="2">
-            <a:schemeClr val="accent1"/>
-          </a:lnRef>
-          <a:fillRef idx="0">
-            <a:schemeClr val="accent1"/>
-          </a:fillRef>
-          <a:effectRef idx="0">
-            <a:schemeClr val="accent1"/>
-          </a:effectRef>
-          <a:fontRef idx="minor">
-            <a:schemeClr val="tx1"/>
-          </a:fontRef>
-        </p:style>
-      </p:cxnSp>
-      <p:sp>
-        <p:nvSpPr>
-          <p:cNvPr id="41" name="Oval 40"/>
-          <p:cNvSpPr/>
-          <p:nvPr/>
-        </p:nvSpPr>
-        <p:spPr>
-          <a:xfrm>
-            <a:off x="4403781" y="4115680"/>
-            <a:ext cx="84568" cy="84568"/>
-          </a:xfrm>
-          <a:prstGeom prst="ellipse">
-            <a:avLst/>
-          </a:prstGeom>
-          <a:solidFill>
-            <a:srgbClr val="2E9E8A"/>
-          </a:solidFill>
-          <a:ln>
-            <a:noFill/>
-          </a:ln>
-          <a:effectLst/>
-        </p:spPr>
-        <p:style>
-          <a:lnRef idx="1">
-            <a:schemeClr val="accent1"/>
-          </a:lnRef>
-          <a:fillRef idx="3">
-            <a:schemeClr val="accent1"/>
-          </a:fillRef>
-          <a:effectRef idx="0">
-            <a:schemeClr val="accent1"/>
-          </a:effectRef>
-          <a:fontRef idx="minor">
-            <a:schemeClr val="lt1"/>
-          </a:fontRef>
-        </p:style>
-        <p:txBody>
-          <a:bodyPr rtlCol="0" anchor="ctr"/>
-          <a:lstStyle/>
-          <a:p>
-            <a:pPr algn="ctr"/>
-          </a:p>
-        </p:txBody>
-      </p:sp>
-      <p:sp>
-        <p:nvSpPr>
-          <p:cNvPr id="42" name="カード_見て、動く"/>
-          <p:cNvSpPr/>
-          <p:nvPr/>
-        </p:nvSpPr>
-        <p:spPr>
-          <a:xfrm>
-            <a:off x="451033" y="3594173"/>
-            <a:ext cx="3523699" cy="1127583"/>
+            <a:off x="451033" y="5179838"/>
+            <a:ext cx="5778867" cy="1057109"/>
           </a:xfrm>
           <a:prstGeom prst="roundRect">
             <a:avLst>
-              <a:gd name="adj" fmla="val 14000"/>
+              <a:gd name="adj" fmla="val 10000"/>
             </a:avLst>
           </a:prstGeom>
           <a:solidFill>
@@ -10354,14 +10412,14 @@
       </p:sp>
       <p:sp>
         <p:nvSpPr>
-          <p:cNvPr id="43" name="カード色バー"/>
+          <p:cNvPr id="43" name="Rounded Rectangle 42"/>
           <p:cNvSpPr/>
           <p:nvPr/>
         </p:nvSpPr>
         <p:spPr>
           <a:xfrm>
-            <a:off x="451033" y="3805595"/>
-            <a:ext cx="56379" cy="704739"/>
+            <a:off x="451033" y="5363070"/>
+            <a:ext cx="56379" cy="690645"/>
           </a:xfrm>
           <a:prstGeom prst="roundRect">
             <a:avLst>
@@ -10369,7 +10427,7 @@
             </a:avLst>
           </a:prstGeom>
           <a:solidFill>
-            <a:srgbClr val="2E9E8A"/>
+            <a:srgbClr val="F28C3C"/>
           </a:solidFill>
           <a:ln>
             <a:noFill/>
@@ -10400,14 +10458,14 @@
       </p:sp>
       <p:sp>
         <p:nvSpPr>
-          <p:cNvPr id="44" name="STEP"/>
+          <p:cNvPr id="44" name="サイトに載せるもの_見出し"/>
           <p:cNvSpPr txBox="1"/>
           <p:nvPr/>
         </p:nvSpPr>
         <p:spPr>
           <a:xfrm>
-            <a:off x="704739" y="3735121"/>
-            <a:ext cx="3100855" cy="211421"/>
+            <a:off x="690645" y="5313738"/>
+            <a:ext cx="5356023" cy="239611"/>
           </a:xfrm>
           <a:prstGeom prst="rect">
             <a:avLst/>
@@ -10422,85 +10480,7 @@
           <a:p>
             <a:pPr algn="l"/>
             <a:r>
-              <a:rPr sz="998" b="1" spc="200">
-                <a:solidFill>
-                  <a:srgbClr val="5B6B73"/>
-                </a:solidFill>
-                <a:latin typeface="游ゴシック"/>
-                <a:ea typeface="游ゴシック"/>
-                <a:cs typeface="游ゴシック"/>
-              </a:rPr>
-              <a:t>STEP 4</a:t>
-            </a:r>
-          </a:p>
-        </p:txBody>
-      </p:sp>
-      <p:sp>
-        <p:nvSpPr>
-          <p:cNvPr id="45" name="要点_見て、動く"/>
-          <p:cNvSpPr txBox="1"/>
-          <p:nvPr/>
-        </p:nvSpPr>
-        <p:spPr>
-          <a:xfrm>
-            <a:off x="704739" y="3918353"/>
-            <a:ext cx="3100855" cy="310085"/>
-          </a:xfrm>
-          <a:prstGeom prst="rect">
-            <a:avLst/>
-          </a:prstGeom>
-          <a:noFill/>
-        </p:spPr>
-        <p:txBody>
-          <a:bodyPr wrap="square" lIns="0" rIns="0" tIns="0" bIns="0" anchor="t">
-            <a:spAutoFit/>
-          </a:bodyPr>
-          <a:lstStyle/>
-          <a:p>
-            <a:pPr algn="l"/>
-            <a:r>
-              <a:rPr sz="1720" b="1">
-                <a:solidFill>
-                  <a:srgbClr val="1F7D6C"/>
-                </a:solidFill>
-                <a:latin typeface="游ゴシック"/>
-                <a:ea typeface="游ゴシック"/>
-                <a:cs typeface="游ゴシック"/>
-              </a:rPr>
-              <a:t>見て、動く</a:t>
-            </a:r>
-          </a:p>
-        </p:txBody>
-      </p:sp>
-      <p:sp>
-        <p:nvSpPr>
-          <p:cNvPr id="46" name="説明_見て、動く"/>
-          <p:cNvSpPr txBox="1"/>
-          <p:nvPr/>
-        </p:nvSpPr>
-        <p:spPr>
-          <a:xfrm>
-            <a:off x="704739" y="4270723"/>
-            <a:ext cx="3100855" cy="380559"/>
-          </a:xfrm>
-          <a:prstGeom prst="rect">
-            <a:avLst/>
-          </a:prstGeom>
-          <a:noFill/>
-        </p:spPr>
-        <p:txBody>
-          <a:bodyPr wrap="square" lIns="0" rIns="0" tIns="0" bIns="0" anchor="t">
-            <a:spAutoFit/>
-          </a:bodyPr>
-          <a:lstStyle/>
-          <a:p>
-            <a:pPr algn="l">
-              <a:lnSpc>
-                <a:spcPct val="115000"/>
-              </a:lnSpc>
-            </a:pPr>
-            <a:r>
-              <a:rPr sz="1109" b="0">
+              <a:rPr sz="1442" b="1">
                 <a:solidFill>
                   <a:srgbClr val="26323A"/>
                 </a:solidFill>
@@ -10508,17 +10488,40 @@
                 <a:ea typeface="游ゴシック"/>
                 <a:cs typeface="游ゴシック"/>
               </a:rPr>
-              <a:t>学校は受け入れを判断し、</a:t>
-            </a:r>
-          </a:p>
+              <a:t>サイトに載せるもの</a:t>
+            </a:r>
+          </a:p>
+        </p:txBody>
+      </p:sp>
+      <p:sp>
+        <p:nvSpPr>
+          <p:cNvPr id="45" name="サイトに載せるもの_本文"/>
+          <p:cNvSpPr txBox="1"/>
+          <p:nvPr/>
+        </p:nvSpPr>
+        <p:spPr>
+          <a:xfrm>
+            <a:off x="690645" y="5609729"/>
+            <a:ext cx="5356023" cy="563791"/>
+          </a:xfrm>
+          <a:prstGeom prst="rect">
+            <a:avLst/>
+          </a:prstGeom>
+          <a:noFill/>
+        </p:spPr>
+        <p:txBody>
+          <a:bodyPr wrap="square" lIns="0" rIns="0" tIns="0" bIns="0" anchor="t">
+            <a:spAutoFit/>
+          </a:bodyPr>
+          <a:lstStyle/>
           <a:p>
             <a:pPr algn="l">
               <a:lnSpc>
-                <a:spcPct val="115000"/>
+                <a:spcPct val="120000"/>
               </a:lnSpc>
             </a:pPr>
             <a:r>
-              <a:rPr sz="1109" b="0">
+              <a:rPr sz="1165" b="0">
                 <a:solidFill>
                   <a:srgbClr val="26323A"/>
                 </a:solidFill>
@@ -10526,445 +10529,39 @@
                 <a:ea typeface="游ゴシック"/>
                 <a:cs typeface="游ゴシック"/>
               </a:rPr>
-              <a:t>次の学生は参加を決めます。</a:t>
-            </a:r>
-          </a:p>
-        </p:txBody>
-      </p:sp>
-      <p:sp>
-        <p:nvSpPr>
-          <p:cNvPr id="47" name="循環マーク白"/>
+              <a:t>プログラム内容と口コミ。学校の先生が受け入れを判断でき、</a:t>
+            </a:r>
+          </a:p>
+          <a:p>
+            <a:pPr algn="l">
+              <a:lnSpc>
+                <a:spcPct val="120000"/>
+              </a:lnSpc>
+            </a:pPr>
+            <a:r>
+              <a:rPr sz="1165" b="0">
+                <a:solidFill>
+                  <a:srgbClr val="26323A"/>
+                </a:solidFill>
+                <a:latin typeface="游ゴシック"/>
+                <a:ea typeface="游ゴシック"/>
+                <a:cs typeface="游ゴシック"/>
+              </a:rPr>
+              <a:t>学生が参加を決められる状態にする。</a:t>
+            </a:r>
+          </a:p>
+        </p:txBody>
+      </p:sp>
+      <p:sp>
+        <p:nvSpPr>
+          <p:cNvPr id="46" name="ボックス_ほかの施策"/>
           <p:cNvSpPr/>
           <p:nvPr/>
         </p:nvSpPr>
         <p:spPr>
           <a:xfrm>
-            <a:off x="5997336" y="1747754"/>
-            <a:ext cx="197327" cy="197327"/>
-          </a:xfrm>
-          <a:prstGeom prst="ellipse">
-            <a:avLst/>
-          </a:prstGeom>
-          <a:solidFill>
-            <a:srgbClr val="FFFFFF"/>
-          </a:solidFill>
-          <a:ln>
-            <a:noFill/>
-          </a:ln>
-          <a:effectLst/>
-        </p:spPr>
-        <p:style>
-          <a:lnRef idx="1">
-            <a:schemeClr val="accent1"/>
-          </a:lnRef>
-          <a:fillRef idx="3">
-            <a:schemeClr val="accent1"/>
-          </a:fillRef>
-          <a:effectRef idx="0">
-            <a:schemeClr val="accent1"/>
-          </a:effectRef>
-          <a:fontRef idx="minor">
-            <a:schemeClr val="lt1"/>
-          </a:fontRef>
-        </p:style>
-        <p:txBody>
-          <a:bodyPr rtlCol="0" anchor="ctr"/>
-          <a:lstStyle/>
-          <a:p>
-            <a:pPr algn="ctr"/>
-          </a:p>
-        </p:txBody>
-      </p:sp>
-      <p:sp>
-        <p:nvSpPr>
-          <p:cNvPr id="48" name="循環マーク矢印"/>
-          <p:cNvSpPr/>
-          <p:nvPr/>
-        </p:nvSpPr>
-        <p:spPr>
-          <a:xfrm>
-            <a:off x="6067810" y="1818228"/>
-            <a:ext cx="84569" cy="56380"/>
-          </a:xfrm>
-          <a:custGeom>
-            <a:avLst/>
-            <a:gdLst/>
-            <a:ahLst/>
-            <a:cxnLst/>
-            <a:rect l="l" t="t" r="r" b="b"/>
-            <a:pathLst>
-              <a:path w="84569" h="56380">
-                <a:moveTo>
-                  <a:pt x="84569" y="28190"/>
-                </a:moveTo>
-                <a:lnTo>
-                  <a:pt x="0" y="56380"/>
-                </a:lnTo>
-                <a:lnTo>
-                  <a:pt x="0" y="0"/>
-                </a:lnTo>
-                <a:close/>
-              </a:path>
-            </a:pathLst>
-          </a:custGeom>
-          <a:solidFill>
-            <a:srgbClr val="2E9E8A"/>
-          </a:solidFill>
-          <a:ln>
-            <a:noFill/>
-          </a:ln>
-          <a:effectLst/>
-        </p:spPr>
-        <p:style>
-          <a:lnRef idx="1">
-            <a:schemeClr val="accent1"/>
-          </a:lnRef>
-          <a:fillRef idx="3">
-            <a:schemeClr val="accent1"/>
-          </a:fillRef>
-          <a:effectRef idx="0">
-            <a:schemeClr val="accent1"/>
-          </a:effectRef>
-          <a:fontRef idx="minor">
-            <a:schemeClr val="lt1"/>
-          </a:fontRef>
-        </p:style>
-        <p:txBody>
-          <a:bodyPr rtlCol="0" anchor="ctr"/>
-          <a:lstStyle/>
-          <a:p>
-            <a:pPr algn="ctr"/>
-          </a:p>
-        </p:txBody>
-      </p:sp>
-      <p:sp>
-        <p:nvSpPr>
-          <p:cNvPr id="49" name="循環マーク白"/>
-          <p:cNvSpPr/>
-          <p:nvPr/>
-        </p:nvSpPr>
-        <p:spPr>
-          <a:xfrm>
-            <a:off x="7449100" y="3199519"/>
-            <a:ext cx="197327" cy="197327"/>
-          </a:xfrm>
-          <a:prstGeom prst="ellipse">
-            <a:avLst/>
-          </a:prstGeom>
-          <a:solidFill>
-            <a:srgbClr val="FFFFFF"/>
-          </a:solidFill>
-          <a:ln>
-            <a:noFill/>
-          </a:ln>
-          <a:effectLst/>
-        </p:spPr>
-        <p:style>
-          <a:lnRef idx="1">
-            <a:schemeClr val="accent1"/>
-          </a:lnRef>
-          <a:fillRef idx="3">
-            <a:schemeClr val="accent1"/>
-          </a:fillRef>
-          <a:effectRef idx="0">
-            <a:schemeClr val="accent1"/>
-          </a:effectRef>
-          <a:fontRef idx="minor">
-            <a:schemeClr val="lt1"/>
-          </a:fontRef>
-        </p:style>
-        <p:txBody>
-          <a:bodyPr rtlCol="0" anchor="ctr"/>
-          <a:lstStyle/>
-          <a:p>
-            <a:pPr algn="ctr"/>
-          </a:p>
-        </p:txBody>
-      </p:sp>
-      <p:sp>
-        <p:nvSpPr>
-          <p:cNvPr id="50" name="循環マーク矢印"/>
-          <p:cNvSpPr/>
-          <p:nvPr/>
-        </p:nvSpPr>
-        <p:spPr>
-          <a:xfrm>
-            <a:off x="7519574" y="3269993"/>
-            <a:ext cx="56379" cy="84568"/>
-          </a:xfrm>
-          <a:custGeom>
-            <a:avLst/>
-            <a:gdLst/>
-            <a:ahLst/>
-            <a:cxnLst/>
-            <a:rect l="l" t="t" r="r" b="b"/>
-            <a:pathLst>
-              <a:path w="56379" h="84568">
-                <a:moveTo>
-                  <a:pt x="28190" y="84568"/>
-                </a:moveTo>
-                <a:lnTo>
-                  <a:pt x="0" y="0"/>
-                </a:lnTo>
-                <a:lnTo>
-                  <a:pt x="56379" y="0"/>
-                </a:lnTo>
-                <a:close/>
-              </a:path>
-            </a:pathLst>
-          </a:custGeom>
-          <a:solidFill>
-            <a:srgbClr val="2E9E8A"/>
-          </a:solidFill>
-          <a:ln>
-            <a:noFill/>
-          </a:ln>
-          <a:effectLst/>
-        </p:spPr>
-        <p:style>
-          <a:lnRef idx="1">
-            <a:schemeClr val="accent1"/>
-          </a:lnRef>
-          <a:fillRef idx="3">
-            <a:schemeClr val="accent1"/>
-          </a:fillRef>
-          <a:effectRef idx="0">
-            <a:schemeClr val="accent1"/>
-          </a:effectRef>
-          <a:fontRef idx="minor">
-            <a:schemeClr val="lt1"/>
-          </a:fontRef>
-        </p:style>
-        <p:txBody>
-          <a:bodyPr rtlCol="0" anchor="ctr"/>
-          <a:lstStyle/>
-          <a:p>
-            <a:pPr algn="ctr"/>
-          </a:p>
-        </p:txBody>
-      </p:sp>
-      <p:sp>
-        <p:nvSpPr>
-          <p:cNvPr id="51" name="循環マーク白"/>
-          <p:cNvSpPr/>
-          <p:nvPr/>
-        </p:nvSpPr>
-        <p:spPr>
-          <a:xfrm>
-            <a:off x="5997336" y="4651283"/>
-            <a:ext cx="197327" cy="197327"/>
-          </a:xfrm>
-          <a:prstGeom prst="ellipse">
-            <a:avLst/>
-          </a:prstGeom>
-          <a:solidFill>
-            <a:srgbClr val="FFFFFF"/>
-          </a:solidFill>
-          <a:ln>
-            <a:noFill/>
-          </a:ln>
-          <a:effectLst/>
-        </p:spPr>
-        <p:style>
-          <a:lnRef idx="1">
-            <a:schemeClr val="accent1"/>
-          </a:lnRef>
-          <a:fillRef idx="3">
-            <a:schemeClr val="accent1"/>
-          </a:fillRef>
-          <a:effectRef idx="0">
-            <a:schemeClr val="accent1"/>
-          </a:effectRef>
-          <a:fontRef idx="minor">
-            <a:schemeClr val="lt1"/>
-          </a:fontRef>
-        </p:style>
-        <p:txBody>
-          <a:bodyPr rtlCol="0" anchor="ctr"/>
-          <a:lstStyle/>
-          <a:p>
-            <a:pPr algn="ctr"/>
-          </a:p>
-        </p:txBody>
-      </p:sp>
-      <p:sp>
-        <p:nvSpPr>
-          <p:cNvPr id="52" name="循環マーク矢印"/>
-          <p:cNvSpPr/>
-          <p:nvPr/>
-        </p:nvSpPr>
-        <p:spPr>
-          <a:xfrm>
-            <a:off x="6039620" y="4721757"/>
-            <a:ext cx="84569" cy="56379"/>
-          </a:xfrm>
-          <a:custGeom>
-            <a:avLst/>
-            <a:gdLst/>
-            <a:ahLst/>
-            <a:cxnLst/>
-            <a:rect l="l" t="t" r="r" b="b"/>
-            <a:pathLst>
-              <a:path w="84569" h="56379">
-                <a:moveTo>
-                  <a:pt x="0" y="28189"/>
-                </a:moveTo>
-                <a:lnTo>
-                  <a:pt x="84569" y="0"/>
-                </a:lnTo>
-                <a:lnTo>
-                  <a:pt x="84569" y="56379"/>
-                </a:lnTo>
-                <a:close/>
-              </a:path>
-            </a:pathLst>
-          </a:custGeom>
-          <a:solidFill>
-            <a:srgbClr val="2E9E8A"/>
-          </a:solidFill>
-          <a:ln>
-            <a:noFill/>
-          </a:ln>
-          <a:effectLst/>
-        </p:spPr>
-        <p:style>
-          <a:lnRef idx="1">
-            <a:schemeClr val="accent1"/>
-          </a:lnRef>
-          <a:fillRef idx="3">
-            <a:schemeClr val="accent1"/>
-          </a:fillRef>
-          <a:effectRef idx="0">
-            <a:schemeClr val="accent1"/>
-          </a:effectRef>
-          <a:fontRef idx="minor">
-            <a:schemeClr val="lt1"/>
-          </a:fontRef>
-        </p:style>
-        <p:txBody>
-          <a:bodyPr rtlCol="0" anchor="ctr"/>
-          <a:lstStyle/>
-          <a:p>
-            <a:pPr algn="ctr"/>
-          </a:p>
-        </p:txBody>
-      </p:sp>
-      <p:sp>
-        <p:nvSpPr>
-          <p:cNvPr id="53" name="循環マーク白"/>
-          <p:cNvSpPr/>
-          <p:nvPr/>
-        </p:nvSpPr>
-        <p:spPr>
-          <a:xfrm>
-            <a:off x="4545572" y="3199519"/>
-            <a:ext cx="197327" cy="197327"/>
-          </a:xfrm>
-          <a:prstGeom prst="ellipse">
-            <a:avLst/>
-          </a:prstGeom>
-          <a:solidFill>
-            <a:srgbClr val="FFFFFF"/>
-          </a:solidFill>
-          <a:ln>
-            <a:noFill/>
-          </a:ln>
-          <a:effectLst/>
-        </p:spPr>
-        <p:style>
-          <a:lnRef idx="1">
-            <a:schemeClr val="accent1"/>
-          </a:lnRef>
-          <a:fillRef idx="3">
-            <a:schemeClr val="accent1"/>
-          </a:fillRef>
-          <a:effectRef idx="0">
-            <a:schemeClr val="accent1"/>
-          </a:effectRef>
-          <a:fontRef idx="minor">
-            <a:schemeClr val="lt1"/>
-          </a:fontRef>
-        </p:style>
-        <p:txBody>
-          <a:bodyPr rtlCol="0" anchor="ctr"/>
-          <a:lstStyle/>
-          <a:p>
-            <a:pPr algn="ctr"/>
-          </a:p>
-        </p:txBody>
-      </p:sp>
-      <p:sp>
-        <p:nvSpPr>
-          <p:cNvPr id="54" name="循環マーク矢印"/>
-          <p:cNvSpPr/>
-          <p:nvPr/>
-        </p:nvSpPr>
-        <p:spPr>
-          <a:xfrm>
-            <a:off x="4616046" y="3241803"/>
-            <a:ext cx="56379" cy="84569"/>
-          </a:xfrm>
-          <a:custGeom>
-            <a:avLst/>
-            <a:gdLst/>
-            <a:ahLst/>
-            <a:cxnLst/>
-            <a:rect l="l" t="t" r="r" b="b"/>
-            <a:pathLst>
-              <a:path w="56379" h="84569">
-                <a:moveTo>
-                  <a:pt x="28189" y="0"/>
-                </a:moveTo>
-                <a:lnTo>
-                  <a:pt x="56379" y="84569"/>
-                </a:lnTo>
-                <a:lnTo>
-                  <a:pt x="0" y="84569"/>
-                </a:lnTo>
-                <a:close/>
-              </a:path>
-            </a:pathLst>
-          </a:custGeom>
-          <a:solidFill>
-            <a:srgbClr val="2E9E8A"/>
-          </a:solidFill>
-          <a:ln>
-            <a:noFill/>
-          </a:ln>
-          <a:effectLst/>
-        </p:spPr>
-        <p:style>
-          <a:lnRef idx="1">
-            <a:schemeClr val="accent1"/>
-          </a:lnRef>
-          <a:fillRef idx="3">
-            <a:schemeClr val="accent1"/>
-          </a:fillRef>
-          <a:effectRef idx="0">
-            <a:schemeClr val="accent1"/>
-          </a:effectRef>
-          <a:fontRef idx="minor">
-            <a:schemeClr val="lt1"/>
-          </a:fontRef>
-        </p:style>
-        <p:txBody>
-          <a:bodyPr rtlCol="0" anchor="ctr"/>
-          <a:lstStyle/>
-          <a:p>
-            <a:pPr algn="ctr"/>
-          </a:p>
-        </p:txBody>
-      </p:sp>
-      <p:sp>
-        <p:nvSpPr>
-          <p:cNvPr id="55" name="ボックス_サイトに載せるもの"/>
-          <p:cNvSpPr/>
-          <p:nvPr/>
-        </p:nvSpPr>
-        <p:spPr>
-          <a:xfrm>
-            <a:off x="451033" y="5179838"/>
-            <a:ext cx="5778867" cy="1057109"/>
+            <a:off x="6413132" y="5179838"/>
+            <a:ext cx="5327833" cy="1057109"/>
           </a:xfrm>
           <a:prstGeom prst="roundRect">
             <a:avLst>
@@ -11009,201 +10606,7 @@
       </p:sp>
       <p:sp>
         <p:nvSpPr>
-          <p:cNvPr id="56" name="Rounded Rectangle 55"/>
-          <p:cNvSpPr/>
-          <p:nvPr/>
-        </p:nvSpPr>
-        <p:spPr>
-          <a:xfrm>
-            <a:off x="451033" y="5363070"/>
-            <a:ext cx="56379" cy="690645"/>
-          </a:xfrm>
-          <a:prstGeom prst="roundRect">
-            <a:avLst>
-              <a:gd name="adj" fmla="val 50000"/>
-            </a:avLst>
-          </a:prstGeom>
-          <a:solidFill>
-            <a:srgbClr val="F28C3C"/>
-          </a:solidFill>
-          <a:ln>
-            <a:noFill/>
-          </a:ln>
-          <a:effectLst/>
-        </p:spPr>
-        <p:style>
-          <a:lnRef idx="1">
-            <a:schemeClr val="accent1"/>
-          </a:lnRef>
-          <a:fillRef idx="3">
-            <a:schemeClr val="accent1"/>
-          </a:fillRef>
-          <a:effectRef idx="0">
-            <a:schemeClr val="accent1"/>
-          </a:effectRef>
-          <a:fontRef idx="minor">
-            <a:schemeClr val="lt1"/>
-          </a:fontRef>
-        </p:style>
-        <p:txBody>
-          <a:bodyPr rtlCol="0" anchor="ctr"/>
-          <a:lstStyle/>
-          <a:p>
-            <a:pPr algn="ctr"/>
-          </a:p>
-        </p:txBody>
-      </p:sp>
-      <p:sp>
-        <p:nvSpPr>
-          <p:cNvPr id="57" name="サイトに載せるもの_見出し"/>
-          <p:cNvSpPr txBox="1"/>
-          <p:nvPr/>
-        </p:nvSpPr>
-        <p:spPr>
-          <a:xfrm>
-            <a:off x="690645" y="5313738"/>
-            <a:ext cx="5356023" cy="239611"/>
-          </a:xfrm>
-          <a:prstGeom prst="rect">
-            <a:avLst/>
-          </a:prstGeom>
-          <a:noFill/>
-        </p:spPr>
-        <p:txBody>
-          <a:bodyPr wrap="square" lIns="0" rIns="0" tIns="0" bIns="0" anchor="t">
-            <a:spAutoFit/>
-          </a:bodyPr>
-          <a:lstStyle/>
-          <a:p>
-            <a:pPr algn="l"/>
-            <a:r>
-              <a:rPr sz="1442" b="1">
-                <a:solidFill>
-                  <a:srgbClr val="26323A"/>
-                </a:solidFill>
-                <a:latin typeface="游ゴシック"/>
-                <a:ea typeface="游ゴシック"/>
-                <a:cs typeface="游ゴシック"/>
-              </a:rPr>
-              <a:t>サイトに載せるもの</a:t>
-            </a:r>
-          </a:p>
-        </p:txBody>
-      </p:sp>
-      <p:sp>
-        <p:nvSpPr>
-          <p:cNvPr id="58" name="サイトに載せるもの_本文"/>
-          <p:cNvSpPr txBox="1"/>
-          <p:nvPr/>
-        </p:nvSpPr>
-        <p:spPr>
-          <a:xfrm>
-            <a:off x="690645" y="5609729"/>
-            <a:ext cx="5356023" cy="563791"/>
-          </a:xfrm>
-          <a:prstGeom prst="rect">
-            <a:avLst/>
-          </a:prstGeom>
-          <a:noFill/>
-        </p:spPr>
-        <p:txBody>
-          <a:bodyPr wrap="square" lIns="0" rIns="0" tIns="0" bIns="0" anchor="t">
-            <a:spAutoFit/>
-          </a:bodyPr>
-          <a:lstStyle/>
-          <a:p>
-            <a:pPr algn="l">
-              <a:lnSpc>
-                <a:spcPct val="120000"/>
-              </a:lnSpc>
-            </a:pPr>
-            <a:r>
-              <a:rPr sz="1165" b="0">
-                <a:solidFill>
-                  <a:srgbClr val="26323A"/>
-                </a:solidFill>
-                <a:latin typeface="游ゴシック"/>
-                <a:ea typeface="游ゴシック"/>
-                <a:cs typeface="游ゴシック"/>
-              </a:rPr>
-              <a:t>プログラム内容と口コミ。学校の先生が受け入れを判断でき、</a:t>
-            </a:r>
-          </a:p>
-          <a:p>
-            <a:pPr algn="l">
-              <a:lnSpc>
-                <a:spcPct val="120000"/>
-              </a:lnSpc>
-            </a:pPr>
-            <a:r>
-              <a:rPr sz="1165" b="0">
-                <a:solidFill>
-                  <a:srgbClr val="26323A"/>
-                </a:solidFill>
-                <a:latin typeface="游ゴシック"/>
-                <a:ea typeface="游ゴシック"/>
-                <a:cs typeface="游ゴシック"/>
-              </a:rPr>
-              <a:t>学生が参加を決められる状態にする。</a:t>
-            </a:r>
-          </a:p>
-        </p:txBody>
-      </p:sp>
-      <p:sp>
-        <p:nvSpPr>
-          <p:cNvPr id="59" name="ボックス_ほかの施策"/>
-          <p:cNvSpPr/>
-          <p:nvPr/>
-        </p:nvSpPr>
-        <p:spPr>
-          <a:xfrm>
-            <a:off x="6413132" y="5179838"/>
-            <a:ext cx="5327833" cy="1057109"/>
-          </a:xfrm>
-          <a:prstGeom prst="roundRect">
-            <a:avLst>
-              <a:gd name="adj" fmla="val 10000"/>
-            </a:avLst>
-          </a:prstGeom>
-          <a:solidFill>
-            <a:srgbClr val="FFFFFF"/>
-          </a:solidFill>
-          <a:ln>
-            <a:noFill/>
-          </a:ln>
-          <a:effectLst>
-            <a:outerShdw blurRad="112758" dist="42284" dir="5400000" algn="t" rotWithShape="0">
-              <a:srgbClr val="2E9E8A">
-                <a:alpha val="16000"/>
-              </a:srgbClr>
-            </a:outerShdw>
-          </a:effectLst>
-        </p:spPr>
-        <p:style>
-          <a:lnRef idx="1">
-            <a:schemeClr val="accent1"/>
-          </a:lnRef>
-          <a:fillRef idx="3">
-            <a:schemeClr val="accent1"/>
-          </a:fillRef>
-          <a:effectRef idx="0">
-            <a:schemeClr val="accent1"/>
-          </a:effectRef>
-          <a:fontRef idx="minor">
-            <a:schemeClr val="lt1"/>
-          </a:fontRef>
-        </p:style>
-        <p:txBody>
-          <a:bodyPr rtlCol="0" anchor="ctr"/>
-          <a:lstStyle/>
-          <a:p>
-            <a:pPr algn="ctr"/>
-          </a:p>
-        </p:txBody>
-      </p:sp>
-      <p:sp>
-        <p:nvSpPr>
-          <p:cNvPr id="60" name="Rounded Rectangle 59"/>
+          <p:cNvPr id="47" name="Rounded Rectangle 46"/>
           <p:cNvSpPr/>
           <p:nvPr/>
         </p:nvSpPr>
@@ -11249,7 +10652,7 @@
       </p:sp>
       <p:sp>
         <p:nvSpPr>
-          <p:cNvPr id="61" name="ほかの施策_見出し"/>
+          <p:cNvPr id="48" name="ほかの施策_見出し"/>
           <p:cNvSpPr txBox="1"/>
           <p:nvPr/>
         </p:nvSpPr>
@@ -11286,7 +10689,7 @@
       </p:sp>
       <p:sp>
         <p:nvSpPr>
-          <p:cNvPr id="62" name="ほかの施策_本文"/>
+          <p:cNvPr id="49" name="ほかの施策_本文"/>
           <p:cNvSpPr txBox="1"/>
           <p:nvPr/>
         </p:nvSpPr>

</xml_diff>

<commit_message>
Cover illustration from LINE banner, continuous population to 2100, drop base-count slide
Co-Authored-By: Claude Sonnet 5.5 <noreply@anthropic.com>
Claude-Session: https://claude.ai/code/session_01MxdMxhi7qZAPC9aBAhtpWC
</commit_message>
<xml_diff>
--- a/kyoiku-jisshu/共育実習_図解.pptx
+++ b/kyoiku-jisshu/共育実習_図解.pptx
@@ -23,7 +23,6 @@
     <p:sldId id="271" r:id="rId23"/>
     <p:sldId id="272" r:id="rId24"/>
     <p:sldId id="273" r:id="rId25"/>
-    <p:sldId id="274" r:id="rId26"/>
   </p:sldIdLst>
   <p:sldSz cx="12192000" cy="6857119" type="screen4x3"/>
   <p:notesSz cx="6858000" cy="9144000"/>
@@ -1513,7 +1512,7 @@
               <c:strCache>
                 <c:ptCount val="1"/>
                 <c:pt idx="0">
-                  <c:v>参考（国連・5年ごと）</c:v>
+                  <c:v>参考（国連推計。5年ごとの値を結んだ年次）</c:v>
                 </c:pt>
               </c:strCache>
             </c:strRef>
@@ -1999,20 +1998,92 @@
               <c:numCache>
                 <c:formatCode>General</c:formatCode>
                 <c:ptCount val="154"/>
+                <c:pt idx="124">
+                  <c:v>8675</c:v>
+                </c:pt>
+                <c:pt idx="125">
+                  <c:v>8650</c:v>
+                </c:pt>
+                <c:pt idx="126">
+                  <c:v>8625</c:v>
+                </c:pt>
+                <c:pt idx="127">
+                  <c:v>8600</c:v>
+                </c:pt>
                 <c:pt idx="128">
                   <c:v>8575</c:v>
                 </c:pt>
+                <c:pt idx="129">
+                  <c:v>8517</c:v>
+                </c:pt>
+                <c:pt idx="130">
+                  <c:v>8459</c:v>
+                </c:pt>
+                <c:pt idx="131">
+                  <c:v>8400</c:v>
+                </c:pt>
+                <c:pt idx="132">
+                  <c:v>8342</c:v>
+                </c:pt>
                 <c:pt idx="133">
                   <c:v>8284</c:v>
                 </c:pt>
+                <c:pt idx="134">
+                  <c:v>8233</c:v>
+                </c:pt>
+                <c:pt idx="135">
+                  <c:v>8182</c:v>
+                </c:pt>
+                <c:pt idx="136">
+                  <c:v>8132</c:v>
+                </c:pt>
+                <c:pt idx="137">
+                  <c:v>8081</c:v>
+                </c:pt>
                 <c:pt idx="138">
                   <c:v>8030</c:v>
                 </c:pt>
+                <c:pt idx="139">
+                  <c:v>7983</c:v>
+                </c:pt>
+                <c:pt idx="140">
+                  <c:v>7936</c:v>
+                </c:pt>
+                <c:pt idx="141">
+                  <c:v>7890</c:v>
+                </c:pt>
+                <c:pt idx="142">
+                  <c:v>7843</c:v>
+                </c:pt>
                 <c:pt idx="143">
                   <c:v>7796</c:v>
                 </c:pt>
+                <c:pt idx="144">
+                  <c:v>7752</c:v>
+                </c:pt>
+                <c:pt idx="145">
+                  <c:v>7707</c:v>
+                </c:pt>
+                <c:pt idx="146">
+                  <c:v>7663</c:v>
+                </c:pt>
+                <c:pt idx="147">
+                  <c:v>7618</c:v>
+                </c:pt>
                 <c:pt idx="148">
                   <c:v>7574</c:v>
+                </c:pt>
+                <c:pt idx="149">
+                  <c:v>7532</c:v>
+                </c:pt>
+                <c:pt idx="150">
+                  <c:v>7490</c:v>
+                </c:pt>
+                <c:pt idx="151">
+                  <c:v>7448</c:v>
+                </c:pt>
+                <c:pt idx="152">
+                  <c:v>7406</c:v>
                 </c:pt>
                 <c:pt idx="153">
                   <c:v>7364</c:v>
@@ -2476,211 +2547,6 @@
         </a:p>
       </c:txPr>
     </c:legend>
-    <c:dispBlanksAs val="gap"/>
-  </c:chart>
-  <c:txPr>
-    <a:bodyPr/>
-    <a:lstStyle/>
-    <a:p>
-      <a:pPr>
-        <a:defRPr sz="1800"/>
-      </a:pPr>
-      <a:endParaRPr lang="en-US"/>
-    </a:p>
-  </c:txPr>
-  <c:externalData r:id="rId1">
-    <c:autoUpdate val="0"/>
-  </c:externalData>
-</c:chartSpace>
-</file>
-
-<file path=ppt/charts/chart3.xml><?xml version="1.0" encoding="utf-8"?>
-<c:chartSpace xmlns:c="http://schemas.openxmlformats.org/drawingml/2006/chart" xmlns:a="http://schemas.openxmlformats.org/drawingml/2006/main" xmlns:r="http://schemas.openxmlformats.org/officeDocument/2006/relationships">
-  <c:date1904 val="0"/>
-  <c:chart>
-    <c:autoTitleDeleted val="1"/>
-    <c:plotArea>
-      <c:barChart>
-        <c:barDir val="col"/>
-        <c:grouping val="clustered"/>
-        <c:ser>
-          <c:idx val="0"/>
-          <c:order val="0"/>
-          <c:tx>
-            <c:strRef>
-              <c:f>Sheet1!$B$1</c:f>
-              <c:strCache>
-                <c:ptCount val="1"/>
-                <c:pt idx="0">
-                  <c:v>拠点数</c:v>
-                </c:pt>
-              </c:strCache>
-            </c:strRef>
-          </c:tx>
-          <c:dPt>
-            <c:idx val="0"/>
-            <c:spPr>
-              <a:solidFill>
-                <a:srgbClr val="F28C3C"/>
-              </a:solidFill>
-            </c:spPr>
-          </c:dPt>
-          <c:dPt>
-            <c:idx val="1"/>
-            <c:spPr>
-              <a:solidFill>
-                <a:srgbClr val="3FB39D"/>
-              </a:solidFill>
-            </c:spPr>
-          </c:dPt>
-          <c:dPt>
-            <c:idx val="2"/>
-            <c:spPr>
-              <a:solidFill>
-                <a:srgbClr val="3FB39D"/>
-              </a:solidFill>
-            </c:spPr>
-          </c:dPt>
-          <c:dPt>
-            <c:idx val="3"/>
-            <c:spPr>
-              <a:solidFill>
-                <a:srgbClr val="3FB39D"/>
-              </a:solidFill>
-            </c:spPr>
-          </c:dPt>
-          <c:dPt>
-            <c:idx val="4"/>
-            <c:spPr>
-              <a:solidFill>
-                <a:srgbClr val="3FB39D"/>
-              </a:solidFill>
-            </c:spPr>
-          </c:dPt>
-          <c:cat>
-            <c:strRef>
-              <c:f>Sheet1!$A$2:$A$6</c:f>
-              <c:strCache>
-                <c:ptCount val="5"/>
-                <c:pt idx="0">
-                  <c:v>長野県</c:v>
-                </c:pt>
-                <c:pt idx="1">
-                  <c:v>新潟県</c:v>
-                </c:pt>
-                <c:pt idx="2">
-                  <c:v>埼玉県</c:v>
-                </c:pt>
-                <c:pt idx="3">
-                  <c:v>群馬県</c:v>
-                </c:pt>
-                <c:pt idx="4">
-                  <c:v>栃木県</c:v>
-                </c:pt>
-              </c:strCache>
-            </c:strRef>
-          </c:cat>
-          <c:val>
-            <c:numRef>
-              <c:f>Sheet1!$B$2:$B$6</c:f>
-              <c:numCache>
-                <c:formatCode>General</c:formatCode>
-                <c:ptCount val="5"/>
-                <c:pt idx="0">
-                  <c:v>57</c:v>
-                </c:pt>
-                <c:pt idx="1">
-                  <c:v>15</c:v>
-                </c:pt>
-                <c:pt idx="2">
-                  <c:v>15</c:v>
-                </c:pt>
-                <c:pt idx="3">
-                  <c:v>12</c:v>
-                </c:pt>
-                <c:pt idx="4">
-                  <c:v>10</c:v>
-                </c:pt>
-              </c:numCache>
-            </c:numRef>
-          </c:val>
-        </c:ser>
-        <c:dLbls>
-          <c:numFmt formatCode="0" sourceLinked="0"/>
-          <c:txPr>
-            <a:bodyPr/>
-            <a:lstStyle/>
-            <a:p>
-              <a:pPr>
-                <a:defRPr sz="2800" b="1">
-                  <a:latin typeface="游ゴシック"/>
-                </a:defRPr>
-              </a:pPr>
-            </a:p>
-          </c:txPr>
-          <c:dLblPos val="outEnd"/>
-          <c:showLegendKey val="0"/>
-          <c:showVal val="1"/>
-          <c:showCatName val="0"/>
-          <c:showSerName val="0"/>
-          <c:showPercent val="0"/>
-          <c:showBubbleSize val="0"/>
-          <c:showLeaderLines val="1"/>
-        </c:dLbls>
-        <c:gapWidth val="50"/>
-        <c:axId val="-2068027336"/>
-        <c:axId val="-2113994440"/>
-      </c:barChart>
-      <c:catAx>
-        <c:axId val="-2068027336"/>
-        <c:scaling>
-          <c:orientation val="minMax"/>
-        </c:scaling>
-        <c:delete val="0"/>
-        <c:axPos val="b"/>
-        <c:majorTickMark val="out"/>
-        <c:minorTickMark val="none"/>
-        <c:tickLblPos val="nextTo"/>
-        <c:spPr>
-          <a:ln>
-            <a:solidFill>
-              <a:srgbClr val="C9D6D1"/>
-            </a:solidFill>
-          </a:ln>
-        </c:spPr>
-        <c:txPr>
-          <a:bodyPr/>
-          <a:lstStyle/>
-          <a:p>
-            <a:pPr>
-              <a:defRPr sz="2200">
-                <a:latin typeface="游ゴシック"/>
-              </a:defRPr>
-            </a:pPr>
-          </a:p>
-        </c:txPr>
-        <c:crossAx val="-2113994440"/>
-        <c:crosses val="autoZero"/>
-        <c:auto val="1"/>
-        <c:lblAlgn val="ctr"/>
-        <c:lblOffset val="100"/>
-        <c:noMultiLvlLbl val="0"/>
-      </c:catAx>
-      <c:valAx>
-        <c:axId val="-2113994440"/>
-        <c:scaling>
-          <c:max val="66.0"/>
-          <c:min val="0.0"/>
-        </c:scaling>
-        <c:delete/>
-        <c:axPos val="l"/>
-        <c:majorTickMark val="out"/>
-        <c:minorTickMark val="none"/>
-        <c:tickLblPos val="nextTo"/>
-        <c:crossAx val="-2068027336"/>
-        <c:crosses val="autoZero"/>
-      </c:valAx>
-    </c:plotArea>
     <c:dispBlanksAs val="gap"/>
   </c:chart>
   <c:txPr>
@@ -3235,76 +3101,6 @@
           <a:p>
             <a:r>
               <a:t>申込から振り返りまでの流れと、サイトのコンテンツ。</a:t>
-            </a:r>
-          </a:p>
-        </p:txBody>
-      </p:sp>
-      <p:sp>
-        <p:nvSpPr>
-          <p:cNvPr id="4" name="Slide Number Placeholder 3"/>
-          <p:cNvSpPr>
-            <a:spLocks noGrp="1"/>
-          </p:cNvSpPr>
-          <p:nvPr>
-            <p:ph type="sldNum" idx="5" sz="quarter"/>
-          </p:nvPr>
-        </p:nvSpPr>
-        <p:spPr/>
-      </p:sp>
-    </p:spTree>
-  </p:cSld>
-  <p:clrMapOvr>
-    <a:masterClrMapping/>
-  </p:clrMapOvr>
-</p:notes>
-</file>
-
-<file path=ppt/notesSlides/notesSlide12.xml><?xml version="1.0" encoding="utf-8"?>
-<p:notes xmlns:a="http://schemas.openxmlformats.org/drawingml/2006/main" xmlns:p="http://schemas.openxmlformats.org/presentationml/2006/main" xmlns:r="http://schemas.openxmlformats.org/officeDocument/2006/relationships">
-  <p:cSld>
-    <p:spTree>
-      <p:nvGrpSpPr>
-        <p:cNvPr id="1" name=""/>
-        <p:cNvGrpSpPr/>
-        <p:nvPr/>
-      </p:nvGrpSpPr>
-      <p:grpSpPr>
-        <a:xfrm>
-          <a:off x="0" y="0"/>
-          <a:ext cx="0" cy="0"/>
-          <a:chOff x="0" y="0"/>
-          <a:chExt cx="0" cy="0"/>
-        </a:xfrm>
-      </p:grpSpPr>
-      <p:sp>
-        <p:nvSpPr>
-          <p:cNvPr id="2" name="Slide Image Placeholder 1"/>
-          <p:cNvSpPr>
-            <a:spLocks noGrp="1"/>
-          </p:cNvSpPr>
-          <p:nvPr>
-            <p:ph type="sldImg" idx="2"/>
-          </p:nvPr>
-        </p:nvSpPr>
-        <p:spPr/>
-      </p:sp>
-      <p:sp>
-        <p:nvSpPr>
-          <p:cNvPr id="3" name="Notes Placeholder 2"/>
-          <p:cNvSpPr>
-            <a:spLocks noGrp="1"/>
-          </p:cNvSpPr>
-          <p:nvPr>
-            <p:ph type="body" idx="3" sz="quarter"/>
-          </p:nvPr>
-        </p:nvSpPr>
-        <p:spPr/>
-        <p:txBody>
-          <a:bodyPr/>
-          <a:lstStyle/>
-          <a:p>
-            <a:r>
-              <a:t>7種109拠点。</a:t>
             </a:r>
           </a:p>
         </p:txBody>
@@ -7233,52 +7029,30 @@
           </a:p>
         </p:txBody>
       </p:sp>
-      <p:sp>
-        <p:nvSpPr>
-          <p:cNvPr id="9" name="イラスト枠（公式LINEバナーのイラストを配置）"/>
-          <p:cNvSpPr/>
-          <p:nvPr/>
-        </p:nvSpPr>
-        <p:spPr>
-          <a:xfrm>
-            <a:off x="7117873" y="916162"/>
-            <a:ext cx="4510335" cy="5003653"/>
-          </a:xfrm>
-          <a:prstGeom prst="roundRect">
-            <a:avLst>
-              <a:gd name="adj" fmla="val 6250"/>
-            </a:avLst>
-          </a:prstGeom>
-          <a:solidFill>
-            <a:srgbClr val="A6DDD1"/>
-          </a:solidFill>
-          <a:ln>
-            <a:noFill/>
-          </a:ln>
-          <a:effectLst/>
-        </p:spPr>
-        <p:style>
-          <a:lnRef idx="1">
-            <a:schemeClr val="accent1"/>
-          </a:lnRef>
-          <a:fillRef idx="3">
-            <a:schemeClr val="accent1"/>
-          </a:fillRef>
-          <a:effectRef idx="0">
-            <a:schemeClr val="accent1"/>
-          </a:effectRef>
-          <a:fontRef idx="minor">
-            <a:schemeClr val="lt1"/>
-          </a:fontRef>
-        </p:style>
-        <p:txBody>
-          <a:bodyPr rtlCol="0" anchor="ctr"/>
-          <a:lstStyle/>
-          <a:p>
-            <a:pPr algn="ctr"/>
-          </a:p>
-        </p:txBody>
-      </p:sp>
+      <p:pic>
+        <p:nvPicPr>
+          <p:cNvPr id="9" name="表紙イラスト（公式LINEバナーより）" descr="cover_illust.png"/>
+          <p:cNvPicPr>
+            <a:picLocks noChangeAspect="1"/>
+          </p:cNvPicPr>
+          <p:nvPr/>
+        </p:nvPicPr>
+        <p:blipFill>
+          <a:blip r:embed="rId2"/>
+          <a:stretch>
+            <a:fillRect/>
+          </a:stretch>
+        </p:blipFill>
+        <p:spPr>
+          <a:xfrm>
+            <a:off x="5426497" y="1057110"/>
+            <a:ext cx="6060763" cy="2516758"/>
+          </a:xfrm>
+          <a:prstGeom prst="rect">
+            <a:avLst/>
+          </a:prstGeom>
+        </p:spPr>
+      </p:pic>
     </p:spTree>
   </p:cSld>
   <p:clrMapOvr>
@@ -10123,7 +9897,7 @@
                 <a:ea typeface="游ゴシック"/>
                 <a:cs typeface="游ゴシック"/>
               </a:rPr>
-              <a:t>10 / 19</a:t>
+              <a:t>10 / 18</a:t>
             </a:r>
           </a:p>
         </p:txBody>
@@ -14041,7 +13815,7 @@
                 <a:ea typeface="游ゴシック"/>
                 <a:cs typeface="游ゴシック"/>
               </a:rPr>
-              <a:t>11 / 19</a:t>
+              <a:t>11 / 18</a:t>
             </a:r>
           </a:p>
         </p:txBody>
@@ -15607,54 +15381,7 @@
       </p:sp>
       <p:sp>
         <p:nvSpPr>
-          <p:cNvPr id="16" name="県別"/>
-          <p:cNvSpPr txBox="1"/>
-          <p:nvPr/>
-        </p:nvSpPr>
-        <p:spPr>
-          <a:xfrm>
-            <a:off x="6399038" y="2889434"/>
-            <a:ext cx="5172791" cy="239612"/>
-          </a:xfrm>
-          <a:prstGeom prst="rect">
-            <a:avLst/>
-          </a:prstGeom>
-          <a:noFill/>
-        </p:spPr>
-        <p:txBody>
-          <a:bodyPr wrap="square" lIns="0" rIns="0" tIns="0" bIns="0" anchor="t">
-            <a:noAutofit/>
-          </a:bodyPr>
-          <a:lstStyle/>
-          <a:p>
-            <a:pPr algn="l">
-              <a:lnSpc>
-                <a:spcPts val="1553"/>
-              </a:lnSpc>
-              <a:spcBef>
-                <a:spcPts val="0"/>
-              </a:spcBef>
-              <a:spcAft>
-                <a:spcPts val="0"/>
-              </a:spcAft>
-            </a:pPr>
-            <a:r>
-              <a:rPr sz="1109" b="0">
-                <a:solidFill>
-                  <a:srgbClr val="5B6B73"/>
-                </a:solidFill>
-                <a:latin typeface="游ゴシック"/>
-                <a:ea typeface="游ゴシック"/>
-                <a:cs typeface="游ゴシック"/>
-              </a:rPr>
-              <a:t>長野57・新潟15・埼玉15・群馬12・栃木10</a:t>
-            </a:r>
-          </a:p>
-        </p:txBody>
-      </p:sp>
-      <p:sp>
-        <p:nvSpPr>
-          <p:cNvPr id="17" name="サービス見出し"/>
+          <p:cNvPr id="16" name="サービス見出し"/>
           <p:cNvSpPr txBox="1"/>
           <p:nvPr/>
         </p:nvSpPr>
@@ -15701,7 +15428,7 @@
       </p:sp>
       <p:sp>
         <p:nvSpPr>
-          <p:cNvPr id="18" name="ヘッダー_自宅で暮らし続ける"/>
+          <p:cNvPr id="17" name="ヘッダー_自宅で暮らし続ける"/>
           <p:cNvSpPr/>
           <p:nvPr/>
         </p:nvSpPr>
@@ -15747,7 +15474,7 @@
       </p:sp>
       <p:sp>
         <p:nvSpPr>
-          <p:cNvPr id="19" name="ヘッダー下"/>
+          <p:cNvPr id="18" name="ヘッダー下"/>
           <p:cNvSpPr/>
           <p:nvPr/>
         </p:nvSpPr>
@@ -15791,7 +15518,7 @@
       </p:sp>
       <p:sp>
         <p:nvSpPr>
-          <p:cNvPr id="20" name="見出し_自宅で暮らし続ける"/>
+          <p:cNvPr id="19" name="見出し_自宅で暮らし続ける"/>
           <p:cNvSpPr txBox="1"/>
           <p:nvPr/>
         </p:nvSpPr>
@@ -15862,7 +15589,7 @@
       </p:sp>
       <p:cxnSp>
         <p:nvCxnSpPr>
-          <p:cNvPr id="21" name="区切り"/>
+          <p:cNvPr id="20" name="区切り"/>
           <p:cNvCxnSpPr/>
           <p:nvPr/>
         </p:nvCxnSpPr>
@@ -15898,7 +15625,7 @@
       </p:cxnSp>
       <p:sp>
         <p:nvSpPr>
-          <p:cNvPr id="22" name="ドット"/>
+          <p:cNvPr id="21" name="ドット"/>
           <p:cNvSpPr/>
           <p:nvPr/>
         </p:nvSpPr>
@@ -15942,7 +15669,7 @@
       </p:sp>
       <p:sp>
         <p:nvSpPr>
-          <p:cNvPr id="23" name="サービス_訪問介護"/>
+          <p:cNvPr id="22" name="サービス_訪問介護"/>
           <p:cNvSpPr txBox="1"/>
           <p:nvPr/>
         </p:nvSpPr>
@@ -16013,7 +15740,7 @@
       </p:sp>
       <p:cxnSp>
         <p:nvCxnSpPr>
-          <p:cNvPr id="24" name="区切り"/>
+          <p:cNvPr id="23" name="区切り"/>
           <p:cNvCxnSpPr/>
           <p:nvPr/>
         </p:nvCxnSpPr>
@@ -16049,7 +15776,7 @@
       </p:cxnSp>
       <p:sp>
         <p:nvSpPr>
-          <p:cNvPr id="25" name="ドット"/>
+          <p:cNvPr id="24" name="ドット"/>
           <p:cNvSpPr/>
           <p:nvPr/>
         </p:nvSpPr>
@@ -16093,7 +15820,7 @@
       </p:sp>
       <p:sp>
         <p:nvSpPr>
-          <p:cNvPr id="26" name="サービス_訪問看護"/>
+          <p:cNvPr id="25" name="サービス_訪問看護"/>
           <p:cNvSpPr txBox="1"/>
           <p:nvPr/>
         </p:nvSpPr>
@@ -16164,7 +15891,7 @@
       </p:sp>
       <p:sp>
         <p:nvSpPr>
-          <p:cNvPr id="27" name="ヘッダー_通い・訪問・泊まりで支える"/>
+          <p:cNvPr id="26" name="ヘッダー_通い・訪問・泊まりで支える"/>
           <p:cNvSpPr/>
           <p:nvPr/>
         </p:nvSpPr>
@@ -16210,7 +15937,7 @@
       </p:sp>
       <p:sp>
         <p:nvSpPr>
-          <p:cNvPr id="28" name="ヘッダー下"/>
+          <p:cNvPr id="27" name="ヘッダー下"/>
           <p:cNvSpPr/>
           <p:nvPr/>
         </p:nvSpPr>
@@ -16254,7 +15981,7 @@
       </p:sp>
       <p:sp>
         <p:nvSpPr>
-          <p:cNvPr id="29" name="見出し_通い・訪問・泊まりで支える"/>
+          <p:cNvPr id="28" name="見出し_通い・訪問・泊まりで支える"/>
           <p:cNvSpPr txBox="1"/>
           <p:nvPr/>
         </p:nvSpPr>
@@ -16325,7 +16052,7 @@
       </p:sp>
       <p:cxnSp>
         <p:nvCxnSpPr>
-          <p:cNvPr id="30" name="区切り"/>
+          <p:cNvPr id="29" name="区切り"/>
           <p:cNvCxnSpPr/>
           <p:nvPr/>
         </p:nvCxnSpPr>
@@ -16361,7 +16088,7 @@
       </p:cxnSp>
       <p:sp>
         <p:nvSpPr>
-          <p:cNvPr id="31" name="ドット"/>
+          <p:cNvPr id="30" name="ドット"/>
           <p:cNvSpPr/>
           <p:nvPr/>
         </p:nvSpPr>
@@ -16405,7 +16132,7 @@
       </p:sp>
       <p:sp>
         <p:nvSpPr>
-          <p:cNvPr id="32" name="サービス_デイサービス"/>
+          <p:cNvPr id="31" name="サービス_デイサービス"/>
           <p:cNvSpPr txBox="1"/>
           <p:nvPr/>
         </p:nvSpPr>
@@ -16476,7 +16203,7 @@
       </p:sp>
       <p:cxnSp>
         <p:nvCxnSpPr>
-          <p:cNvPr id="33" name="区切り"/>
+          <p:cNvPr id="32" name="区切り"/>
           <p:cNvCxnSpPr/>
           <p:nvPr/>
         </p:nvCxnSpPr>
@@ -16512,7 +16239,7 @@
       </p:cxnSp>
       <p:sp>
         <p:nvSpPr>
-          <p:cNvPr id="34" name="ドット"/>
+          <p:cNvPr id="33" name="ドット"/>
           <p:cNvSpPr/>
           <p:nvPr/>
         </p:nvSpPr>
@@ -16556,7 +16283,7 @@
       </p:sp>
       <p:sp>
         <p:nvSpPr>
-          <p:cNvPr id="35" name="サービス_小規模多機能型"/>
+          <p:cNvPr id="34" name="サービス_小規模多機能型"/>
           <p:cNvSpPr txBox="1"/>
           <p:nvPr/>
         </p:nvSpPr>
@@ -16627,7 +16354,7 @@
       </p:sp>
       <p:cxnSp>
         <p:nvCxnSpPr>
-          <p:cNvPr id="36" name="区切り"/>
+          <p:cNvPr id="35" name="区切り"/>
           <p:cNvCxnSpPr/>
           <p:nvPr/>
         </p:nvCxnSpPr>
@@ -16663,7 +16390,7 @@
       </p:cxnSp>
       <p:sp>
         <p:nvSpPr>
-          <p:cNvPr id="37" name="ドット"/>
+          <p:cNvPr id="36" name="ドット"/>
           <p:cNvSpPr/>
           <p:nvPr/>
         </p:nvSpPr>
@@ -16707,7 +16434,7 @@
       </p:sp>
       <p:sp>
         <p:nvSpPr>
-          <p:cNvPr id="38" name="サービス_看護小規模多機能型"/>
+          <p:cNvPr id="37" name="サービス_看護小規模多機能型"/>
           <p:cNvSpPr txBox="1"/>
           <p:nvPr/>
         </p:nvSpPr>
@@ -16778,7 +16505,7 @@
       </p:sp>
       <p:sp>
         <p:nvSpPr>
-          <p:cNvPr id="39" name="ヘッダー_住まいで暮らす"/>
+          <p:cNvPr id="38" name="ヘッダー_住まいで暮らす"/>
           <p:cNvSpPr/>
           <p:nvPr/>
         </p:nvSpPr>
@@ -16824,7 +16551,7 @@
       </p:sp>
       <p:sp>
         <p:nvSpPr>
-          <p:cNvPr id="40" name="ヘッダー下"/>
+          <p:cNvPr id="39" name="ヘッダー下"/>
           <p:cNvSpPr/>
           <p:nvPr/>
         </p:nvSpPr>
@@ -16868,7 +16595,7 @@
       </p:sp>
       <p:sp>
         <p:nvSpPr>
-          <p:cNvPr id="41" name="見出し_住まいで暮らす"/>
+          <p:cNvPr id="40" name="見出し_住まいで暮らす"/>
           <p:cNvSpPr txBox="1"/>
           <p:nvPr/>
         </p:nvSpPr>
@@ -16939,7 +16666,7 @@
       </p:sp>
       <p:cxnSp>
         <p:nvCxnSpPr>
-          <p:cNvPr id="42" name="区切り"/>
+          <p:cNvPr id="41" name="区切り"/>
           <p:cNvCxnSpPr/>
           <p:nvPr/>
         </p:nvCxnSpPr>
@@ -16975,7 +16702,7 @@
       </p:cxnSp>
       <p:sp>
         <p:nvSpPr>
-          <p:cNvPr id="43" name="ドット"/>
+          <p:cNvPr id="42" name="ドット"/>
           <p:cNvSpPr/>
           <p:nvPr/>
         </p:nvSpPr>
@@ -17019,7 +16746,7 @@
       </p:sp>
       <p:sp>
         <p:nvSpPr>
-          <p:cNvPr id="44" name="サービス_有料老人ホーム"/>
+          <p:cNvPr id="43" name="サービス_有料老人ホーム"/>
           <p:cNvSpPr txBox="1"/>
           <p:nvPr/>
         </p:nvSpPr>
@@ -17090,7 +16817,7 @@
       </p:sp>
       <p:cxnSp>
         <p:nvCxnSpPr>
-          <p:cNvPr id="45" name="区切り"/>
+          <p:cNvPr id="44" name="区切り"/>
           <p:cNvCxnSpPr/>
           <p:nvPr/>
         </p:nvCxnSpPr>
@@ -17126,7 +16853,7 @@
       </p:cxnSp>
       <p:sp>
         <p:nvSpPr>
-          <p:cNvPr id="46" name="ドット"/>
+          <p:cNvPr id="45" name="ドット"/>
           <p:cNvSpPr/>
           <p:nvPr/>
         </p:nvSpPr>
@@ -17170,7 +16897,7 @@
       </p:sp>
       <p:sp>
         <p:nvSpPr>
-          <p:cNvPr id="47" name="サービス_グループホーム"/>
+          <p:cNvPr id="46" name="サービス_グループホーム"/>
           <p:cNvSpPr txBox="1"/>
           <p:nvPr/>
         </p:nvSpPr>
@@ -17241,7 +16968,7 @@
       </p:sp>
       <p:sp>
         <p:nvSpPr>
-          <p:cNvPr id="48" name="注記"/>
+          <p:cNvPr id="47" name="注記"/>
           <p:cNvSpPr txBox="1"/>
           <p:nvPr/>
         </p:nvSpPr>
@@ -17288,7 +17015,7 @@
       </p:sp>
       <p:sp>
         <p:nvSpPr>
-          <p:cNvPr id="49" name="ページ番号"/>
+          <p:cNvPr id="48" name="ページ番号"/>
           <p:cNvSpPr txBox="1"/>
           <p:nvPr/>
         </p:nvSpPr>
@@ -17328,7 +17055,7 @@
                 <a:ea typeface="游ゴシック"/>
                 <a:cs typeface="游ゴシック"/>
               </a:rPr>
-              <a:t>12 / 19</a:t>
+              <a:t>12 / 18</a:t>
             </a:r>
           </a:p>
         </p:txBody>
@@ -22261,7 +21988,7 @@
                 <a:ea typeface="游ゴシック"/>
                 <a:cs typeface="游ゴシック"/>
               </a:rPr>
-              <a:t>13 / 19</a:t>
+              <a:t>13 / 18</a:t>
             </a:r>
           </a:p>
         </p:txBody>
@@ -24926,7 +24653,7 @@
                 <a:ea typeface="游ゴシック"/>
                 <a:cs typeface="游ゴシック"/>
               </a:rPr>
-              <a:t>14 / 19</a:t>
+              <a:t>14 / 18</a:t>
             </a:r>
           </a:p>
         </p:txBody>
@@ -27881,7 +27608,7 @@
                 <a:ea typeface="游ゴシック"/>
                 <a:cs typeface="游ゴシック"/>
               </a:rPr>
-              <a:t>15 / 19</a:t>
+              <a:t>15 / 18</a:t>
             </a:r>
           </a:p>
         </p:txBody>
@@ -31390,7 +31117,7 @@
                 <a:ea typeface="游ゴシック"/>
                 <a:cs typeface="游ゴシック"/>
               </a:rPr>
-              <a:t>16 / 19</a:t>
+              <a:t>16 / 18</a:t>
             </a:r>
           </a:p>
         </p:txBody>
@@ -33619,7 +33346,7 @@
                 <a:ea typeface="游ゴシック"/>
                 <a:cs typeface="游ゴシック"/>
               </a:rPr>
-              <a:t>17 / 19</a:t>
+              <a:t>17 / 18</a:t>
             </a:r>
           </a:p>
         </p:txBody>
@@ -37094,2865 +36821,7 @@
                 <a:ea typeface="游ゴシック"/>
                 <a:cs typeface="游ゴシック"/>
               </a:rPr>
-              <a:t>18 / 19</a:t>
-            </a:r>
-          </a:p>
-        </p:txBody>
-      </p:sp>
-    </p:spTree>
-  </p:cSld>
-  <p:clrMapOvr>
-    <a:masterClrMapping/>
-  </p:clrMapOvr>
-</p:sld>
-</file>
-
-<file path=ppt/slides/slide19.xml><?xml version="1.0" encoding="utf-8"?>
-<p:sld xmlns:a="http://schemas.openxmlformats.org/drawingml/2006/main" xmlns:p="http://schemas.openxmlformats.org/presentationml/2006/main" xmlns:r="http://schemas.openxmlformats.org/officeDocument/2006/relationships">
-  <p:cSld>
-    <p:spTree>
-      <p:nvGrpSpPr>
-        <p:cNvPr id="1" name=""/>
-        <p:cNvGrpSpPr/>
-        <p:nvPr/>
-      </p:nvGrpSpPr>
-      <p:grpSpPr/>
-      <p:sp>
-        <p:nvSpPr>
-          <p:cNvPr id="2" name="背景"/>
-          <p:cNvSpPr/>
-          <p:nvPr/>
-        </p:nvSpPr>
-        <p:spPr>
-          <a:xfrm>
-            <a:off x="0" y="0"/>
-            <a:ext cx="12192000" cy="6857119"/>
-          </a:xfrm>
-          <a:prstGeom prst="rect">
-            <a:avLst/>
-          </a:prstGeom>
-          <a:solidFill>
-            <a:srgbClr val="FFFFFF"/>
-          </a:solidFill>
-          <a:ln>
-            <a:noFill/>
-          </a:ln>
-          <a:effectLst/>
-        </p:spPr>
-        <p:style>
-          <a:lnRef idx="1">
-            <a:schemeClr val="accent1"/>
-          </a:lnRef>
-          <a:fillRef idx="3">
-            <a:schemeClr val="accent1"/>
-          </a:fillRef>
-          <a:effectRef idx="0">
-            <a:schemeClr val="accent1"/>
-          </a:effectRef>
-          <a:fontRef idx="minor">
-            <a:schemeClr val="lt1"/>
-          </a:fontRef>
-        </p:style>
-        <p:txBody>
-          <a:bodyPr rtlCol="0" anchor="ctr"/>
-          <a:lstStyle/>
-          <a:p>
-            <a:pPr algn="ctr"/>
-          </a:p>
-        </p:txBody>
-      </p:sp>
-      <p:sp>
-        <p:nvSpPr>
-          <p:cNvPr id="3" name="ヘッダー帯"/>
-          <p:cNvSpPr/>
-          <p:nvPr/>
-        </p:nvSpPr>
-        <p:spPr>
-          <a:xfrm>
-            <a:off x="0" y="0"/>
-            <a:ext cx="12192000" cy="1254437"/>
-          </a:xfrm>
-          <a:custGeom>
-            <a:avLst/>
-            <a:gdLst/>
-            <a:ahLst/>
-            <a:cxnLst/>
-            <a:rect l="l" t="t" r="r" b="b"/>
-            <a:pathLst>
-              <a:path w="12192000" h="1254437">
-                <a:moveTo>
-                  <a:pt x="0" y="0"/>
-                </a:moveTo>
-                <a:lnTo>
-                  <a:pt x="12192000" y="0"/>
-                </a:lnTo>
-                <a:lnTo>
-                  <a:pt x="12192000" y="1169868"/>
-                </a:lnTo>
-                <a:lnTo>
-                  <a:pt x="12141200" y="1167654"/>
-                </a:lnTo>
-                <a:lnTo>
-                  <a:pt x="12090400" y="1165442"/>
-                </a:lnTo>
-                <a:lnTo>
-                  <a:pt x="12039600" y="1163233"/>
-                </a:lnTo>
-                <a:lnTo>
-                  <a:pt x="11988800" y="1161028"/>
-                </a:lnTo>
-                <a:lnTo>
-                  <a:pt x="11938000" y="1158830"/>
-                </a:lnTo>
-                <a:lnTo>
-                  <a:pt x="11887200" y="1156639"/>
-                </a:lnTo>
-                <a:lnTo>
-                  <a:pt x="11836400" y="1154457"/>
-                </a:lnTo>
-                <a:lnTo>
-                  <a:pt x="11785600" y="1152285"/>
-                </a:lnTo>
-                <a:lnTo>
-                  <a:pt x="11734800" y="1150126"/>
-                </a:lnTo>
-                <a:lnTo>
-                  <a:pt x="11684000" y="1147980"/>
-                </a:lnTo>
-                <a:lnTo>
-                  <a:pt x="11633200" y="1145849"/>
-                </a:lnTo>
-                <a:lnTo>
-                  <a:pt x="11582400" y="1143735"/>
-                </a:lnTo>
-                <a:lnTo>
-                  <a:pt x="11531600" y="1141639"/>
-                </a:lnTo>
-                <a:lnTo>
-                  <a:pt x="11480800" y="1139561"/>
-                </a:lnTo>
-                <a:lnTo>
-                  <a:pt x="11430000" y="1137505"/>
-                </a:lnTo>
-                <a:lnTo>
-                  <a:pt x="11379200" y="1135471"/>
-                </a:lnTo>
-                <a:lnTo>
-                  <a:pt x="11328400" y="1133460"/>
-                </a:lnTo>
-                <a:lnTo>
-                  <a:pt x="11277600" y="1131475"/>
-                </a:lnTo>
-                <a:lnTo>
-                  <a:pt x="11226800" y="1129515"/>
-                </a:lnTo>
-                <a:lnTo>
-                  <a:pt x="11176000" y="1127584"/>
-                </a:lnTo>
-                <a:lnTo>
-                  <a:pt x="11125200" y="1125681"/>
-                </a:lnTo>
-                <a:lnTo>
-                  <a:pt x="11074400" y="1123809"/>
-                </a:lnTo>
-                <a:lnTo>
-                  <a:pt x="11023600" y="1121968"/>
-                </a:lnTo>
-                <a:lnTo>
-                  <a:pt x="10972800" y="1120160"/>
-                </a:lnTo>
-                <a:lnTo>
-                  <a:pt x="10922000" y="1118386"/>
-                </a:lnTo>
-                <a:lnTo>
-                  <a:pt x="10871200" y="1116647"/>
-                </a:lnTo>
-                <a:lnTo>
-                  <a:pt x="10820400" y="1114945"/>
-                </a:lnTo>
-                <a:lnTo>
-                  <a:pt x="10769600" y="1113281"/>
-                </a:lnTo>
-                <a:lnTo>
-                  <a:pt x="10718800" y="1111655"/>
-                </a:lnTo>
-                <a:lnTo>
-                  <a:pt x="10668000" y="1110069"/>
-                </a:lnTo>
-                <a:lnTo>
-                  <a:pt x="10617200" y="1108524"/>
-                </a:lnTo>
-                <a:lnTo>
-                  <a:pt x="10566400" y="1107021"/>
-                </a:lnTo>
-                <a:lnTo>
-                  <a:pt x="10515600" y="1105562"/>
-                </a:lnTo>
-                <a:lnTo>
-                  <a:pt x="10464800" y="1104146"/>
-                </a:lnTo>
-                <a:lnTo>
-                  <a:pt x="10414000" y="1102775"/>
-                </a:lnTo>
-                <a:lnTo>
-                  <a:pt x="10363200" y="1101451"/>
-                </a:lnTo>
-                <a:lnTo>
-                  <a:pt x="10312400" y="1100173"/>
-                </a:lnTo>
-                <a:lnTo>
-                  <a:pt x="10261600" y="1098943"/>
-                </a:lnTo>
-                <a:lnTo>
-                  <a:pt x="10210800" y="1097761"/>
-                </a:lnTo>
-                <a:lnTo>
-                  <a:pt x="10160000" y="1096629"/>
-                </a:lnTo>
-                <a:lnTo>
-                  <a:pt x="10109200" y="1095548"/>
-                </a:lnTo>
-                <a:lnTo>
-                  <a:pt x="10058400" y="1094517"/>
-                </a:lnTo>
-                <a:lnTo>
-                  <a:pt x="10007600" y="1093538"/>
-                </a:lnTo>
-                <a:lnTo>
-                  <a:pt x="9956800" y="1092611"/>
-                </a:lnTo>
-                <a:lnTo>
-                  <a:pt x="9906000" y="1091737"/>
-                </a:lnTo>
-                <a:lnTo>
-                  <a:pt x="9855200" y="1090916"/>
-                </a:lnTo>
-                <a:lnTo>
-                  <a:pt x="9804400" y="1090150"/>
-                </a:lnTo>
-                <a:lnTo>
-                  <a:pt x="9753600" y="1089439"/>
-                </a:lnTo>
-                <a:lnTo>
-                  <a:pt x="9702800" y="1088782"/>
-                </a:lnTo>
-                <a:lnTo>
-                  <a:pt x="9652000" y="1088181"/>
-                </a:lnTo>
-                <a:lnTo>
-                  <a:pt x="9601200" y="1087636"/>
-                </a:lnTo>
-                <a:lnTo>
-                  <a:pt x="9550400" y="1087147"/>
-                </a:lnTo>
-                <a:lnTo>
-                  <a:pt x="9499600" y="1086716"/>
-                </a:lnTo>
-                <a:lnTo>
-                  <a:pt x="9448800" y="1086341"/>
-                </a:lnTo>
-                <a:lnTo>
-                  <a:pt x="9398000" y="1086023"/>
-                </a:lnTo>
-                <a:lnTo>
-                  <a:pt x="9347200" y="1085763"/>
-                </a:lnTo>
-                <a:lnTo>
-                  <a:pt x="9296400" y="1085560"/>
-                </a:lnTo>
-                <a:lnTo>
-                  <a:pt x="9245600" y="1085415"/>
-                </a:lnTo>
-                <a:lnTo>
-                  <a:pt x="9194800" y="1085328"/>
-                </a:lnTo>
-                <a:lnTo>
-                  <a:pt x="9144000" y="1085299"/>
-                </a:lnTo>
-                <a:lnTo>
-                  <a:pt x="9093200" y="1085328"/>
-                </a:lnTo>
-                <a:lnTo>
-                  <a:pt x="9042400" y="1085415"/>
-                </a:lnTo>
-                <a:lnTo>
-                  <a:pt x="8991600" y="1085560"/>
-                </a:lnTo>
-                <a:lnTo>
-                  <a:pt x="8940800" y="1085763"/>
-                </a:lnTo>
-                <a:lnTo>
-                  <a:pt x="8890000" y="1086023"/>
-                </a:lnTo>
-                <a:lnTo>
-                  <a:pt x="8839200" y="1086341"/>
-                </a:lnTo>
-                <a:lnTo>
-                  <a:pt x="8788400" y="1086716"/>
-                </a:lnTo>
-                <a:lnTo>
-                  <a:pt x="8737600" y="1087147"/>
-                </a:lnTo>
-                <a:lnTo>
-                  <a:pt x="8686800" y="1087636"/>
-                </a:lnTo>
-                <a:lnTo>
-                  <a:pt x="8636000" y="1088181"/>
-                </a:lnTo>
-                <a:lnTo>
-                  <a:pt x="8585200" y="1088782"/>
-                </a:lnTo>
-                <a:lnTo>
-                  <a:pt x="8534400" y="1089439"/>
-                </a:lnTo>
-                <a:lnTo>
-                  <a:pt x="8483600" y="1090150"/>
-                </a:lnTo>
-                <a:lnTo>
-                  <a:pt x="8432800" y="1090916"/>
-                </a:lnTo>
-                <a:lnTo>
-                  <a:pt x="8382000" y="1091737"/>
-                </a:lnTo>
-                <a:lnTo>
-                  <a:pt x="8331200" y="1092611"/>
-                </a:lnTo>
-                <a:lnTo>
-                  <a:pt x="8280400" y="1093538"/>
-                </a:lnTo>
-                <a:lnTo>
-                  <a:pt x="8229600" y="1094517"/>
-                </a:lnTo>
-                <a:lnTo>
-                  <a:pt x="8178800" y="1095548"/>
-                </a:lnTo>
-                <a:lnTo>
-                  <a:pt x="8128000" y="1096629"/>
-                </a:lnTo>
-                <a:lnTo>
-                  <a:pt x="8077200" y="1097761"/>
-                </a:lnTo>
-                <a:lnTo>
-                  <a:pt x="8026400" y="1098943"/>
-                </a:lnTo>
-                <a:lnTo>
-                  <a:pt x="7975600" y="1100173"/>
-                </a:lnTo>
-                <a:lnTo>
-                  <a:pt x="7924800" y="1101451"/>
-                </a:lnTo>
-                <a:lnTo>
-                  <a:pt x="7874000" y="1102775"/>
-                </a:lnTo>
-                <a:lnTo>
-                  <a:pt x="7823200" y="1104146"/>
-                </a:lnTo>
-                <a:lnTo>
-                  <a:pt x="7772400" y="1105562"/>
-                </a:lnTo>
-                <a:lnTo>
-                  <a:pt x="7721600" y="1107021"/>
-                </a:lnTo>
-                <a:lnTo>
-                  <a:pt x="7670800" y="1108524"/>
-                </a:lnTo>
-                <a:lnTo>
-                  <a:pt x="7620000" y="1110069"/>
-                </a:lnTo>
-                <a:lnTo>
-                  <a:pt x="7569200" y="1111655"/>
-                </a:lnTo>
-                <a:lnTo>
-                  <a:pt x="7518400" y="1113281"/>
-                </a:lnTo>
-                <a:lnTo>
-                  <a:pt x="7467600" y="1114945"/>
-                </a:lnTo>
-                <a:lnTo>
-                  <a:pt x="7416800" y="1116647"/>
-                </a:lnTo>
-                <a:lnTo>
-                  <a:pt x="7366000" y="1118386"/>
-                </a:lnTo>
-                <a:lnTo>
-                  <a:pt x="7315200" y="1120160"/>
-                </a:lnTo>
-                <a:lnTo>
-                  <a:pt x="7264400" y="1121968"/>
-                </a:lnTo>
-                <a:lnTo>
-                  <a:pt x="7213600" y="1123809"/>
-                </a:lnTo>
-                <a:lnTo>
-                  <a:pt x="7162800" y="1125681"/>
-                </a:lnTo>
-                <a:lnTo>
-                  <a:pt x="7112000" y="1127584"/>
-                </a:lnTo>
-                <a:lnTo>
-                  <a:pt x="7061200" y="1129515"/>
-                </a:lnTo>
-                <a:lnTo>
-                  <a:pt x="7010400" y="1131475"/>
-                </a:lnTo>
-                <a:lnTo>
-                  <a:pt x="6959600" y="1133460"/>
-                </a:lnTo>
-                <a:lnTo>
-                  <a:pt x="6908800" y="1135471"/>
-                </a:lnTo>
-                <a:lnTo>
-                  <a:pt x="6858000" y="1137505"/>
-                </a:lnTo>
-                <a:lnTo>
-                  <a:pt x="6807200" y="1139561"/>
-                </a:lnTo>
-                <a:lnTo>
-                  <a:pt x="6756400" y="1141639"/>
-                </a:lnTo>
-                <a:lnTo>
-                  <a:pt x="6705600" y="1143735"/>
-                </a:lnTo>
-                <a:lnTo>
-                  <a:pt x="6654800" y="1145849"/>
-                </a:lnTo>
-                <a:lnTo>
-                  <a:pt x="6604000" y="1147980"/>
-                </a:lnTo>
-                <a:lnTo>
-                  <a:pt x="6553200" y="1150126"/>
-                </a:lnTo>
-                <a:lnTo>
-                  <a:pt x="6502400" y="1152285"/>
-                </a:lnTo>
-                <a:lnTo>
-                  <a:pt x="6451600" y="1154457"/>
-                </a:lnTo>
-                <a:lnTo>
-                  <a:pt x="6400800" y="1156639"/>
-                </a:lnTo>
-                <a:lnTo>
-                  <a:pt x="6350000" y="1158830"/>
-                </a:lnTo>
-                <a:lnTo>
-                  <a:pt x="6299200" y="1161028"/>
-                </a:lnTo>
-                <a:lnTo>
-                  <a:pt x="6248400" y="1163233"/>
-                </a:lnTo>
-                <a:lnTo>
-                  <a:pt x="6197600" y="1165442"/>
-                </a:lnTo>
-                <a:lnTo>
-                  <a:pt x="6146800" y="1167654"/>
-                </a:lnTo>
-                <a:lnTo>
-                  <a:pt x="6096000" y="1169868"/>
-                </a:lnTo>
-                <a:lnTo>
-                  <a:pt x="6045200" y="1172082"/>
-                </a:lnTo>
-                <a:lnTo>
-                  <a:pt x="5994400" y="1174294"/>
-                </a:lnTo>
-                <a:lnTo>
-                  <a:pt x="5943600" y="1176503"/>
-                </a:lnTo>
-                <a:lnTo>
-                  <a:pt x="5892800" y="1178708"/>
-                </a:lnTo>
-                <a:lnTo>
-                  <a:pt x="5842000" y="1180907"/>
-                </a:lnTo>
-                <a:lnTo>
-                  <a:pt x="5791200" y="1183098"/>
-                </a:lnTo>
-                <a:lnTo>
-                  <a:pt x="5740400" y="1185280"/>
-                </a:lnTo>
-                <a:lnTo>
-                  <a:pt x="5689600" y="1187451"/>
-                </a:lnTo>
-                <a:lnTo>
-                  <a:pt x="5638800" y="1189610"/>
-                </a:lnTo>
-                <a:lnTo>
-                  <a:pt x="5588000" y="1191756"/>
-                </a:lnTo>
-                <a:lnTo>
-                  <a:pt x="5537200" y="1193887"/>
-                </a:lnTo>
-                <a:lnTo>
-                  <a:pt x="5486400" y="1196001"/>
-                </a:lnTo>
-                <a:lnTo>
-                  <a:pt x="5435600" y="1198098"/>
-                </a:lnTo>
-                <a:lnTo>
-                  <a:pt x="5384800" y="1200175"/>
-                </a:lnTo>
-                <a:lnTo>
-                  <a:pt x="5334000" y="1202231"/>
-                </a:lnTo>
-                <a:lnTo>
-                  <a:pt x="5283200" y="1204265"/>
-                </a:lnTo>
-                <a:lnTo>
-                  <a:pt x="5232400" y="1206276"/>
-                </a:lnTo>
-                <a:lnTo>
-                  <a:pt x="5181600" y="1208262"/>
-                </a:lnTo>
-                <a:lnTo>
-                  <a:pt x="5130800" y="1210221"/>
-                </a:lnTo>
-                <a:lnTo>
-                  <a:pt x="5080000" y="1212153"/>
-                </a:lnTo>
-                <a:lnTo>
-                  <a:pt x="5029200" y="1214055"/>
-                </a:lnTo>
-                <a:lnTo>
-                  <a:pt x="4978400" y="1215928"/>
-                </a:lnTo>
-                <a:lnTo>
-                  <a:pt x="4927600" y="1217768"/>
-                </a:lnTo>
-                <a:lnTo>
-                  <a:pt x="4876800" y="1219576"/>
-                </a:lnTo>
-                <a:lnTo>
-                  <a:pt x="4826000" y="1221350"/>
-                </a:lnTo>
-                <a:lnTo>
-                  <a:pt x="4775200" y="1223089"/>
-                </a:lnTo>
-                <a:lnTo>
-                  <a:pt x="4724400" y="1224791"/>
-                </a:lnTo>
-                <a:lnTo>
-                  <a:pt x="4673600" y="1226456"/>
-                </a:lnTo>
-                <a:lnTo>
-                  <a:pt x="4622800" y="1228082"/>
-                </a:lnTo>
-                <a:lnTo>
-                  <a:pt x="4572000" y="1229667"/>
-                </a:lnTo>
-                <a:lnTo>
-                  <a:pt x="4521200" y="1231212"/>
-                </a:lnTo>
-                <a:lnTo>
-                  <a:pt x="4470400" y="1232715"/>
-                </a:lnTo>
-                <a:lnTo>
-                  <a:pt x="4419600" y="1234175"/>
-                </a:lnTo>
-                <a:lnTo>
-                  <a:pt x="4368800" y="1235590"/>
-                </a:lnTo>
-                <a:lnTo>
-                  <a:pt x="4318000" y="1236961"/>
-                </a:lnTo>
-                <a:lnTo>
-                  <a:pt x="4267200" y="1238286"/>
-                </a:lnTo>
-                <a:lnTo>
-                  <a:pt x="4216400" y="1239564"/>
-                </a:lnTo>
-                <a:lnTo>
-                  <a:pt x="4165600" y="1240794"/>
-                </a:lnTo>
-                <a:lnTo>
-                  <a:pt x="4114800" y="1241975"/>
-                </a:lnTo>
-                <a:lnTo>
-                  <a:pt x="4064000" y="1243107"/>
-                </a:lnTo>
-                <a:lnTo>
-                  <a:pt x="4013200" y="1244189"/>
-                </a:lnTo>
-                <a:lnTo>
-                  <a:pt x="3962400" y="1245220"/>
-                </a:lnTo>
-                <a:lnTo>
-                  <a:pt x="3911600" y="1246199"/>
-                </a:lnTo>
-                <a:lnTo>
-                  <a:pt x="3860800" y="1247126"/>
-                </a:lnTo>
-                <a:lnTo>
-                  <a:pt x="3810000" y="1248000"/>
-                </a:lnTo>
-                <a:lnTo>
-                  <a:pt x="3759200" y="1248820"/>
-                </a:lnTo>
-                <a:lnTo>
-                  <a:pt x="3708400" y="1249586"/>
-                </a:lnTo>
-                <a:lnTo>
-                  <a:pt x="3657600" y="1250298"/>
-                </a:lnTo>
-                <a:lnTo>
-                  <a:pt x="3606800" y="1250954"/>
-                </a:lnTo>
-                <a:lnTo>
-                  <a:pt x="3556000" y="1251555"/>
-                </a:lnTo>
-                <a:lnTo>
-                  <a:pt x="3505200" y="1252100"/>
-                </a:lnTo>
-                <a:lnTo>
-                  <a:pt x="3454400" y="1252589"/>
-                </a:lnTo>
-                <a:lnTo>
-                  <a:pt x="3403600" y="1253021"/>
-                </a:lnTo>
-                <a:lnTo>
-                  <a:pt x="3352800" y="1253396"/>
-                </a:lnTo>
-                <a:lnTo>
-                  <a:pt x="3302000" y="1253713"/>
-                </a:lnTo>
-                <a:lnTo>
-                  <a:pt x="3251200" y="1253974"/>
-                </a:lnTo>
-                <a:lnTo>
-                  <a:pt x="3200400" y="1254176"/>
-                </a:lnTo>
-                <a:lnTo>
-                  <a:pt x="3149600" y="1254321"/>
-                </a:lnTo>
-                <a:lnTo>
-                  <a:pt x="3098800" y="1254408"/>
-                </a:lnTo>
-                <a:lnTo>
-                  <a:pt x="3048000" y="1254437"/>
-                </a:lnTo>
-                <a:lnTo>
-                  <a:pt x="2997200" y="1254408"/>
-                </a:lnTo>
-                <a:lnTo>
-                  <a:pt x="2946400" y="1254321"/>
-                </a:lnTo>
-                <a:lnTo>
-                  <a:pt x="2895600" y="1254176"/>
-                </a:lnTo>
-                <a:lnTo>
-                  <a:pt x="2844800" y="1253974"/>
-                </a:lnTo>
-                <a:lnTo>
-                  <a:pt x="2794000" y="1253713"/>
-                </a:lnTo>
-                <a:lnTo>
-                  <a:pt x="2743200" y="1253396"/>
-                </a:lnTo>
-                <a:lnTo>
-                  <a:pt x="2692400" y="1253021"/>
-                </a:lnTo>
-                <a:lnTo>
-                  <a:pt x="2641600" y="1252589"/>
-                </a:lnTo>
-                <a:lnTo>
-                  <a:pt x="2590800" y="1252100"/>
-                </a:lnTo>
-                <a:lnTo>
-                  <a:pt x="2540000" y="1251555"/>
-                </a:lnTo>
-                <a:lnTo>
-                  <a:pt x="2489200" y="1250954"/>
-                </a:lnTo>
-                <a:lnTo>
-                  <a:pt x="2438400" y="1250298"/>
-                </a:lnTo>
-                <a:lnTo>
-                  <a:pt x="2387600" y="1249586"/>
-                </a:lnTo>
-                <a:lnTo>
-                  <a:pt x="2336800" y="1248820"/>
-                </a:lnTo>
-                <a:lnTo>
-                  <a:pt x="2286000" y="1248000"/>
-                </a:lnTo>
-                <a:lnTo>
-                  <a:pt x="2235200" y="1247126"/>
-                </a:lnTo>
-                <a:lnTo>
-                  <a:pt x="2184400" y="1246199"/>
-                </a:lnTo>
-                <a:lnTo>
-                  <a:pt x="2133600" y="1245220"/>
-                </a:lnTo>
-                <a:lnTo>
-                  <a:pt x="2082800" y="1244189"/>
-                </a:lnTo>
-                <a:lnTo>
-                  <a:pt x="2032000" y="1243107"/>
-                </a:lnTo>
-                <a:lnTo>
-                  <a:pt x="1981200" y="1241975"/>
-                </a:lnTo>
-                <a:lnTo>
-                  <a:pt x="1930400" y="1240794"/>
-                </a:lnTo>
-                <a:lnTo>
-                  <a:pt x="1879600" y="1239564"/>
-                </a:lnTo>
-                <a:lnTo>
-                  <a:pt x="1828800" y="1238286"/>
-                </a:lnTo>
-                <a:lnTo>
-                  <a:pt x="1778000" y="1236961"/>
-                </a:lnTo>
-                <a:lnTo>
-                  <a:pt x="1727200" y="1235590"/>
-                </a:lnTo>
-                <a:lnTo>
-                  <a:pt x="1676400" y="1234175"/>
-                </a:lnTo>
-                <a:lnTo>
-                  <a:pt x="1625600" y="1232715"/>
-                </a:lnTo>
-                <a:lnTo>
-                  <a:pt x="1574800" y="1231212"/>
-                </a:lnTo>
-                <a:lnTo>
-                  <a:pt x="1524000" y="1229667"/>
-                </a:lnTo>
-                <a:lnTo>
-                  <a:pt x="1473200" y="1228082"/>
-                </a:lnTo>
-                <a:lnTo>
-                  <a:pt x="1422400" y="1226456"/>
-                </a:lnTo>
-                <a:lnTo>
-                  <a:pt x="1371600" y="1224791"/>
-                </a:lnTo>
-                <a:lnTo>
-                  <a:pt x="1320800" y="1223089"/>
-                </a:lnTo>
-                <a:lnTo>
-                  <a:pt x="1270000" y="1221350"/>
-                </a:lnTo>
-                <a:lnTo>
-                  <a:pt x="1219200" y="1219576"/>
-                </a:lnTo>
-                <a:lnTo>
-                  <a:pt x="1168400" y="1217768"/>
-                </a:lnTo>
-                <a:lnTo>
-                  <a:pt x="1117600" y="1215928"/>
-                </a:lnTo>
-                <a:lnTo>
-                  <a:pt x="1066800" y="1214055"/>
-                </a:lnTo>
-                <a:lnTo>
-                  <a:pt x="1016000" y="1212153"/>
-                </a:lnTo>
-                <a:lnTo>
-                  <a:pt x="965200" y="1210221"/>
-                </a:lnTo>
-                <a:lnTo>
-                  <a:pt x="914400" y="1208262"/>
-                </a:lnTo>
-                <a:lnTo>
-                  <a:pt x="863600" y="1206276"/>
-                </a:lnTo>
-                <a:lnTo>
-                  <a:pt x="812800" y="1204265"/>
-                </a:lnTo>
-                <a:lnTo>
-                  <a:pt x="762000" y="1202231"/>
-                </a:lnTo>
-                <a:lnTo>
-                  <a:pt x="711200" y="1200175"/>
-                </a:lnTo>
-                <a:lnTo>
-                  <a:pt x="660400" y="1198098"/>
-                </a:lnTo>
-                <a:lnTo>
-                  <a:pt x="609600" y="1196001"/>
-                </a:lnTo>
-                <a:lnTo>
-                  <a:pt x="558800" y="1193887"/>
-                </a:lnTo>
-                <a:lnTo>
-                  <a:pt x="508000" y="1191756"/>
-                </a:lnTo>
-                <a:lnTo>
-                  <a:pt x="457200" y="1189610"/>
-                </a:lnTo>
-                <a:lnTo>
-                  <a:pt x="406400" y="1187451"/>
-                </a:lnTo>
-                <a:lnTo>
-                  <a:pt x="355600" y="1185280"/>
-                </a:lnTo>
-                <a:lnTo>
-                  <a:pt x="304800" y="1183098"/>
-                </a:lnTo>
-                <a:lnTo>
-                  <a:pt x="254000" y="1180907"/>
-                </a:lnTo>
-                <a:lnTo>
-                  <a:pt x="203200" y="1178708"/>
-                </a:lnTo>
-                <a:lnTo>
-                  <a:pt x="152400" y="1176503"/>
-                </a:lnTo>
-                <a:lnTo>
-                  <a:pt x="101600" y="1174294"/>
-                </a:lnTo>
-                <a:lnTo>
-                  <a:pt x="50800" y="1172082"/>
-                </a:lnTo>
-                <a:lnTo>
-                  <a:pt x="0" y="1169868"/>
-                </a:lnTo>
-                <a:close/>
-              </a:path>
-            </a:pathLst>
-          </a:custGeom>
-          <a:solidFill>
-            <a:srgbClr val="74C2B2"/>
-          </a:solidFill>
-          <a:ln>
-            <a:noFill/>
-          </a:ln>
-          <a:effectLst/>
-        </p:spPr>
-        <p:style>
-          <a:lnRef idx="1">
-            <a:schemeClr val="accent1"/>
-          </a:lnRef>
-          <a:fillRef idx="3">
-            <a:schemeClr val="accent1"/>
-          </a:fillRef>
-          <a:effectRef idx="0">
-            <a:schemeClr val="accent1"/>
-          </a:effectRef>
-          <a:fontRef idx="minor">
-            <a:schemeClr val="lt1"/>
-          </a:fontRef>
-        </p:style>
-        <p:txBody>
-          <a:bodyPr rtlCol="0" anchor="ctr"/>
-          <a:lstStyle/>
-          <a:p>
-            <a:pPr algn="ctr"/>
-          </a:p>
-        </p:txBody>
-      </p:sp>
-      <p:sp>
-        <p:nvSpPr>
-          <p:cNvPr id="4" name="ヘッダー山1"/>
-          <p:cNvSpPr/>
-          <p:nvPr/>
-        </p:nvSpPr>
-        <p:spPr>
-          <a:xfrm>
-            <a:off x="8386405" y="436939"/>
-            <a:ext cx="2086030" cy="634266"/>
-          </a:xfrm>
-          <a:custGeom>
-            <a:avLst/>
-            <a:gdLst/>
-            <a:ahLst/>
-            <a:cxnLst/>
-            <a:rect l="l" t="t" r="r" b="b"/>
-            <a:pathLst>
-              <a:path w="2086030" h="634266">
-                <a:moveTo>
-                  <a:pt x="0" y="634266"/>
-                </a:moveTo>
-                <a:lnTo>
-                  <a:pt x="1141678" y="0"/>
-                </a:lnTo>
-                <a:lnTo>
-                  <a:pt x="2086030" y="634266"/>
-                </a:lnTo>
-                <a:close/>
-              </a:path>
-            </a:pathLst>
-          </a:custGeom>
-          <a:solidFill>
-            <a:srgbClr val="8ACFC0"/>
-          </a:solidFill>
-          <a:ln>
-            <a:noFill/>
-          </a:ln>
-          <a:effectLst/>
-        </p:spPr>
-        <p:style>
-          <a:lnRef idx="1">
-            <a:schemeClr val="accent1"/>
-          </a:lnRef>
-          <a:fillRef idx="3">
-            <a:schemeClr val="accent1"/>
-          </a:fillRef>
-          <a:effectRef idx="0">
-            <a:schemeClr val="accent1"/>
-          </a:effectRef>
-          <a:fontRef idx="minor">
-            <a:schemeClr val="lt1"/>
-          </a:fontRef>
-        </p:style>
-        <p:txBody>
-          <a:bodyPr rtlCol="0" anchor="ctr"/>
-          <a:lstStyle/>
-          <a:p>
-            <a:pPr algn="ctr"/>
-          </a:p>
-        </p:txBody>
-      </p:sp>
-      <p:sp>
-        <p:nvSpPr>
-          <p:cNvPr id="5" name="ヘッダー山2"/>
-          <p:cNvSpPr/>
-          <p:nvPr/>
-        </p:nvSpPr>
-        <p:spPr>
-          <a:xfrm>
-            <a:off x="9936832" y="690645"/>
-            <a:ext cx="2043746" cy="380560"/>
-          </a:xfrm>
-          <a:custGeom>
-            <a:avLst/>
-            <a:gdLst/>
-            <a:ahLst/>
-            <a:cxnLst/>
-            <a:rect l="l" t="t" r="r" b="b"/>
-            <a:pathLst>
-              <a:path w="2043746" h="380560">
-                <a:moveTo>
-                  <a:pt x="0" y="380560"/>
-                </a:moveTo>
-                <a:lnTo>
-                  <a:pt x="1028921" y="0"/>
-                </a:lnTo>
-                <a:lnTo>
-                  <a:pt x="2043746" y="380560"/>
-                </a:lnTo>
-                <a:close/>
-              </a:path>
-            </a:pathLst>
-          </a:custGeom>
-          <a:solidFill>
-            <a:srgbClr val="8ACFC0"/>
-          </a:solidFill>
-          <a:ln>
-            <a:noFill/>
-          </a:ln>
-          <a:effectLst/>
-        </p:spPr>
-        <p:style>
-          <a:lnRef idx="1">
-            <a:schemeClr val="accent1"/>
-          </a:lnRef>
-          <a:fillRef idx="3">
-            <a:schemeClr val="accent1"/>
-          </a:fillRef>
-          <a:effectRef idx="0">
-            <a:schemeClr val="accent1"/>
-          </a:effectRef>
-          <a:fontRef idx="minor">
-            <a:schemeClr val="lt1"/>
-          </a:fontRef>
-        </p:style>
-        <p:txBody>
-          <a:bodyPr rtlCol="0" anchor="ctr"/>
-          <a:lstStyle/>
-          <a:p>
-            <a:pPr algn="ctr"/>
-          </a:p>
-        </p:txBody>
-      </p:sp>
-      <p:sp>
-        <p:nvSpPr>
-          <p:cNvPr id="6" name="小見出し"/>
-          <p:cNvSpPr txBox="1"/>
-          <p:nvPr/>
-        </p:nvSpPr>
-        <p:spPr>
-          <a:xfrm>
-            <a:off x="620171" y="225517"/>
-            <a:ext cx="6342659" cy="183232"/>
-          </a:xfrm>
-          <a:prstGeom prst="rect">
-            <a:avLst/>
-          </a:prstGeom>
-          <a:noFill/>
-        </p:spPr>
-        <p:txBody>
-          <a:bodyPr wrap="square" lIns="0" rIns="0" tIns="0" bIns="0" anchor="t">
-            <a:noAutofit/>
-          </a:bodyPr>
-          <a:lstStyle/>
-          <a:p>
-            <a:pPr algn="l">
-              <a:lnSpc>
-                <a:spcPts val="1581"/>
-              </a:lnSpc>
-              <a:spcBef>
-                <a:spcPts val="0"/>
-              </a:spcBef>
-              <a:spcAft>
-                <a:spcPts val="0"/>
-              </a:spcAft>
-            </a:pPr>
-            <a:r>
-              <a:rPr sz="1054" b="1" spc="300">
-                <a:solidFill>
-                  <a:srgbClr val="EAF8F4"/>
-                </a:solidFill>
-                <a:latin typeface="游ゴシック"/>
-                <a:ea typeface="游ゴシック"/>
-                <a:cs typeface="游ゴシック"/>
-              </a:rPr>
-              <a:t>拠点</a:t>
-            </a:r>
-          </a:p>
-        </p:txBody>
-      </p:sp>
-      <p:sp>
-        <p:nvSpPr>
-          <p:cNvPr id="7" name="タイトル"/>
-          <p:cNvSpPr txBox="1"/>
-          <p:nvPr/>
-        </p:nvSpPr>
-        <p:spPr>
-          <a:xfrm>
-            <a:off x="620171" y="422844"/>
-            <a:ext cx="9161618" cy="422844"/>
-          </a:xfrm>
-          <a:prstGeom prst="rect">
-            <a:avLst/>
-          </a:prstGeom>
-          <a:noFill/>
-        </p:spPr>
-        <p:txBody>
-          <a:bodyPr wrap="square" lIns="0" rIns="0" tIns="0" bIns="0" anchor="t">
-            <a:noAutofit/>
-          </a:bodyPr>
-          <a:lstStyle/>
-          <a:p>
-            <a:pPr algn="l">
-              <a:lnSpc>
-                <a:spcPts val="2929"/>
-              </a:lnSpc>
-              <a:spcBef>
-                <a:spcPts val="0"/>
-              </a:spcBef>
-              <a:spcAft>
-                <a:spcPts val="0"/>
-              </a:spcAft>
-            </a:pPr>
-            <a:r>
-              <a:rPr sz="2441" b="1">
-                <a:solidFill>
-                  <a:srgbClr val="FFFFFF"/>
-                </a:solidFill>
-                <a:latin typeface="游ゴシック"/>
-                <a:ea typeface="游ゴシック"/>
-                <a:cs typeface="游ゴシック"/>
-              </a:rPr>
-              <a:t>長野を中心に、信越・北関東に109の拠点</a:t>
-            </a:r>
-          </a:p>
-        </p:txBody>
-      </p:sp>
-      <p:sp>
-        <p:nvSpPr>
-          <p:cNvPr id="8" name="グラフカード"/>
-          <p:cNvSpPr/>
-          <p:nvPr/>
-        </p:nvSpPr>
-        <p:spPr>
-          <a:xfrm>
-            <a:off x="620171" y="1465859"/>
-            <a:ext cx="6342659" cy="4890895"/>
-          </a:xfrm>
-          <a:prstGeom prst="roundRect">
-            <a:avLst>
-              <a:gd name="adj" fmla="val 2881"/>
-            </a:avLst>
-          </a:prstGeom>
-          <a:solidFill>
-            <a:srgbClr val="FFFFFF"/>
-          </a:solidFill>
-          <a:ln w="12700">
-            <a:solidFill>
-              <a:srgbClr val="E1EAE6"/>
-            </a:solidFill>
-          </a:ln>
-          <a:effectLst/>
-        </p:spPr>
-        <p:style>
-          <a:lnRef idx="1">
-            <a:schemeClr val="accent1"/>
-          </a:lnRef>
-          <a:fillRef idx="3">
-            <a:schemeClr val="accent1"/>
-          </a:fillRef>
-          <a:effectRef idx="0">
-            <a:schemeClr val="accent1"/>
-          </a:effectRef>
-          <a:fontRef idx="minor">
-            <a:schemeClr val="lt1"/>
-          </a:fontRef>
-        </p:style>
-        <p:txBody>
-          <a:bodyPr rtlCol="0" anchor="ctr"/>
-          <a:lstStyle/>
-          <a:p>
-            <a:pPr algn="ctr"/>
-          </a:p>
-        </p:txBody>
-      </p:sp>
-      <p:sp>
-        <p:nvSpPr>
-          <p:cNvPr id="9" name="グラフ見出し"/>
-          <p:cNvSpPr txBox="1"/>
-          <p:nvPr/>
-        </p:nvSpPr>
-        <p:spPr>
-          <a:xfrm>
-            <a:off x="902067" y="1677281"/>
-            <a:ext cx="5778867" cy="253706"/>
-          </a:xfrm>
-          <a:prstGeom prst="rect">
-            <a:avLst/>
-          </a:prstGeom>
-          <a:noFill/>
-        </p:spPr>
-        <p:txBody>
-          <a:bodyPr wrap="square" lIns="0" rIns="0" tIns="0" bIns="0" anchor="t">
-            <a:noAutofit/>
-          </a:bodyPr>
-          <a:lstStyle/>
-          <a:p>
-            <a:pPr algn="l">
-              <a:lnSpc>
-                <a:spcPts val="1947"/>
-              </a:lnSpc>
-              <a:spcBef>
-                <a:spcPts val="0"/>
-              </a:spcBef>
-              <a:spcAft>
-                <a:spcPts val="0"/>
-              </a:spcAft>
-            </a:pPr>
-            <a:r>
-              <a:rPr sz="1498" b="1">
-                <a:solidFill>
-                  <a:srgbClr val="26323A"/>
-                </a:solidFill>
-                <a:latin typeface="游ゴシック"/>
-                <a:ea typeface="游ゴシック"/>
-                <a:cs typeface="游ゴシック"/>
-              </a:rPr>
-              <a:t>都県別の拠点数（計109拠点）</a:t>
-            </a:r>
-          </a:p>
-        </p:txBody>
-      </p:sp>
-      <p:graphicFrame>
-        <p:nvGraphicFramePr>
-          <p:cNvPr id="10" name="拠点数グラフ"/>
-          <p:cNvGraphicFramePr>
-            <a:graphicFrameLocks noGrp="1"/>
-          </p:cNvGraphicFramePr>
-          <p:nvPr/>
-        </p:nvGraphicFramePr>
-        <p:xfrm>
-          <a:off x="831593" y="2057840"/>
-          <a:ext cx="5919815" cy="4115681"/>
-        </p:xfrm>
-        <a:graphic>
-          <a:graphicData uri="http://schemas.openxmlformats.org/drawingml/2006/chart">
-            <c:chart xmlns:c="http://schemas.openxmlformats.org/drawingml/2006/chart" r:id="rId3"/>
-          </a:graphicData>
-        </a:graphic>
-      </p:graphicFrame>
-      <p:sp>
-        <p:nvSpPr>
-          <p:cNvPr id="11" name="サービスカード"/>
-          <p:cNvSpPr/>
-          <p:nvPr/>
-        </p:nvSpPr>
-        <p:spPr>
-          <a:xfrm>
-            <a:off x="7188347" y="1465859"/>
-            <a:ext cx="4383482" cy="2114220"/>
-          </a:xfrm>
-          <a:prstGeom prst="roundRect">
-            <a:avLst>
-              <a:gd name="adj" fmla="val 6666"/>
-            </a:avLst>
-          </a:prstGeom>
-          <a:solidFill>
-            <a:srgbClr val="FFFFFF"/>
-          </a:solidFill>
-          <a:ln w="12700">
-            <a:solidFill>
-              <a:srgbClr val="E1EAE6"/>
-            </a:solidFill>
-          </a:ln>
-          <a:effectLst/>
-        </p:spPr>
-        <p:style>
-          <a:lnRef idx="1">
-            <a:schemeClr val="accent1"/>
-          </a:lnRef>
-          <a:fillRef idx="3">
-            <a:schemeClr val="accent1"/>
-          </a:fillRef>
-          <a:effectRef idx="0">
-            <a:schemeClr val="accent1"/>
-          </a:effectRef>
-          <a:fontRef idx="minor">
-            <a:schemeClr val="lt1"/>
-          </a:fontRef>
-        </p:style>
-        <p:txBody>
-          <a:bodyPr rtlCol="0" anchor="ctr"/>
-          <a:lstStyle/>
-          <a:p>
-            <a:pPr algn="ctr"/>
-          </a:p>
-        </p:txBody>
-      </p:sp>
-      <p:sp>
-        <p:nvSpPr>
-          <p:cNvPr id="12" name="サービス見出し"/>
-          <p:cNvSpPr txBox="1"/>
-          <p:nvPr/>
-        </p:nvSpPr>
-        <p:spPr>
-          <a:xfrm>
-            <a:off x="7442053" y="1663186"/>
-            <a:ext cx="3876069" cy="253706"/>
-          </a:xfrm>
-          <a:prstGeom prst="rect">
-            <a:avLst/>
-          </a:prstGeom>
-          <a:noFill/>
-        </p:spPr>
-        <p:txBody>
-          <a:bodyPr wrap="square" lIns="0" rIns="0" tIns="0" bIns="0" anchor="t">
-            <a:noAutofit/>
-          </a:bodyPr>
-          <a:lstStyle/>
-          <a:p>
-            <a:pPr algn="l">
-              <a:lnSpc>
-                <a:spcPts val="1803"/>
-              </a:lnSpc>
-              <a:spcBef>
-                <a:spcPts val="0"/>
-              </a:spcBef>
-              <a:spcAft>
-                <a:spcPts val="0"/>
-              </a:spcAft>
-            </a:pPr>
-            <a:r>
-              <a:rPr sz="1387" b="1">
-                <a:solidFill>
-                  <a:srgbClr val="26323A"/>
-                </a:solidFill>
-                <a:latin typeface="游ゴシック"/>
-                <a:ea typeface="游ゴシック"/>
-                <a:cs typeface="游ゴシック"/>
-              </a:rPr>
-              <a:t>提供しているサービス　7種</a:t>
-            </a:r>
-          </a:p>
-        </p:txBody>
-      </p:sp>
-      <p:sp>
-        <p:nvSpPr>
-          <p:cNvPr id="13" name="サービス_有料老人ホーム"/>
-          <p:cNvSpPr/>
-          <p:nvPr/>
-        </p:nvSpPr>
-        <p:spPr>
-          <a:xfrm>
-            <a:off x="7442053" y="2057840"/>
-            <a:ext cx="1881655" cy="366465"/>
-          </a:xfrm>
-          <a:prstGeom prst="roundRect">
-            <a:avLst>
-              <a:gd name="adj" fmla="val 50000"/>
-            </a:avLst>
-          </a:prstGeom>
-          <a:solidFill>
-            <a:srgbClr val="E3F4F0"/>
-          </a:solidFill>
-          <a:ln>
-            <a:noFill/>
-          </a:ln>
-          <a:effectLst/>
-        </p:spPr>
-        <p:style>
-          <a:lnRef idx="1">
-            <a:schemeClr val="accent1"/>
-          </a:lnRef>
-          <a:fillRef idx="3">
-            <a:schemeClr val="accent1"/>
-          </a:fillRef>
-          <a:effectRef idx="0">
-            <a:schemeClr val="accent1"/>
-          </a:effectRef>
-          <a:fontRef idx="minor">
-            <a:schemeClr val="lt1"/>
-          </a:fontRef>
-        </p:style>
-        <p:txBody>
-          <a:bodyPr rtlCol="0" anchor="ctr"/>
-          <a:lstStyle/>
-          <a:p>
-            <a:pPr algn="ctr"/>
-          </a:p>
-        </p:txBody>
-      </p:sp>
-      <p:sp>
-        <p:nvSpPr>
-          <p:cNvPr id="14" name="サービス文字_有料老人ホーム"/>
-          <p:cNvSpPr txBox="1"/>
-          <p:nvPr/>
-        </p:nvSpPr>
-        <p:spPr>
-          <a:xfrm>
-            <a:off x="7442053" y="2057840"/>
-            <a:ext cx="1881655" cy="366465"/>
-          </a:xfrm>
-          <a:prstGeom prst="rect">
-            <a:avLst/>
-          </a:prstGeom>
-          <a:noFill/>
-        </p:spPr>
-        <p:txBody>
-          <a:bodyPr wrap="square" lIns="0" rIns="0" tIns="0" bIns="0" anchor="ctr">
-            <a:noAutofit/>
-          </a:bodyPr>
-          <a:lstStyle/>
-          <a:p>
-            <a:pPr algn="ctr">
-              <a:lnSpc>
-                <a:spcPts val="1265"/>
-              </a:lnSpc>
-              <a:spcBef>
-                <a:spcPts val="0"/>
-              </a:spcBef>
-              <a:spcAft>
-                <a:spcPts val="0"/>
-              </a:spcAft>
-            </a:pPr>
-            <a:r>
-              <a:rPr sz="1054" b="1">
-                <a:solidFill>
-                  <a:srgbClr val="1F7D6C"/>
-                </a:solidFill>
-                <a:latin typeface="游ゴシック"/>
-                <a:ea typeface="游ゴシック"/>
-                <a:cs typeface="游ゴシック"/>
-              </a:rPr>
-              <a:t>有料老人ホーム</a:t>
-            </a:r>
-          </a:p>
-        </p:txBody>
-      </p:sp>
-      <p:sp>
-        <p:nvSpPr>
-          <p:cNvPr id="15" name="サービス_グループホーム"/>
-          <p:cNvSpPr/>
-          <p:nvPr/>
-        </p:nvSpPr>
-        <p:spPr>
-          <a:xfrm>
-            <a:off x="9436467" y="2057840"/>
-            <a:ext cx="1881655" cy="366465"/>
-          </a:xfrm>
-          <a:prstGeom prst="roundRect">
-            <a:avLst>
-              <a:gd name="adj" fmla="val 50000"/>
-            </a:avLst>
-          </a:prstGeom>
-          <a:solidFill>
-            <a:srgbClr val="E3F4F0"/>
-          </a:solidFill>
-          <a:ln>
-            <a:noFill/>
-          </a:ln>
-          <a:effectLst/>
-        </p:spPr>
-        <p:style>
-          <a:lnRef idx="1">
-            <a:schemeClr val="accent1"/>
-          </a:lnRef>
-          <a:fillRef idx="3">
-            <a:schemeClr val="accent1"/>
-          </a:fillRef>
-          <a:effectRef idx="0">
-            <a:schemeClr val="accent1"/>
-          </a:effectRef>
-          <a:fontRef idx="minor">
-            <a:schemeClr val="lt1"/>
-          </a:fontRef>
-        </p:style>
-        <p:txBody>
-          <a:bodyPr rtlCol="0" anchor="ctr"/>
-          <a:lstStyle/>
-          <a:p>
-            <a:pPr algn="ctr"/>
-          </a:p>
-        </p:txBody>
-      </p:sp>
-      <p:sp>
-        <p:nvSpPr>
-          <p:cNvPr id="16" name="サービス文字_グループホーム"/>
-          <p:cNvSpPr txBox="1"/>
-          <p:nvPr/>
-        </p:nvSpPr>
-        <p:spPr>
-          <a:xfrm>
-            <a:off x="9436467" y="2057840"/>
-            <a:ext cx="1881655" cy="366465"/>
-          </a:xfrm>
-          <a:prstGeom prst="rect">
-            <a:avLst/>
-          </a:prstGeom>
-          <a:noFill/>
-        </p:spPr>
-        <p:txBody>
-          <a:bodyPr wrap="square" lIns="0" rIns="0" tIns="0" bIns="0" anchor="ctr">
-            <a:noAutofit/>
-          </a:bodyPr>
-          <a:lstStyle/>
-          <a:p>
-            <a:pPr algn="ctr">
-              <a:lnSpc>
-                <a:spcPts val="1265"/>
-              </a:lnSpc>
-              <a:spcBef>
-                <a:spcPts val="0"/>
-              </a:spcBef>
-              <a:spcAft>
-                <a:spcPts val="0"/>
-              </a:spcAft>
-            </a:pPr>
-            <a:r>
-              <a:rPr sz="1054" b="1">
-                <a:solidFill>
-                  <a:srgbClr val="1F7D6C"/>
-                </a:solidFill>
-                <a:latin typeface="游ゴシック"/>
-                <a:ea typeface="游ゴシック"/>
-                <a:cs typeface="游ゴシック"/>
-              </a:rPr>
-              <a:t>グループホーム</a:t>
-            </a:r>
-          </a:p>
-        </p:txBody>
-      </p:sp>
-      <p:sp>
-        <p:nvSpPr>
-          <p:cNvPr id="17" name="サービス_デイサービス"/>
-          <p:cNvSpPr/>
-          <p:nvPr/>
-        </p:nvSpPr>
-        <p:spPr>
-          <a:xfrm>
-            <a:off x="7442053" y="2522969"/>
-            <a:ext cx="1881655" cy="366465"/>
-          </a:xfrm>
-          <a:prstGeom prst="roundRect">
-            <a:avLst>
-              <a:gd name="adj" fmla="val 50000"/>
-            </a:avLst>
-          </a:prstGeom>
-          <a:solidFill>
-            <a:srgbClr val="E3F4F0"/>
-          </a:solidFill>
-          <a:ln>
-            <a:noFill/>
-          </a:ln>
-          <a:effectLst/>
-        </p:spPr>
-        <p:style>
-          <a:lnRef idx="1">
-            <a:schemeClr val="accent1"/>
-          </a:lnRef>
-          <a:fillRef idx="3">
-            <a:schemeClr val="accent1"/>
-          </a:fillRef>
-          <a:effectRef idx="0">
-            <a:schemeClr val="accent1"/>
-          </a:effectRef>
-          <a:fontRef idx="minor">
-            <a:schemeClr val="lt1"/>
-          </a:fontRef>
-        </p:style>
-        <p:txBody>
-          <a:bodyPr rtlCol="0" anchor="ctr"/>
-          <a:lstStyle/>
-          <a:p>
-            <a:pPr algn="ctr"/>
-          </a:p>
-        </p:txBody>
-      </p:sp>
-      <p:sp>
-        <p:nvSpPr>
-          <p:cNvPr id="18" name="サービス文字_デイサービス"/>
-          <p:cNvSpPr txBox="1"/>
-          <p:nvPr/>
-        </p:nvSpPr>
-        <p:spPr>
-          <a:xfrm>
-            <a:off x="7442053" y="2522969"/>
-            <a:ext cx="1881655" cy="366465"/>
-          </a:xfrm>
-          <a:prstGeom prst="rect">
-            <a:avLst/>
-          </a:prstGeom>
-          <a:noFill/>
-        </p:spPr>
-        <p:txBody>
-          <a:bodyPr wrap="square" lIns="0" rIns="0" tIns="0" bIns="0" anchor="ctr">
-            <a:noAutofit/>
-          </a:bodyPr>
-          <a:lstStyle/>
-          <a:p>
-            <a:pPr algn="ctr">
-              <a:lnSpc>
-                <a:spcPts val="1265"/>
-              </a:lnSpc>
-              <a:spcBef>
-                <a:spcPts val="0"/>
-              </a:spcBef>
-              <a:spcAft>
-                <a:spcPts val="0"/>
-              </a:spcAft>
-            </a:pPr>
-            <a:r>
-              <a:rPr sz="1054" b="1">
-                <a:solidFill>
-                  <a:srgbClr val="1F7D6C"/>
-                </a:solidFill>
-                <a:latin typeface="游ゴシック"/>
-                <a:ea typeface="游ゴシック"/>
-                <a:cs typeface="游ゴシック"/>
-              </a:rPr>
-              <a:t>デイサービス</a:t>
-            </a:r>
-          </a:p>
-        </p:txBody>
-      </p:sp>
-      <p:sp>
-        <p:nvSpPr>
-          <p:cNvPr id="19" name="サービス_小規模多機能"/>
-          <p:cNvSpPr/>
-          <p:nvPr/>
-        </p:nvSpPr>
-        <p:spPr>
-          <a:xfrm>
-            <a:off x="9436467" y="2522969"/>
-            <a:ext cx="1881655" cy="366465"/>
-          </a:xfrm>
-          <a:prstGeom prst="roundRect">
-            <a:avLst>
-              <a:gd name="adj" fmla="val 50000"/>
-            </a:avLst>
-          </a:prstGeom>
-          <a:solidFill>
-            <a:srgbClr val="E3F4F0"/>
-          </a:solidFill>
-          <a:ln>
-            <a:noFill/>
-          </a:ln>
-          <a:effectLst/>
-        </p:spPr>
-        <p:style>
-          <a:lnRef idx="1">
-            <a:schemeClr val="accent1"/>
-          </a:lnRef>
-          <a:fillRef idx="3">
-            <a:schemeClr val="accent1"/>
-          </a:fillRef>
-          <a:effectRef idx="0">
-            <a:schemeClr val="accent1"/>
-          </a:effectRef>
-          <a:fontRef idx="minor">
-            <a:schemeClr val="lt1"/>
-          </a:fontRef>
-        </p:style>
-        <p:txBody>
-          <a:bodyPr rtlCol="0" anchor="ctr"/>
-          <a:lstStyle/>
-          <a:p>
-            <a:pPr algn="ctr"/>
-          </a:p>
-        </p:txBody>
-      </p:sp>
-      <p:sp>
-        <p:nvSpPr>
-          <p:cNvPr id="20" name="サービス文字_小規模多機能"/>
-          <p:cNvSpPr txBox="1"/>
-          <p:nvPr/>
-        </p:nvSpPr>
-        <p:spPr>
-          <a:xfrm>
-            <a:off x="9436467" y="2522969"/>
-            <a:ext cx="1881655" cy="366465"/>
-          </a:xfrm>
-          <a:prstGeom prst="rect">
-            <a:avLst/>
-          </a:prstGeom>
-          <a:noFill/>
-        </p:spPr>
-        <p:txBody>
-          <a:bodyPr wrap="square" lIns="0" rIns="0" tIns="0" bIns="0" anchor="ctr">
-            <a:noAutofit/>
-          </a:bodyPr>
-          <a:lstStyle/>
-          <a:p>
-            <a:pPr algn="ctr">
-              <a:lnSpc>
-                <a:spcPts val="1265"/>
-              </a:lnSpc>
-              <a:spcBef>
-                <a:spcPts val="0"/>
-              </a:spcBef>
-              <a:spcAft>
-                <a:spcPts val="0"/>
-              </a:spcAft>
-            </a:pPr>
-            <a:r>
-              <a:rPr sz="1054" b="1">
-                <a:solidFill>
-                  <a:srgbClr val="1F7D6C"/>
-                </a:solidFill>
-                <a:latin typeface="游ゴシック"/>
-                <a:ea typeface="游ゴシック"/>
-                <a:cs typeface="游ゴシック"/>
-              </a:rPr>
-              <a:t>小規模多機能</a:t>
-            </a:r>
-          </a:p>
-        </p:txBody>
-      </p:sp>
-      <p:sp>
-        <p:nvSpPr>
-          <p:cNvPr id="21" name="サービス_看護小規模多機能型"/>
-          <p:cNvSpPr/>
-          <p:nvPr/>
-        </p:nvSpPr>
-        <p:spPr>
-          <a:xfrm>
-            <a:off x="7442053" y="2988097"/>
-            <a:ext cx="1881655" cy="366465"/>
-          </a:xfrm>
-          <a:prstGeom prst="roundRect">
-            <a:avLst>
-              <a:gd name="adj" fmla="val 50000"/>
-            </a:avLst>
-          </a:prstGeom>
-          <a:solidFill>
-            <a:srgbClr val="E3F4F0"/>
-          </a:solidFill>
-          <a:ln>
-            <a:noFill/>
-          </a:ln>
-          <a:effectLst/>
-        </p:spPr>
-        <p:style>
-          <a:lnRef idx="1">
-            <a:schemeClr val="accent1"/>
-          </a:lnRef>
-          <a:fillRef idx="3">
-            <a:schemeClr val="accent1"/>
-          </a:fillRef>
-          <a:effectRef idx="0">
-            <a:schemeClr val="accent1"/>
-          </a:effectRef>
-          <a:fontRef idx="minor">
-            <a:schemeClr val="lt1"/>
-          </a:fontRef>
-        </p:style>
-        <p:txBody>
-          <a:bodyPr rtlCol="0" anchor="ctr"/>
-          <a:lstStyle/>
-          <a:p>
-            <a:pPr algn="ctr"/>
-          </a:p>
-        </p:txBody>
-      </p:sp>
-      <p:sp>
-        <p:nvSpPr>
-          <p:cNvPr id="22" name="サービス文字_看護小規模多機能型"/>
-          <p:cNvSpPr txBox="1"/>
-          <p:nvPr/>
-        </p:nvSpPr>
-        <p:spPr>
-          <a:xfrm>
-            <a:off x="7442053" y="2988097"/>
-            <a:ext cx="1881655" cy="366465"/>
-          </a:xfrm>
-          <a:prstGeom prst="rect">
-            <a:avLst/>
-          </a:prstGeom>
-          <a:noFill/>
-        </p:spPr>
-        <p:txBody>
-          <a:bodyPr wrap="square" lIns="0" rIns="0" tIns="0" bIns="0" anchor="ctr">
-            <a:noAutofit/>
-          </a:bodyPr>
-          <a:lstStyle/>
-          <a:p>
-            <a:pPr algn="ctr">
-              <a:lnSpc>
-                <a:spcPts val="1265"/>
-              </a:lnSpc>
-              <a:spcBef>
-                <a:spcPts val="0"/>
-              </a:spcBef>
-              <a:spcAft>
-                <a:spcPts val="0"/>
-              </a:spcAft>
-            </a:pPr>
-            <a:r>
-              <a:rPr sz="1054" b="1">
-                <a:solidFill>
-                  <a:srgbClr val="1F7D6C"/>
-                </a:solidFill>
-                <a:latin typeface="游ゴシック"/>
-                <a:ea typeface="游ゴシック"/>
-                <a:cs typeface="游ゴシック"/>
-              </a:rPr>
-              <a:t>看護小規模多機能型</a:t>
-            </a:r>
-          </a:p>
-        </p:txBody>
-      </p:sp>
-      <p:sp>
-        <p:nvSpPr>
-          <p:cNvPr id="23" name="サービス_訪問介護"/>
-          <p:cNvSpPr/>
-          <p:nvPr/>
-        </p:nvSpPr>
-        <p:spPr>
-          <a:xfrm>
-            <a:off x="9436467" y="2988097"/>
-            <a:ext cx="1881655" cy="366465"/>
-          </a:xfrm>
-          <a:prstGeom prst="roundRect">
-            <a:avLst>
-              <a:gd name="adj" fmla="val 50000"/>
-            </a:avLst>
-          </a:prstGeom>
-          <a:solidFill>
-            <a:srgbClr val="E3F4F0"/>
-          </a:solidFill>
-          <a:ln>
-            <a:noFill/>
-          </a:ln>
-          <a:effectLst/>
-        </p:spPr>
-        <p:style>
-          <a:lnRef idx="1">
-            <a:schemeClr val="accent1"/>
-          </a:lnRef>
-          <a:fillRef idx="3">
-            <a:schemeClr val="accent1"/>
-          </a:fillRef>
-          <a:effectRef idx="0">
-            <a:schemeClr val="accent1"/>
-          </a:effectRef>
-          <a:fontRef idx="minor">
-            <a:schemeClr val="lt1"/>
-          </a:fontRef>
-        </p:style>
-        <p:txBody>
-          <a:bodyPr rtlCol="0" anchor="ctr"/>
-          <a:lstStyle/>
-          <a:p>
-            <a:pPr algn="ctr"/>
-          </a:p>
-        </p:txBody>
-      </p:sp>
-      <p:sp>
-        <p:nvSpPr>
-          <p:cNvPr id="24" name="サービス文字_訪問介護"/>
-          <p:cNvSpPr txBox="1"/>
-          <p:nvPr/>
-        </p:nvSpPr>
-        <p:spPr>
-          <a:xfrm>
-            <a:off x="9436467" y="2988097"/>
-            <a:ext cx="1881655" cy="366465"/>
-          </a:xfrm>
-          <a:prstGeom prst="rect">
-            <a:avLst/>
-          </a:prstGeom>
-          <a:noFill/>
-        </p:spPr>
-        <p:txBody>
-          <a:bodyPr wrap="square" lIns="0" rIns="0" tIns="0" bIns="0" anchor="ctr">
-            <a:noAutofit/>
-          </a:bodyPr>
-          <a:lstStyle/>
-          <a:p>
-            <a:pPr algn="ctr">
-              <a:lnSpc>
-                <a:spcPts val="1265"/>
-              </a:lnSpc>
-              <a:spcBef>
-                <a:spcPts val="0"/>
-              </a:spcBef>
-              <a:spcAft>
-                <a:spcPts val="0"/>
-              </a:spcAft>
-            </a:pPr>
-            <a:r>
-              <a:rPr sz="1054" b="1">
-                <a:solidFill>
-                  <a:srgbClr val="1F7D6C"/>
-                </a:solidFill>
-                <a:latin typeface="游ゴシック"/>
-                <a:ea typeface="游ゴシック"/>
-                <a:cs typeface="游ゴシック"/>
-              </a:rPr>
-              <a:t>訪問介護</a:t>
-            </a:r>
-          </a:p>
-        </p:txBody>
-      </p:sp>
-      <p:sp>
-        <p:nvSpPr>
-          <p:cNvPr id="25" name="サービス_訪問看護"/>
-          <p:cNvSpPr/>
-          <p:nvPr/>
-        </p:nvSpPr>
-        <p:spPr>
-          <a:xfrm>
-            <a:off x="7442053" y="3453225"/>
-            <a:ext cx="1881655" cy="366465"/>
-          </a:xfrm>
-          <a:prstGeom prst="roundRect">
-            <a:avLst>
-              <a:gd name="adj" fmla="val 50000"/>
-            </a:avLst>
-          </a:prstGeom>
-          <a:solidFill>
-            <a:srgbClr val="E3F4F0"/>
-          </a:solidFill>
-          <a:ln>
-            <a:noFill/>
-          </a:ln>
-          <a:effectLst/>
-        </p:spPr>
-        <p:style>
-          <a:lnRef idx="1">
-            <a:schemeClr val="accent1"/>
-          </a:lnRef>
-          <a:fillRef idx="3">
-            <a:schemeClr val="accent1"/>
-          </a:fillRef>
-          <a:effectRef idx="0">
-            <a:schemeClr val="accent1"/>
-          </a:effectRef>
-          <a:fontRef idx="minor">
-            <a:schemeClr val="lt1"/>
-          </a:fontRef>
-        </p:style>
-        <p:txBody>
-          <a:bodyPr rtlCol="0" anchor="ctr"/>
-          <a:lstStyle/>
-          <a:p>
-            <a:pPr algn="ctr"/>
-          </a:p>
-        </p:txBody>
-      </p:sp>
-      <p:sp>
-        <p:nvSpPr>
-          <p:cNvPr id="26" name="サービス文字_訪問看護"/>
-          <p:cNvSpPr txBox="1"/>
-          <p:nvPr/>
-        </p:nvSpPr>
-        <p:spPr>
-          <a:xfrm>
-            <a:off x="7442053" y="3453225"/>
-            <a:ext cx="1881655" cy="366465"/>
-          </a:xfrm>
-          <a:prstGeom prst="rect">
-            <a:avLst/>
-          </a:prstGeom>
-          <a:noFill/>
-        </p:spPr>
-        <p:txBody>
-          <a:bodyPr wrap="square" lIns="0" rIns="0" tIns="0" bIns="0" anchor="ctr">
-            <a:noAutofit/>
-          </a:bodyPr>
-          <a:lstStyle/>
-          <a:p>
-            <a:pPr algn="ctr">
-              <a:lnSpc>
-                <a:spcPts val="1265"/>
-              </a:lnSpc>
-              <a:spcBef>
-                <a:spcPts val="0"/>
-              </a:spcBef>
-              <a:spcAft>
-                <a:spcPts val="0"/>
-              </a:spcAft>
-            </a:pPr>
-            <a:r>
-              <a:rPr sz="1054" b="1">
-                <a:solidFill>
-                  <a:srgbClr val="1F7D6C"/>
-                </a:solidFill>
-                <a:latin typeface="游ゴシック"/>
-                <a:ea typeface="游ゴシック"/>
-                <a:cs typeface="游ゴシック"/>
-              </a:rPr>
-              <a:t>訪問看護</a:t>
-            </a:r>
-          </a:p>
-        </p:txBody>
-      </p:sp>
-      <p:sp>
-        <p:nvSpPr>
-          <p:cNvPr id="27" name="ツアーカード"/>
-          <p:cNvSpPr/>
-          <p:nvPr/>
-        </p:nvSpPr>
-        <p:spPr>
-          <a:xfrm>
-            <a:off x="7188347" y="3805595"/>
-            <a:ext cx="4383482" cy="2551158"/>
-          </a:xfrm>
-          <a:prstGeom prst="roundRect">
-            <a:avLst>
-              <a:gd name="adj" fmla="val 5524"/>
-            </a:avLst>
-          </a:prstGeom>
-          <a:solidFill>
-            <a:srgbClr val="FFFFFF"/>
-          </a:solidFill>
-          <a:ln w="12700">
-            <a:solidFill>
-              <a:srgbClr val="E1EAE6"/>
-            </a:solidFill>
-          </a:ln>
-          <a:effectLst/>
-        </p:spPr>
-        <p:style>
-          <a:lnRef idx="1">
-            <a:schemeClr val="accent1"/>
-          </a:lnRef>
-          <a:fillRef idx="3">
-            <a:schemeClr val="accent1"/>
-          </a:fillRef>
-          <a:effectRef idx="0">
-            <a:schemeClr val="accent1"/>
-          </a:effectRef>
-          <a:fontRef idx="minor">
-            <a:schemeClr val="lt1"/>
-          </a:fontRef>
-        </p:style>
-        <p:txBody>
-          <a:bodyPr rtlCol="0" anchor="ctr"/>
-          <a:lstStyle/>
-          <a:p>
-            <a:pPr algn="ctr"/>
-          </a:p>
-        </p:txBody>
-      </p:sp>
-      <p:sp>
-        <p:nvSpPr>
-          <p:cNvPr id="28" name="ツアー見出し"/>
-          <p:cNvSpPr txBox="1"/>
-          <p:nvPr/>
-        </p:nvSpPr>
-        <p:spPr>
-          <a:xfrm>
-            <a:off x="7442053" y="4002923"/>
-            <a:ext cx="3876069" cy="253706"/>
-          </a:xfrm>
-          <a:prstGeom prst="rect">
-            <a:avLst/>
-          </a:prstGeom>
-          <a:noFill/>
-        </p:spPr>
-        <p:txBody>
-          <a:bodyPr wrap="square" lIns="0" rIns="0" tIns="0" bIns="0" anchor="t">
-            <a:noAutofit/>
-          </a:bodyPr>
-          <a:lstStyle/>
-          <a:p>
-            <a:pPr algn="l">
-              <a:lnSpc>
-                <a:spcPts val="1731"/>
-              </a:lnSpc>
-              <a:spcBef>
-                <a:spcPts val="0"/>
-              </a:spcBef>
-              <a:spcAft>
-                <a:spcPts val="0"/>
-              </a:spcAft>
-            </a:pPr>
-            <a:r>
-              <a:rPr sz="1331" b="1">
-                <a:solidFill>
-                  <a:srgbClr val="26323A"/>
-                </a:solidFill>
-                <a:latin typeface="游ゴシック"/>
-                <a:ea typeface="游ゴシック"/>
-                <a:cs typeface="游ゴシック"/>
-              </a:rPr>
-              <a:t>360°ツアーで見学できる事業所　9拠点</a:t>
-            </a:r>
-          </a:p>
-        </p:txBody>
-      </p:sp>
-      <p:sp>
-        <p:nvSpPr>
-          <p:cNvPr id="29" name="県"/>
-          <p:cNvSpPr/>
-          <p:nvPr/>
-        </p:nvSpPr>
-        <p:spPr>
-          <a:xfrm>
-            <a:off x="7442053" y="4462765"/>
-            <a:ext cx="902067" cy="338275"/>
-          </a:xfrm>
-          <a:prstGeom prst="roundRect">
-            <a:avLst>
-              <a:gd name="adj" fmla="val 50000"/>
-            </a:avLst>
-          </a:prstGeom>
-          <a:solidFill>
-            <a:srgbClr val="FDEBDC"/>
-          </a:solidFill>
-          <a:ln>
-            <a:noFill/>
-          </a:ln>
-          <a:effectLst/>
-        </p:spPr>
-        <p:style>
-          <a:lnRef idx="1">
-            <a:schemeClr val="accent1"/>
-          </a:lnRef>
-          <a:fillRef idx="3">
-            <a:schemeClr val="accent1"/>
-          </a:fillRef>
-          <a:effectRef idx="0">
-            <a:schemeClr val="accent1"/>
-          </a:effectRef>
-          <a:fontRef idx="minor">
-            <a:schemeClr val="lt1"/>
-          </a:fontRef>
-        </p:style>
-        <p:txBody>
-          <a:bodyPr rtlCol="0" anchor="ctr"/>
-          <a:lstStyle/>
-          <a:p>
-            <a:pPr algn="ctr"/>
-          </a:p>
-        </p:txBody>
-      </p:sp>
-      <p:sp>
-        <p:nvSpPr>
-          <p:cNvPr id="30" name="県_長野県"/>
-          <p:cNvSpPr txBox="1"/>
-          <p:nvPr/>
-        </p:nvSpPr>
-        <p:spPr>
-          <a:xfrm>
-            <a:off x="7442053" y="4462765"/>
-            <a:ext cx="902067" cy="338275"/>
-          </a:xfrm>
-          <a:prstGeom prst="rect">
-            <a:avLst/>
-          </a:prstGeom>
-          <a:noFill/>
-        </p:spPr>
-        <p:txBody>
-          <a:bodyPr wrap="square" lIns="0" rIns="0" tIns="0" bIns="0" anchor="ctr">
-            <a:noAutofit/>
-          </a:bodyPr>
-          <a:lstStyle/>
-          <a:p>
-            <a:pPr algn="ctr">
-              <a:lnSpc>
-                <a:spcPts val="1265"/>
-              </a:lnSpc>
-              <a:spcBef>
-                <a:spcPts val="0"/>
-              </a:spcBef>
-              <a:spcAft>
-                <a:spcPts val="0"/>
-              </a:spcAft>
-            </a:pPr>
-            <a:r>
-              <a:rPr sz="1054" b="1">
-                <a:solidFill>
-                  <a:srgbClr val="C8651A"/>
-                </a:solidFill>
-                <a:latin typeface="游ゴシック"/>
-                <a:ea typeface="游ゴシック"/>
-                <a:cs typeface="游ゴシック"/>
-              </a:rPr>
-              <a:t>長野県</a:t>
-            </a:r>
-          </a:p>
-        </p:txBody>
-      </p:sp>
-      <p:sp>
-        <p:nvSpPr>
-          <p:cNvPr id="31" name="拠点数_長野県"/>
-          <p:cNvSpPr txBox="1"/>
-          <p:nvPr/>
-        </p:nvSpPr>
-        <p:spPr>
-          <a:xfrm>
-            <a:off x="8485068" y="4397577"/>
-            <a:ext cx="704740" cy="468652"/>
-          </a:xfrm>
-          <a:prstGeom prst="rect">
-            <a:avLst/>
-          </a:prstGeom>
-          <a:noFill/>
-        </p:spPr>
-        <p:txBody>
-          <a:bodyPr wrap="square" lIns="0" rIns="0" tIns="0" bIns="0" anchor="ctr">
-            <a:noAutofit/>
-          </a:bodyPr>
-          <a:lstStyle/>
-          <a:p>
-            <a:pPr algn="l">
-              <a:lnSpc>
-                <a:spcPts val="1464"/>
-              </a:lnSpc>
-              <a:spcBef>
-                <a:spcPts val="0"/>
-              </a:spcBef>
-              <a:spcAft>
-                <a:spcPts val="0"/>
-              </a:spcAft>
-            </a:pPr>
-            <a:r>
-              <a:rPr sz="1220" b="1">
-                <a:solidFill>
-                  <a:srgbClr val="26323A"/>
-                </a:solidFill>
-                <a:latin typeface="游ゴシック"/>
-                <a:ea typeface="游ゴシック"/>
-                <a:cs typeface="游ゴシック"/>
-              </a:rPr>
-              <a:t>5拠点</a:t>
-            </a:r>
-          </a:p>
-        </p:txBody>
-      </p:sp>
-      <p:sp>
-        <p:nvSpPr>
-          <p:cNvPr id="32" name="所在地_長野県"/>
-          <p:cNvSpPr txBox="1"/>
-          <p:nvPr/>
-        </p:nvSpPr>
-        <p:spPr>
-          <a:xfrm>
-            <a:off x="9232092" y="4397577"/>
-            <a:ext cx="2086030" cy="468652"/>
-          </a:xfrm>
-          <a:prstGeom prst="rect">
-            <a:avLst/>
-          </a:prstGeom>
-          <a:noFill/>
-        </p:spPr>
-        <p:txBody>
-          <a:bodyPr wrap="square" lIns="0" rIns="0" tIns="0" bIns="0" anchor="ctr">
-            <a:noAutofit/>
-          </a:bodyPr>
-          <a:lstStyle/>
-          <a:p>
-            <a:pPr algn="l">
-              <a:lnSpc>
-                <a:spcPts val="1370"/>
-              </a:lnSpc>
-              <a:spcBef>
-                <a:spcPts val="0"/>
-              </a:spcBef>
-              <a:spcAft>
-                <a:spcPts val="0"/>
-              </a:spcAft>
-            </a:pPr>
-            <a:r>
-              <a:rPr sz="1054" b="0">
-                <a:solidFill>
-                  <a:srgbClr val="5B6B73"/>
-                </a:solidFill>
-                <a:latin typeface="游ゴシック"/>
-                <a:ea typeface="游ゴシック"/>
-                <a:cs typeface="游ゴシック"/>
-              </a:rPr>
-              <a:t>安曇野・松本・佐久・諏訪・上田</a:t>
-            </a:r>
-          </a:p>
-        </p:txBody>
-      </p:sp>
-      <p:sp>
-        <p:nvSpPr>
-          <p:cNvPr id="33" name="県"/>
-          <p:cNvSpPr/>
-          <p:nvPr/>
-        </p:nvSpPr>
-        <p:spPr>
-          <a:xfrm>
-            <a:off x="7442053" y="4931417"/>
-            <a:ext cx="902067" cy="338275"/>
-          </a:xfrm>
-          <a:prstGeom prst="roundRect">
-            <a:avLst>
-              <a:gd name="adj" fmla="val 50000"/>
-            </a:avLst>
-          </a:prstGeom>
-          <a:solidFill>
-            <a:srgbClr val="FDEBDC"/>
-          </a:solidFill>
-          <a:ln>
-            <a:noFill/>
-          </a:ln>
-          <a:effectLst/>
-        </p:spPr>
-        <p:style>
-          <a:lnRef idx="1">
-            <a:schemeClr val="accent1"/>
-          </a:lnRef>
-          <a:fillRef idx="3">
-            <a:schemeClr val="accent1"/>
-          </a:fillRef>
-          <a:effectRef idx="0">
-            <a:schemeClr val="accent1"/>
-          </a:effectRef>
-          <a:fontRef idx="minor">
-            <a:schemeClr val="lt1"/>
-          </a:fontRef>
-        </p:style>
-        <p:txBody>
-          <a:bodyPr rtlCol="0" anchor="ctr"/>
-          <a:lstStyle/>
-          <a:p>
-            <a:pPr algn="ctr"/>
-          </a:p>
-        </p:txBody>
-      </p:sp>
-      <p:sp>
-        <p:nvSpPr>
-          <p:cNvPr id="34" name="県_新潟県"/>
-          <p:cNvSpPr txBox="1"/>
-          <p:nvPr/>
-        </p:nvSpPr>
-        <p:spPr>
-          <a:xfrm>
-            <a:off x="7442053" y="4931417"/>
-            <a:ext cx="902067" cy="338275"/>
-          </a:xfrm>
-          <a:prstGeom prst="rect">
-            <a:avLst/>
-          </a:prstGeom>
-          <a:noFill/>
-        </p:spPr>
-        <p:txBody>
-          <a:bodyPr wrap="square" lIns="0" rIns="0" tIns="0" bIns="0" anchor="ctr">
-            <a:noAutofit/>
-          </a:bodyPr>
-          <a:lstStyle/>
-          <a:p>
-            <a:pPr algn="ctr">
-              <a:lnSpc>
-                <a:spcPts val="1265"/>
-              </a:lnSpc>
-              <a:spcBef>
-                <a:spcPts val="0"/>
-              </a:spcBef>
-              <a:spcAft>
-                <a:spcPts val="0"/>
-              </a:spcAft>
-            </a:pPr>
-            <a:r>
-              <a:rPr sz="1054" b="1">
-                <a:solidFill>
-                  <a:srgbClr val="C8651A"/>
-                </a:solidFill>
-                <a:latin typeface="游ゴシック"/>
-                <a:ea typeface="游ゴシック"/>
-                <a:cs typeface="游ゴシック"/>
-              </a:rPr>
-              <a:t>新潟県</a:t>
-            </a:r>
-          </a:p>
-        </p:txBody>
-      </p:sp>
-      <p:sp>
-        <p:nvSpPr>
-          <p:cNvPr id="35" name="拠点数_新潟県"/>
-          <p:cNvSpPr txBox="1"/>
-          <p:nvPr/>
-        </p:nvSpPr>
-        <p:spPr>
-          <a:xfrm>
-            <a:off x="8485068" y="4866229"/>
-            <a:ext cx="704740" cy="468652"/>
-          </a:xfrm>
-          <a:prstGeom prst="rect">
-            <a:avLst/>
-          </a:prstGeom>
-          <a:noFill/>
-        </p:spPr>
-        <p:txBody>
-          <a:bodyPr wrap="square" lIns="0" rIns="0" tIns="0" bIns="0" anchor="ctr">
-            <a:noAutofit/>
-          </a:bodyPr>
-          <a:lstStyle/>
-          <a:p>
-            <a:pPr algn="l">
-              <a:lnSpc>
-                <a:spcPts val="1464"/>
-              </a:lnSpc>
-              <a:spcBef>
-                <a:spcPts val="0"/>
-              </a:spcBef>
-              <a:spcAft>
-                <a:spcPts val="0"/>
-              </a:spcAft>
-            </a:pPr>
-            <a:r>
-              <a:rPr sz="1220" b="1">
-                <a:solidFill>
-                  <a:srgbClr val="26323A"/>
-                </a:solidFill>
-                <a:latin typeface="游ゴシック"/>
-                <a:ea typeface="游ゴシック"/>
-                <a:cs typeface="游ゴシック"/>
-              </a:rPr>
-              <a:t>1拠点</a:t>
-            </a:r>
-          </a:p>
-        </p:txBody>
-      </p:sp>
-      <p:sp>
-        <p:nvSpPr>
-          <p:cNvPr id="36" name="所在地_新潟県"/>
-          <p:cNvSpPr txBox="1"/>
-          <p:nvPr/>
-        </p:nvSpPr>
-        <p:spPr>
-          <a:xfrm>
-            <a:off x="9232092" y="4866229"/>
-            <a:ext cx="2086030" cy="468652"/>
-          </a:xfrm>
-          <a:prstGeom prst="rect">
-            <a:avLst/>
-          </a:prstGeom>
-          <a:noFill/>
-        </p:spPr>
-        <p:txBody>
-          <a:bodyPr wrap="square" lIns="0" rIns="0" tIns="0" bIns="0" anchor="ctr">
-            <a:noAutofit/>
-          </a:bodyPr>
-          <a:lstStyle/>
-          <a:p>
-            <a:pPr algn="l">
-              <a:lnSpc>
-                <a:spcPts val="1370"/>
-              </a:lnSpc>
-              <a:spcBef>
-                <a:spcPts val="0"/>
-              </a:spcBef>
-              <a:spcAft>
-                <a:spcPts val="0"/>
-              </a:spcAft>
-            </a:pPr>
-            <a:r>
-              <a:rPr sz="1054" b="0">
-                <a:solidFill>
-                  <a:srgbClr val="5B6B73"/>
-                </a:solidFill>
-                <a:latin typeface="游ゴシック"/>
-                <a:ea typeface="游ゴシック"/>
-                <a:cs typeface="游ゴシック"/>
-              </a:rPr>
-              <a:t>糸魚川</a:t>
-            </a:r>
-          </a:p>
-        </p:txBody>
-      </p:sp>
-      <p:sp>
-        <p:nvSpPr>
-          <p:cNvPr id="37" name="県"/>
-          <p:cNvSpPr/>
-          <p:nvPr/>
-        </p:nvSpPr>
-        <p:spPr>
-          <a:xfrm>
-            <a:off x="7442053" y="5400069"/>
-            <a:ext cx="902067" cy="338275"/>
-          </a:xfrm>
-          <a:prstGeom prst="roundRect">
-            <a:avLst>
-              <a:gd name="adj" fmla="val 50000"/>
-            </a:avLst>
-          </a:prstGeom>
-          <a:solidFill>
-            <a:srgbClr val="FDEBDC"/>
-          </a:solidFill>
-          <a:ln>
-            <a:noFill/>
-          </a:ln>
-          <a:effectLst/>
-        </p:spPr>
-        <p:style>
-          <a:lnRef idx="1">
-            <a:schemeClr val="accent1"/>
-          </a:lnRef>
-          <a:fillRef idx="3">
-            <a:schemeClr val="accent1"/>
-          </a:fillRef>
-          <a:effectRef idx="0">
-            <a:schemeClr val="accent1"/>
-          </a:effectRef>
-          <a:fontRef idx="minor">
-            <a:schemeClr val="lt1"/>
-          </a:fontRef>
-        </p:style>
-        <p:txBody>
-          <a:bodyPr rtlCol="0" anchor="ctr"/>
-          <a:lstStyle/>
-          <a:p>
-            <a:pPr algn="ctr"/>
-          </a:p>
-        </p:txBody>
-      </p:sp>
-      <p:sp>
-        <p:nvSpPr>
-          <p:cNvPr id="38" name="県_栃木県"/>
-          <p:cNvSpPr txBox="1"/>
-          <p:nvPr/>
-        </p:nvSpPr>
-        <p:spPr>
-          <a:xfrm>
-            <a:off x="7442053" y="5400069"/>
-            <a:ext cx="902067" cy="338275"/>
-          </a:xfrm>
-          <a:prstGeom prst="rect">
-            <a:avLst/>
-          </a:prstGeom>
-          <a:noFill/>
-        </p:spPr>
-        <p:txBody>
-          <a:bodyPr wrap="square" lIns="0" rIns="0" tIns="0" bIns="0" anchor="ctr">
-            <a:noAutofit/>
-          </a:bodyPr>
-          <a:lstStyle/>
-          <a:p>
-            <a:pPr algn="ctr">
-              <a:lnSpc>
-                <a:spcPts val="1265"/>
-              </a:lnSpc>
-              <a:spcBef>
-                <a:spcPts val="0"/>
-              </a:spcBef>
-              <a:spcAft>
-                <a:spcPts val="0"/>
-              </a:spcAft>
-            </a:pPr>
-            <a:r>
-              <a:rPr sz="1054" b="1">
-                <a:solidFill>
-                  <a:srgbClr val="C8651A"/>
-                </a:solidFill>
-                <a:latin typeface="游ゴシック"/>
-                <a:ea typeface="游ゴシック"/>
-                <a:cs typeface="游ゴシック"/>
-              </a:rPr>
-              <a:t>栃木県</a:t>
-            </a:r>
-          </a:p>
-        </p:txBody>
-      </p:sp>
-      <p:sp>
-        <p:nvSpPr>
-          <p:cNvPr id="39" name="拠点数_栃木県"/>
-          <p:cNvSpPr txBox="1"/>
-          <p:nvPr/>
-        </p:nvSpPr>
-        <p:spPr>
-          <a:xfrm>
-            <a:off x="8485068" y="5334881"/>
-            <a:ext cx="704740" cy="468652"/>
-          </a:xfrm>
-          <a:prstGeom prst="rect">
-            <a:avLst/>
-          </a:prstGeom>
-          <a:noFill/>
-        </p:spPr>
-        <p:txBody>
-          <a:bodyPr wrap="square" lIns="0" rIns="0" tIns="0" bIns="0" anchor="ctr">
-            <a:noAutofit/>
-          </a:bodyPr>
-          <a:lstStyle/>
-          <a:p>
-            <a:pPr algn="l">
-              <a:lnSpc>
-                <a:spcPts val="1464"/>
-              </a:lnSpc>
-              <a:spcBef>
-                <a:spcPts val="0"/>
-              </a:spcBef>
-              <a:spcAft>
-                <a:spcPts val="0"/>
-              </a:spcAft>
-            </a:pPr>
-            <a:r>
-              <a:rPr sz="1220" b="1">
-                <a:solidFill>
-                  <a:srgbClr val="26323A"/>
-                </a:solidFill>
-                <a:latin typeface="游ゴシック"/>
-                <a:ea typeface="游ゴシック"/>
-                <a:cs typeface="游ゴシック"/>
-              </a:rPr>
-              <a:t>2拠点</a:t>
-            </a:r>
-          </a:p>
-        </p:txBody>
-      </p:sp>
-      <p:sp>
-        <p:nvSpPr>
-          <p:cNvPr id="40" name="所在地_栃木県"/>
-          <p:cNvSpPr txBox="1"/>
-          <p:nvPr/>
-        </p:nvSpPr>
-        <p:spPr>
-          <a:xfrm>
-            <a:off x="9232092" y="5334881"/>
-            <a:ext cx="2086030" cy="468652"/>
-          </a:xfrm>
-          <a:prstGeom prst="rect">
-            <a:avLst/>
-          </a:prstGeom>
-          <a:noFill/>
-        </p:spPr>
-        <p:txBody>
-          <a:bodyPr wrap="square" lIns="0" rIns="0" tIns="0" bIns="0" anchor="ctr">
-            <a:noAutofit/>
-          </a:bodyPr>
-          <a:lstStyle/>
-          <a:p>
-            <a:pPr algn="l">
-              <a:lnSpc>
-                <a:spcPts val="1370"/>
-              </a:lnSpc>
-              <a:spcBef>
-                <a:spcPts val="0"/>
-              </a:spcBef>
-              <a:spcAft>
-                <a:spcPts val="0"/>
-              </a:spcAft>
-            </a:pPr>
-            <a:r>
-              <a:rPr sz="1054" b="0">
-                <a:solidFill>
-                  <a:srgbClr val="5B6B73"/>
-                </a:solidFill>
-                <a:latin typeface="游ゴシック"/>
-                <a:ea typeface="游ゴシック"/>
-                <a:cs typeface="游ゴシック"/>
-              </a:rPr>
-              <a:t>宇都宮・小山</a:t>
-            </a:r>
-          </a:p>
-        </p:txBody>
-      </p:sp>
-      <p:sp>
-        <p:nvSpPr>
-          <p:cNvPr id="41" name="県"/>
-          <p:cNvSpPr/>
-          <p:nvPr/>
-        </p:nvSpPr>
-        <p:spPr>
-          <a:xfrm>
-            <a:off x="7442053" y="5868721"/>
-            <a:ext cx="902067" cy="338275"/>
-          </a:xfrm>
-          <a:prstGeom prst="roundRect">
-            <a:avLst>
-              <a:gd name="adj" fmla="val 50000"/>
-            </a:avLst>
-          </a:prstGeom>
-          <a:solidFill>
-            <a:srgbClr val="FDEBDC"/>
-          </a:solidFill>
-          <a:ln>
-            <a:noFill/>
-          </a:ln>
-          <a:effectLst/>
-        </p:spPr>
-        <p:style>
-          <a:lnRef idx="1">
-            <a:schemeClr val="accent1"/>
-          </a:lnRef>
-          <a:fillRef idx="3">
-            <a:schemeClr val="accent1"/>
-          </a:fillRef>
-          <a:effectRef idx="0">
-            <a:schemeClr val="accent1"/>
-          </a:effectRef>
-          <a:fontRef idx="minor">
-            <a:schemeClr val="lt1"/>
-          </a:fontRef>
-        </p:style>
-        <p:txBody>
-          <a:bodyPr rtlCol="0" anchor="ctr"/>
-          <a:lstStyle/>
-          <a:p>
-            <a:pPr algn="ctr"/>
-          </a:p>
-        </p:txBody>
-      </p:sp>
-      <p:sp>
-        <p:nvSpPr>
-          <p:cNvPr id="42" name="県_埼玉県"/>
-          <p:cNvSpPr txBox="1"/>
-          <p:nvPr/>
-        </p:nvSpPr>
-        <p:spPr>
-          <a:xfrm>
-            <a:off x="7442053" y="5868721"/>
-            <a:ext cx="902067" cy="338275"/>
-          </a:xfrm>
-          <a:prstGeom prst="rect">
-            <a:avLst/>
-          </a:prstGeom>
-          <a:noFill/>
-        </p:spPr>
-        <p:txBody>
-          <a:bodyPr wrap="square" lIns="0" rIns="0" tIns="0" bIns="0" anchor="ctr">
-            <a:noAutofit/>
-          </a:bodyPr>
-          <a:lstStyle/>
-          <a:p>
-            <a:pPr algn="ctr">
-              <a:lnSpc>
-                <a:spcPts val="1265"/>
-              </a:lnSpc>
-              <a:spcBef>
-                <a:spcPts val="0"/>
-              </a:spcBef>
-              <a:spcAft>
-                <a:spcPts val="0"/>
-              </a:spcAft>
-            </a:pPr>
-            <a:r>
-              <a:rPr sz="1054" b="1">
-                <a:solidFill>
-                  <a:srgbClr val="C8651A"/>
-                </a:solidFill>
-                <a:latin typeface="游ゴシック"/>
-                <a:ea typeface="游ゴシック"/>
-                <a:cs typeface="游ゴシック"/>
-              </a:rPr>
-              <a:t>埼玉県</a:t>
-            </a:r>
-          </a:p>
-        </p:txBody>
-      </p:sp>
-      <p:sp>
-        <p:nvSpPr>
-          <p:cNvPr id="43" name="拠点数_埼玉県"/>
-          <p:cNvSpPr txBox="1"/>
-          <p:nvPr/>
-        </p:nvSpPr>
-        <p:spPr>
-          <a:xfrm>
-            <a:off x="8485068" y="5803533"/>
-            <a:ext cx="704740" cy="468652"/>
-          </a:xfrm>
-          <a:prstGeom prst="rect">
-            <a:avLst/>
-          </a:prstGeom>
-          <a:noFill/>
-        </p:spPr>
-        <p:txBody>
-          <a:bodyPr wrap="square" lIns="0" rIns="0" tIns="0" bIns="0" anchor="ctr">
-            <a:noAutofit/>
-          </a:bodyPr>
-          <a:lstStyle/>
-          <a:p>
-            <a:pPr algn="l">
-              <a:lnSpc>
-                <a:spcPts val="1464"/>
-              </a:lnSpc>
-              <a:spcBef>
-                <a:spcPts val="0"/>
-              </a:spcBef>
-              <a:spcAft>
-                <a:spcPts val="0"/>
-              </a:spcAft>
-            </a:pPr>
-            <a:r>
-              <a:rPr sz="1220" b="1">
-                <a:solidFill>
-                  <a:srgbClr val="26323A"/>
-                </a:solidFill>
-                <a:latin typeface="游ゴシック"/>
-                <a:ea typeface="游ゴシック"/>
-                <a:cs typeface="游ゴシック"/>
-              </a:rPr>
-              <a:t>1拠点</a:t>
-            </a:r>
-          </a:p>
-        </p:txBody>
-      </p:sp>
-      <p:sp>
-        <p:nvSpPr>
-          <p:cNvPr id="44" name="所在地_埼玉県"/>
-          <p:cNvSpPr txBox="1"/>
-          <p:nvPr/>
-        </p:nvSpPr>
-        <p:spPr>
-          <a:xfrm>
-            <a:off x="9232092" y="5803533"/>
-            <a:ext cx="2086030" cy="468652"/>
-          </a:xfrm>
-          <a:prstGeom prst="rect">
-            <a:avLst/>
-          </a:prstGeom>
-          <a:noFill/>
-        </p:spPr>
-        <p:txBody>
-          <a:bodyPr wrap="square" lIns="0" rIns="0" tIns="0" bIns="0" anchor="ctr">
-            <a:noAutofit/>
-          </a:bodyPr>
-          <a:lstStyle/>
-          <a:p>
-            <a:pPr algn="l">
-              <a:lnSpc>
-                <a:spcPts val="1370"/>
-              </a:lnSpc>
-              <a:spcBef>
-                <a:spcPts val="0"/>
-              </a:spcBef>
-              <a:spcAft>
-                <a:spcPts val="0"/>
-              </a:spcAft>
-            </a:pPr>
-            <a:r>
-              <a:rPr sz="1054" b="0">
-                <a:solidFill>
-                  <a:srgbClr val="5B6B73"/>
-                </a:solidFill>
-                <a:latin typeface="游ゴシック"/>
-                <a:ea typeface="游ゴシック"/>
-                <a:cs typeface="游ゴシック"/>
-              </a:rPr>
-              <a:t>羽生</a:t>
-            </a:r>
-          </a:p>
-        </p:txBody>
-      </p:sp>
-      <p:sp>
-        <p:nvSpPr>
-          <p:cNvPr id="45" name="注記"/>
-          <p:cNvSpPr txBox="1"/>
-          <p:nvPr/>
-        </p:nvSpPr>
-        <p:spPr>
-          <a:xfrm>
-            <a:off x="620171" y="6539986"/>
-            <a:ext cx="9161618" cy="155043"/>
-          </a:xfrm>
-          <a:prstGeom prst="rect">
-            <a:avLst/>
-          </a:prstGeom>
-          <a:noFill/>
-        </p:spPr>
-        <p:txBody>
-          <a:bodyPr wrap="square" lIns="0" rIns="0" tIns="0" bIns="0" anchor="t">
-            <a:noAutofit/>
-          </a:bodyPr>
-          <a:lstStyle/>
-          <a:p>
-            <a:pPr algn="l">
-              <a:lnSpc>
-                <a:spcPts val="1082"/>
-              </a:lnSpc>
-              <a:spcBef>
-                <a:spcPts val="0"/>
-              </a:spcBef>
-              <a:spcAft>
-                <a:spcPts val="0"/>
-              </a:spcAft>
-            </a:pPr>
-            <a:r>
-              <a:rPr sz="832" b="0">
-                <a:solidFill>
-                  <a:srgbClr val="8A9A96"/>
-                </a:solidFill>
-                <a:latin typeface="游ゴシック"/>
-                <a:ea typeface="游ゴシック"/>
-                <a:cs typeface="游ゴシック"/>
-              </a:rPr>
-              <a:t>※ 出典：エフビー介護サービス コーポレートサイト（360°ツアー）ほか、実習サイトの掲載内容。</a:t>
-            </a:r>
-          </a:p>
-        </p:txBody>
-      </p:sp>
-      <p:sp>
-        <p:nvSpPr>
-          <p:cNvPr id="46" name="ページ番号"/>
-          <p:cNvSpPr txBox="1"/>
-          <p:nvPr/>
-        </p:nvSpPr>
-        <p:spPr>
-          <a:xfrm>
-            <a:off x="10726141" y="6525891"/>
-            <a:ext cx="845688" cy="155043"/>
-          </a:xfrm>
-          <a:prstGeom prst="rect">
-            <a:avLst/>
-          </a:prstGeom>
-          <a:noFill/>
-        </p:spPr>
-        <p:txBody>
-          <a:bodyPr wrap="square" lIns="0" rIns="0" tIns="0" bIns="0" anchor="t">
-            <a:noAutofit/>
-          </a:bodyPr>
-          <a:lstStyle/>
-          <a:p>
-            <a:pPr algn="r">
-              <a:lnSpc>
-                <a:spcPts val="1082"/>
-              </a:lnSpc>
-              <a:spcBef>
-                <a:spcPts val="0"/>
-              </a:spcBef>
-              <a:spcAft>
-                <a:spcPts val="0"/>
-              </a:spcAft>
-            </a:pPr>
-            <a:r>
-              <a:rPr sz="832" b="0">
-                <a:solidFill>
-                  <a:srgbClr val="8A9A96"/>
-                </a:solidFill>
-                <a:latin typeface="游ゴシック"/>
-                <a:ea typeface="游ゴシック"/>
-                <a:cs typeface="游ゴシック"/>
-              </a:rPr>
-              <a:t>19 / 19</a:t>
+              <a:t>18 / 18</a:t>
             </a:r>
           </a:p>
         </p:txBody>
@@ -40501,7 +37370,7 @@
                 <a:ea typeface="游ゴシック"/>
                 <a:cs typeface="游ゴシック"/>
               </a:rPr>
-              <a:t>2 / 19</a:t>
+              <a:t>2 / 18</a:t>
             </a:r>
           </a:p>
         </p:txBody>
@@ -42462,7 +39331,7 @@
                 <a:ea typeface="游ゴシック"/>
                 <a:cs typeface="游ゴシック"/>
               </a:rPr>
-              <a:t>3 / 19</a:t>
+              <a:t>3 / 18</a:t>
             </a:r>
           </a:p>
         </p:txBody>
@@ -46539,7 +43408,7 @@
                 <a:ea typeface="游ゴシック"/>
                 <a:cs typeface="游ゴシック"/>
               </a:rPr>
-              <a:t>4 / 19</a:t>
+              <a:t>4 / 18</a:t>
             </a:r>
           </a:p>
         </p:txBody>
@@ -49405,7 +46274,7 @@
                 <a:ea typeface="游ゴシック"/>
                 <a:cs typeface="游ゴシック"/>
               </a:rPr>
-              <a:t>5 / 19</a:t>
+              <a:t>5 / 18</a:t>
             </a:r>
           </a:p>
         </p:txBody>
@@ -50936,7 +47805,7 @@
                 <a:ea typeface="游ゴシック"/>
                 <a:cs typeface="游ゴシック"/>
               </a:rPr>
-              <a:t>出典：総務省統計局／社人研 令和5年推計・出生中位（〜2070年）／国連 World Population Prospects（2075年〜、推計方法が異なる参考値）</a:t>
+              <a:t>出典：総務省統計局／社人研 令和5年推計・出生中位（〜2070年）／国連 World Population Prospects（2075年〜は5年ごとの値を直線で結んだ参考値）</a:t>
             </a:r>
           </a:p>
         </p:txBody>
@@ -50983,7 +47852,7 @@
                 <a:ea typeface="游ゴシック"/>
                 <a:cs typeface="游ゴシック"/>
               </a:rPr>
-              <a:t>6 / 19</a:t>
+              <a:t>6 / 18</a:t>
             </a:r>
           </a:p>
         </p:txBody>
@@ -52601,7 +49470,7 @@
                 <a:ea typeface="游ゴシック"/>
                 <a:cs typeface="游ゴシック"/>
               </a:rPr>
-              <a:t>7 / 19</a:t>
+              <a:t>7 / 18</a:t>
             </a:r>
           </a:p>
         </p:txBody>
@@ -54552,7 +51421,7 @@
                 <a:ea typeface="游ゴシック"/>
                 <a:cs typeface="游ゴシック"/>
               </a:rPr>
-              <a:t>8 / 19</a:t>
+              <a:t>8 / 18</a:t>
             </a:r>
           </a:p>
         </p:txBody>
@@ -57085,7 +53954,7 @@
                 <a:ea typeface="游ゴシック"/>
                 <a:cs typeface="游ゴシック"/>
               </a:rPr>
-              <a:t>9 / 19</a:t>
+              <a:t>9 / 18</a:t>
             </a:r>
           </a:p>
         </p:txBody>

</xml_diff>

<commit_message>
Vision statement: build workforce together, regional happiness, hope amid population decline
Co-Authored-By: Claude Sonnet 5.5 <noreply@anthropic.com>
Claude-Session: https://claude.ai/code/session_01MxdMxhi7qZAPC9aBAhtpWC
</commit_message>
<xml_diff>
--- a/kyoiku-jisshu/共育実習_図解.pptx
+++ b/kyoiku-jisshu/共育実習_図解.pptx
@@ -37121,8 +37121,8 @@
         </p:nvSpPr>
         <p:spPr>
           <a:xfrm>
-            <a:off x="845688" y="2959908"/>
-            <a:ext cx="10430150" cy="3523699"/>
+            <a:off x="845688" y="2889434"/>
+            <a:ext cx="10571098" cy="3523699"/>
           </a:xfrm>
           <a:prstGeom prst="rect">
             <a:avLst/>
@@ -37137,7 +37137,7 @@
           <a:p>
             <a:pPr algn="l">
               <a:lnSpc>
-                <a:spcPts val="2816"/>
+                <a:spcPts val="2621"/>
               </a:lnSpc>
               <a:spcBef>
                 <a:spcPts val="0"/>
@@ -37147,7 +37147,7 @@
               </a:spcAft>
             </a:pPr>
             <a:r>
-              <a:rPr sz="1609" b="0">
+              <a:rPr sz="1498" b="0">
                 <a:solidFill>
                   <a:srgbClr val="F0FBF8"/>
                 </a:solidFill>
@@ -37161,17 +37161,17 @@
           <a:p>
             <a:pPr algn="l">
               <a:lnSpc>
-                <a:spcPts val="2816"/>
+                <a:spcPts val="2621"/>
               </a:lnSpc>
               <a:spcBef>
                 <a:spcPts val="0"/>
               </a:spcBef>
               <a:spcAft>
-                <a:spcPts val="1220"/>
+                <a:spcPts val="1109"/>
               </a:spcAft>
             </a:pPr>
             <a:r>
-              <a:rPr sz="1609" b="0">
+              <a:rPr sz="1498" b="0">
                 <a:solidFill>
                   <a:srgbClr val="F0FBF8"/>
                 </a:solidFill>
@@ -37185,7 +37185,7 @@
           <a:p>
             <a:pPr algn="l">
               <a:lnSpc>
-                <a:spcPts val="2816"/>
+                <a:spcPts val="2621"/>
               </a:lnSpc>
               <a:spcBef>
                 <a:spcPts val="0"/>
@@ -37195,7 +37195,7 @@
               </a:spcAft>
             </a:pPr>
             <a:r>
-              <a:rPr sz="1609" b="0">
+              <a:rPr sz="1498" b="0">
                 <a:solidFill>
                   <a:srgbClr val="F0FBF8"/>
                 </a:solidFill>
@@ -37203,13 +37203,13 @@
                 <a:ea typeface="游ゴシック"/>
                 <a:cs typeface="游ゴシック"/>
               </a:rPr>
-              <a:t>エフビー介護サービスの共育実習は、「教える・教わる」だけの実習ではありません。</a:t>
+              <a:t>共育実習は、「教える・教わる」だけの実習ではありません。</a:t>
             </a:r>
           </a:p>
           <a:p>
             <a:pPr algn="l">
               <a:lnSpc>
-                <a:spcPts val="2816"/>
+                <a:spcPts val="2621"/>
               </a:lnSpc>
               <a:spcBef>
                 <a:spcPts val="0"/>
@@ -37219,7 +37219,7 @@
               </a:spcAft>
             </a:pPr>
             <a:r>
-              <a:rPr sz="1609" b="0">
+              <a:rPr sz="1498" b="0">
                 <a:solidFill>
                   <a:srgbClr val="F0FBF8"/>
                 </a:solidFill>
@@ -37227,23 +37227,23 @@
                 <a:ea typeface="游ゴシック"/>
                 <a:cs typeface="游ゴシック"/>
               </a:rPr>
-              <a:t>学生さんも、先生も、利用者さんも、社員も、みんなが「主役」になれる場所をつくっています。</a:t>
+              <a:t>学生さんも、先生も、利用者さんも、社員も、地域の人も。みんなで福祉の人材を育てていく取り組みです。</a:t>
             </a:r>
           </a:p>
           <a:p>
             <a:pPr algn="l">
               <a:lnSpc>
-                <a:spcPts val="2816"/>
+                <a:spcPts val="2621"/>
               </a:lnSpc>
               <a:spcBef>
                 <a:spcPts val="0"/>
               </a:spcBef>
               <a:spcAft>
-                <a:spcPts val="110"/>
+                <a:spcPts val="1109"/>
               </a:spcAft>
             </a:pPr>
             <a:r>
-              <a:rPr sz="1609" b="0">
+              <a:rPr sz="1498" b="0">
                 <a:solidFill>
                   <a:srgbClr val="F0FBF8"/>
                 </a:solidFill>
@@ -37257,17 +37257,17 @@
           <a:p>
             <a:pPr algn="l">
               <a:lnSpc>
-                <a:spcPts val="2816"/>
+                <a:spcPts val="2621"/>
               </a:lnSpc>
               <a:spcBef>
                 <a:spcPts val="0"/>
               </a:spcBef>
               <a:spcAft>
-                <a:spcPts val="1220"/>
+                <a:spcPts val="110"/>
               </a:spcAft>
             </a:pPr>
             <a:r>
-              <a:rPr sz="1609" b="0">
+              <a:rPr sz="1498" b="0">
                 <a:solidFill>
                   <a:srgbClr val="F0FBF8"/>
                 </a:solidFill>
@@ -37275,23 +37275,23 @@
                 <a:ea typeface="游ゴシック"/>
                 <a:cs typeface="游ゴシック"/>
               </a:rPr>
-              <a:t>そこに「迎える人」と「学ぶ人」の区別はなく、みんなが「ありがとう」を言い合います。</a:t>
+              <a:t>人が育てば、地域の幸福度が高まる。</a:t>
             </a:r>
           </a:p>
           <a:p>
             <a:pPr algn="l">
               <a:lnSpc>
-                <a:spcPts val="2816"/>
+                <a:spcPts val="2621"/>
               </a:lnSpc>
               <a:spcBef>
                 <a:spcPts val="0"/>
               </a:spcBef>
               <a:spcAft>
-                <a:spcPts val="110"/>
+                <a:spcPts val="1109"/>
               </a:spcAft>
             </a:pPr>
             <a:r>
-              <a:rPr sz="1609" b="0">
+              <a:rPr sz="1498" b="0">
                 <a:solidFill>
                   <a:srgbClr val="F0FBF8"/>
                 </a:solidFill>
@@ -37299,13 +37299,13 @@
                 <a:ea typeface="游ゴシック"/>
                 <a:cs typeface="游ゴシック"/>
               </a:rPr>
-              <a:t>そこで生まれた声は、次の学生へ、そして地域へ。共に育つ輪が、長野から広がっていきます。</a:t>
+              <a:t>これから人口が減っていく長野で、支え合う人が育つことが、地域の希望になる。</a:t>
             </a:r>
           </a:p>
           <a:p>
             <a:pPr algn="l">
               <a:lnSpc>
-                <a:spcPts val="2816"/>
+                <a:spcPts val="2621"/>
               </a:lnSpc>
               <a:spcBef>
                 <a:spcPts val="0"/>
@@ -37315,7 +37315,7 @@
               </a:spcAft>
             </a:pPr>
             <a:r>
-              <a:rPr sz="1609" b="1">
+              <a:rPr sz="1498" b="1">
                 <a:solidFill>
                   <a:srgbClr val="FFFFFF"/>
                 </a:solidFill>

</xml_diff>

<commit_message>
Agenda slide with separated illustration elements replaces brand story slide
Co-Authored-By: Claude Sonnet 5.5 <noreply@anthropic.com>
Claude-Session: https://claude.ai/code/session_01MxdMxhi7qZAPC9aBAhtpWC
</commit_message>
<xml_diff>
--- a/kyoiku-jisshu/共育実習_図解.pptx
+++ b/kyoiku-jisshu/共育実習_図解.pptx
@@ -8,8 +8,8 @@
     <p:sldId id="256" r:id="rId7"/>
     <p:sldId id="257" r:id="rId8"/>
     <p:sldId id="258" r:id="rId9"/>
-    <p:sldId id="259" r:id="rId11"/>
-    <p:sldId id="260" r:id="rId12"/>
+    <p:sldId id="259" r:id="rId10"/>
+    <p:sldId id="260" r:id="rId11"/>
     <p:sldId id="261" r:id="rId13"/>
     <p:sldId id="262" r:id="rId14"/>
     <p:sldId id="263" r:id="rId15"/>
@@ -2960,7 +2960,7 @@
           <a:lstStyle/>
           <a:p>
             <a:r>
-              <a:t>採用コンセプト FUN LIFE! FUN LOCAL! をもとにした、ブランドストーリーの叩き台。</a:t>
+              <a:t>人口：1947〜2022年は実績（総務省統計局・人口統計資料集）、2023〜2070年は推計（社人研・令和5年推計 出生中位）、2075〜2100年は国連推計（5年ごと）。</a:t>
             </a:r>
           </a:p>
         </p:txBody>
@@ -3030,76 +3030,6 @@
           <a:lstStyle/>
           <a:p>
             <a:r>
-              <a:t>実習サイト「エフビー流の学び」。</a:t>
-            </a:r>
-          </a:p>
-        </p:txBody>
-      </p:sp>
-      <p:sp>
-        <p:nvSpPr>
-          <p:cNvPr id="4" name="Slide Number Placeholder 3"/>
-          <p:cNvSpPr>
-            <a:spLocks noGrp="1"/>
-          </p:cNvSpPr>
-          <p:nvPr>
-            <p:ph type="sldNum" idx="5" sz="quarter"/>
-          </p:nvPr>
-        </p:nvSpPr>
-        <p:spPr/>
-      </p:sp>
-    </p:spTree>
-  </p:cSld>
-  <p:clrMapOvr>
-    <a:masterClrMapping/>
-  </p:clrMapOvr>
-</p:notes>
-</file>
-
-<file path=ppt/notesSlides/notesSlide11.xml><?xml version="1.0" encoding="utf-8"?>
-<p:notes xmlns:a="http://schemas.openxmlformats.org/drawingml/2006/main" xmlns:p="http://schemas.openxmlformats.org/presentationml/2006/main" xmlns:r="http://schemas.openxmlformats.org/officeDocument/2006/relationships">
-  <p:cSld>
-    <p:spTree>
-      <p:nvGrpSpPr>
-        <p:cNvPr id="1" name=""/>
-        <p:cNvGrpSpPr/>
-        <p:nvPr/>
-      </p:nvGrpSpPr>
-      <p:grpSpPr>
-        <a:xfrm>
-          <a:off x="0" y="0"/>
-          <a:ext cx="0" cy="0"/>
-          <a:chOff x="0" y="0"/>
-          <a:chExt cx="0" cy="0"/>
-        </a:xfrm>
-      </p:grpSpPr>
-      <p:sp>
-        <p:nvSpPr>
-          <p:cNvPr id="2" name="Slide Image Placeholder 1"/>
-          <p:cNvSpPr>
-            <a:spLocks noGrp="1"/>
-          </p:cNvSpPr>
-          <p:nvPr>
-            <p:ph type="sldImg" idx="2"/>
-          </p:nvPr>
-        </p:nvSpPr>
-        <p:spPr/>
-      </p:sp>
-      <p:sp>
-        <p:nvSpPr>
-          <p:cNvPr id="3" name="Notes Placeholder 2"/>
-          <p:cNvSpPr>
-            <a:spLocks noGrp="1"/>
-          </p:cNvSpPr>
-          <p:nvPr>
-            <p:ph type="body" idx="3" sz="quarter"/>
-          </p:nvPr>
-        </p:nvSpPr>
-        <p:spPr/>
-        <p:txBody>
-          <a:bodyPr/>
-          <a:lstStyle/>
-          <a:p>
-            <a:r>
               <a:t>申込から振り返りまでの流れと、サイトのコンテンツ。</a:t>
             </a:r>
           </a:p>
@@ -3170,7 +3100,7 @@
           <a:lstStyle/>
           <a:p>
             <a:r>
-              <a:t>人口：1947〜2022年は実績（総務省統計局・人口統計資料集）、2023〜2070年は推計（社人研・令和5年推計 出生中位）、2075〜2100年は国連推計（5年ごと）。</a:t>
+              <a:t>介護費：社会保障費用統計 第8表「介護対策」（2000〜2020年度）、2025・2040年度は厚生労働省「2040年を見据えた社会保障の将来見通し」計画ベース。</a:t>
             </a:r>
           </a:p>
         </p:txBody>
@@ -3240,7 +3170,7 @@
           <a:lstStyle/>
           <a:p>
             <a:r>
-              <a:t>介護費：社会保障費用統計 第8表「介護対策」（2000〜2020年度）、2025・2040年度は厚生労働省「2040年を見据えた社会保障の将来見通し」計画ベース。</a:t>
+              <a:t>長野大学×エフビー 産学連携プロジェクト資料（社会状況・やりがい）をもとに整理。</a:t>
             </a:r>
           </a:p>
         </p:txBody>
@@ -3310,7 +3240,7 @@
           <a:lstStyle/>
           <a:p>
             <a:r>
-              <a:t>長野大学×エフビー 産学連携プロジェクト資料（社会状況・やりがい）をもとに整理。</a:t>
+              <a:t>出典：企業説明会資料・経営者ヒアリング。</a:t>
             </a:r>
           </a:p>
         </p:txBody>
@@ -3380,7 +3310,7 @@
           <a:lstStyle/>
           <a:p>
             <a:r>
-              <a:t>出典：企業説明会資料・経営者ヒアリング。</a:t>
+              <a:t>visions college（エフビー介護サービス回）Chapter02「感情労働の未来」をもとに整理。</a:t>
             </a:r>
           </a:p>
         </p:txBody>
@@ -3450,7 +3380,7 @@
           <a:lstStyle/>
           <a:p>
             <a:r>
-              <a:t>visions college（エフビー介護サービス回）Chapter02「感情労働の未来」をもとに整理。</a:t>
+              <a:t>沿革。西暦は5年ごとの目盛り。</a:t>
             </a:r>
           </a:p>
         </p:txBody>
@@ -3520,7 +3450,7 @@
           <a:lstStyle/>
           <a:p>
             <a:r>
-              <a:t>沿革。西暦は5年ごとの目盛り。</a:t>
+              <a:t>小規模・多拠点・サービスの見せ方。</a:t>
             </a:r>
           </a:p>
         </p:txBody>
@@ -3590,7 +3520,7 @@
           <a:lstStyle/>
           <a:p>
             <a:r>
-              <a:t>小規模・多拠点・サービスの見せ方。</a:t>
+              <a:t>売上推移（26期〜36期）。出典：企業説明会資料。</a:t>
             </a:r>
           </a:p>
         </p:txBody>
@@ -3660,7 +3590,7 @@
           <a:lstStyle/>
           <a:p>
             <a:r>
-              <a:t>売上推移（26期〜36期）。出典：企業説明会資料。</a:t>
+              <a:t>実習サイト「エフビー流の学び」。</a:t>
             </a:r>
           </a:p>
         </p:txBody>
@@ -38317,7 +38247,7 @@
                 <a:ea typeface="游ゴシック"/>
                 <a:cs typeface="游ゴシック"/>
               </a:rPr>
-              <a:t>ブランドストーリー</a:t>
+              <a:t>アジェンダ</a:t>
             </a:r>
           </a:p>
         </p:txBody>
@@ -38364,7 +38294,7 @@
                 <a:ea typeface="游ゴシック"/>
                 <a:cs typeface="游ゴシック"/>
               </a:rPr>
-              <a:t>介護のイメージを、一緒にひっくり返したい</a:t>
+              <a:t>このあと、お伝えすること</a:t>
             </a:r>
           </a:p>
         </p:txBody>
@@ -38541,8 +38471,8 @@
         </p:nvSpPr>
         <p:spPr>
           <a:xfrm>
-            <a:off x="1014825" y="5299644"/>
-            <a:ext cx="4143871" cy="704740"/>
+            <a:off x="1014825" y="4284818"/>
+            <a:ext cx="4143871" cy="422844"/>
           </a:xfrm>
           <a:prstGeom prst="rect">
             <a:avLst/>
@@ -38580,58 +38510,70 @@
           </a:p>
         </p:txBody>
       </p:sp>
-      <p:cxnSp>
-        <p:nvCxnSpPr>
-          <p:cNvPr id="12" name="縦線"/>
-          <p:cNvCxnSpPr/>
-          <p:nvPr/>
-        </p:nvCxnSpPr>
-        <p:spPr>
-          <a:xfrm>
-            <a:off x="6377896" y="1818229"/>
-            <a:ext cx="0" cy="3100855"/>
-          </a:xfrm>
-          <a:prstGeom prst="line">
-            <a:avLst/>
-          </a:prstGeom>
-          <a:ln w="38100">
-            <a:solidFill>
-              <a:srgbClr val="E1EAE6"/>
-            </a:solidFill>
-          </a:ln>
-          <a:effectLst/>
-        </p:spPr>
-        <p:style>
-          <a:lnRef idx="2">
-            <a:schemeClr val="accent1"/>
-          </a:lnRef>
-          <a:fillRef idx="0">
-            <a:schemeClr val="accent1"/>
-          </a:fillRef>
-          <a:effectRef idx="0">
-            <a:schemeClr val="accent1"/>
-          </a:effectRef>
-          <a:fontRef idx="minor">
-            <a:schemeClr val="tx1"/>
-          </a:fontRef>
-        </p:style>
-      </p:cxnSp>
-      <p:sp>
-        <p:nvSpPr>
-          <p:cNvPr id="13" name="点"/>
+      <p:pic>
+        <p:nvPicPr>
+          <p:cNvPr id="12" name="イラスト_picnic" descr="picnic.png"/>
+          <p:cNvPicPr>
+            <a:picLocks noChangeAspect="1"/>
+          </p:cNvPicPr>
+          <p:nvPr/>
+        </p:nvPicPr>
+        <p:blipFill>
+          <a:blip r:embed="rId2"/>
+          <a:stretch>
+            <a:fillRect/>
+          </a:stretch>
+        </p:blipFill>
+        <p:spPr>
+          <a:xfrm>
+            <a:off x="1043015" y="5017748"/>
+            <a:ext cx="1409480" cy="947589"/>
+          </a:xfrm>
+          <a:prstGeom prst="rect">
+            <a:avLst/>
+          </a:prstGeom>
+        </p:spPr>
+      </p:pic>
+      <p:pic>
+        <p:nvPicPr>
+          <p:cNvPr id="13" name="イラスト_runners" descr="runners.png"/>
+          <p:cNvPicPr>
+            <a:picLocks noChangeAspect="1"/>
+          </p:cNvPicPr>
+          <p:nvPr/>
+        </p:nvPicPr>
+        <p:blipFill>
+          <a:blip r:embed="rId3"/>
+          <a:stretch>
+            <a:fillRect/>
+          </a:stretch>
+        </p:blipFill>
+        <p:spPr>
+          <a:xfrm>
+            <a:off x="3509605" y="5158696"/>
+            <a:ext cx="1204428" cy="880925"/>
+          </a:xfrm>
+          <a:prstGeom prst="rect">
+            <a:avLst/>
+          </a:prstGeom>
+        </p:spPr>
+      </p:pic>
+      <p:sp>
+        <p:nvSpPr>
+          <p:cNvPr id="14" name="番号点"/>
           <p:cNvSpPr/>
           <p:nvPr/>
         </p:nvSpPr>
         <p:spPr>
           <a:xfrm>
-            <a:off x="6187616" y="1627949"/>
-            <a:ext cx="380560" cy="380560"/>
+            <a:off x="6060763" y="1757621"/>
+            <a:ext cx="394654" cy="394654"/>
           </a:xfrm>
           <a:prstGeom prst="ellipse">
             <a:avLst/>
           </a:prstGeom>
           <a:solidFill>
-            <a:srgbClr val="8A9A96"/>
+            <a:srgbClr val="3FB39D"/>
           </a:solidFill>
           <a:ln>
             <a:noFill/>
@@ -38662,14 +38604,14 @@
       </p:sp>
       <p:sp>
         <p:nvSpPr>
-          <p:cNvPr id="14" name="番号"/>
+          <p:cNvPr id="15" name="番号1"/>
           <p:cNvSpPr txBox="1"/>
           <p:nvPr/>
         </p:nvSpPr>
         <p:spPr>
           <a:xfrm>
-            <a:off x="6187616" y="1620902"/>
-            <a:ext cx="380560" cy="394654"/>
+            <a:off x="6046668" y="1757621"/>
+            <a:ext cx="422844" cy="394654"/>
           </a:xfrm>
           <a:prstGeom prst="rect">
             <a:avLst/>
@@ -38709,14 +38651,14 @@
       </p:sp>
       <p:sp>
         <p:nvSpPr>
-          <p:cNvPr id="15" name="ストーリー_きっかけ"/>
+          <p:cNvPr id="16" name="項目_共育実習が目指すこと"/>
           <p:cNvSpPr txBox="1"/>
           <p:nvPr/>
         </p:nvSpPr>
         <p:spPr>
           <a:xfrm>
-            <a:off x="6821882" y="1536333"/>
-            <a:ext cx="4749947" cy="1409480"/>
+            <a:off x="6666839" y="1564523"/>
+            <a:ext cx="3425036" cy="780852"/>
           </a:xfrm>
           <a:prstGeom prst="rect">
             <a:avLst/>
@@ -38724,24 +38666,48 @@
           <a:noFill/>
         </p:spPr>
         <p:txBody>
-          <a:bodyPr wrap="square" lIns="0" rIns="0" tIns="0" bIns="0" anchor="t">
+          <a:bodyPr wrap="square" lIns="0" rIns="0" tIns="0" bIns="0" anchor="ctr">
             <a:noAutofit/>
           </a:bodyPr>
           <a:lstStyle/>
           <a:p>
             <a:pPr algn="l">
               <a:lnSpc>
-                <a:spcPts val="1587"/>
+                <a:spcPts val="2236"/>
               </a:lnSpc>
               <a:spcBef>
                 <a:spcPts val="0"/>
               </a:spcBef>
               <a:spcAft>
-                <a:spcPts val="0"/>
+                <a:spcPts val="110"/>
               </a:spcAft>
             </a:pPr>
             <a:r>
-              <a:rPr sz="1220" b="1" spc="200">
+              <a:rPr sz="1720" b="1">
+                <a:solidFill>
+                  <a:srgbClr val="26323A"/>
+                </a:solidFill>
+                <a:latin typeface="游ゴシック"/>
+                <a:ea typeface="游ゴシック"/>
+                <a:cs typeface="游ゴシック"/>
+              </a:rPr>
+              <a:t>共育実習が目指すこと</a:t>
+            </a:r>
+          </a:p>
+          <a:p>
+            <a:pPr algn="l">
+              <a:lnSpc>
+                <a:spcPts val="1609"/>
+              </a:lnSpc>
+              <a:spcBef>
+                <a:spcPts val="0"/>
+              </a:spcBef>
+              <a:spcAft>
+                <a:spcPts val="0"/>
+              </a:spcAft>
+            </a:pPr>
+            <a:r>
+              <a:rPr sz="1109" b="0">
                 <a:solidFill>
                   <a:srgbClr val="5B6B73"/>
                 </a:solidFill>
@@ -38749,69 +38715,105 @@
                 <a:ea typeface="游ゴシック"/>
                 <a:cs typeface="游ゴシック"/>
               </a:rPr>
-              <a:t>きっかけ</a:t>
+              <a:t>ビジョンと、みんなで育つ共創モデル</a:t>
             </a:r>
           </a:p>
           <a:p>
             <a:pPr algn="l">
               <a:lnSpc>
-                <a:spcPts val="2547"/>
+                <a:spcPts val="1298"/>
               </a:lnSpc>
               <a:spcBef>
                 <a:spcPts val="0"/>
               </a:spcBef>
               <a:spcAft>
-                <a:spcPts val="332"/>
+                <a:spcPts val="0"/>
               </a:spcAft>
             </a:pPr>
             <a:r>
-              <a:rPr sz="1886" b="1">
+              <a:rPr sz="998" b="1">
                 <a:solidFill>
-                  <a:srgbClr val="26323A"/>
+                  <a:srgbClr val="1F7D6C"/>
                 </a:solidFill>
                 <a:latin typeface="游ゴシック"/>
                 <a:ea typeface="游ゴシック"/>
                 <a:cs typeface="游ゴシック"/>
               </a:rPr>
-              <a:t>介護や老後の話は、なんだか暗い。</a:t>
+              <a:t>P.2–4</a:t>
             </a:r>
           </a:p>
-          <a:p>
-            <a:pPr algn="l">
-              <a:lnSpc>
-                <a:spcPts val="2042"/>
-              </a:lnSpc>
-              <a:spcBef>
-                <a:spcPts val="0"/>
-              </a:spcBef>
-              <a:spcAft>
-                <a:spcPts val="0"/>
-              </a:spcAft>
-            </a:pPr>
-            <a:r>
-              <a:rPr sz="1276" b="0">
-                <a:solidFill>
-                  <a:srgbClr val="5B6B73"/>
-                </a:solidFill>
-                <a:latin typeface="游ゴシック"/>
-                <a:ea typeface="游ゴシック"/>
-                <a:cs typeface="游ゴシック"/>
-              </a:rPr>
-              <a:t>そんなイメージが、若い世代を遠ざけてきました。</a:t>
-            </a:r>
-          </a:p>
-        </p:txBody>
-      </p:sp>
-      <p:sp>
-        <p:nvSpPr>
-          <p:cNvPr id="16" name="点"/>
+        </p:txBody>
+      </p:sp>
+      <p:pic>
+        <p:nvPicPr>
+          <p:cNvPr id="17" name="イラスト_selfie" descr="selfie.png"/>
+          <p:cNvPicPr>
+            <a:picLocks noChangeAspect="1"/>
+          </p:cNvPicPr>
+          <p:nvPr/>
+        </p:nvPicPr>
+        <p:blipFill>
+          <a:blip r:embed="rId4"/>
+          <a:stretch>
+            <a:fillRect/>
+          </a:stretch>
+        </p:blipFill>
+        <p:spPr>
+          <a:xfrm>
+            <a:off x="10648106" y="1564523"/>
+            <a:ext cx="853249" cy="780852"/>
+          </a:xfrm>
+          <a:prstGeom prst="rect">
+            <a:avLst/>
+          </a:prstGeom>
+        </p:spPr>
+      </p:pic>
+      <p:cxnSp>
+        <p:nvCxnSpPr>
+          <p:cNvPr id="18" name="区切り"/>
+          <p:cNvCxnSpPr/>
+          <p:nvPr/>
+        </p:nvCxnSpPr>
+        <p:spPr>
+          <a:xfrm>
+            <a:off x="6046668" y="2444038"/>
+            <a:ext cx="5525161" cy="0"/>
+          </a:xfrm>
+          <a:prstGeom prst="line">
+            <a:avLst/>
+          </a:prstGeom>
+          <a:ln w="19050">
+            <a:solidFill>
+              <a:srgbClr val="E1EAE6"/>
+            </a:solidFill>
+          </a:ln>
+          <a:effectLst/>
+        </p:spPr>
+        <p:style>
+          <a:lnRef idx="2">
+            <a:schemeClr val="accent1"/>
+          </a:lnRef>
+          <a:fillRef idx="0">
+            <a:schemeClr val="accent1"/>
+          </a:fillRef>
+          <a:effectRef idx="0">
+            <a:schemeClr val="accent1"/>
+          </a:effectRef>
+          <a:fontRef idx="minor">
+            <a:schemeClr val="tx1"/>
+          </a:fontRef>
+        </p:style>
+      </p:cxnSp>
+      <p:sp>
+        <p:nvSpPr>
+          <p:cNvPr id="19" name="番号点"/>
           <p:cNvSpPr/>
           <p:nvPr/>
         </p:nvSpPr>
         <p:spPr>
           <a:xfrm>
-            <a:off x="6187616" y="3178377"/>
-            <a:ext cx="380560" cy="380560"/>
+            <a:off x="6060763" y="2735800"/>
+            <a:ext cx="394654" cy="394654"/>
           </a:xfrm>
           <a:prstGeom prst="ellipse">
             <a:avLst/>
@@ -38848,14 +38850,14 @@
       </p:sp>
       <p:sp>
         <p:nvSpPr>
-          <p:cNvPr id="17" name="番号"/>
+          <p:cNvPr id="20" name="番号2"/>
           <p:cNvSpPr txBox="1"/>
           <p:nvPr/>
         </p:nvSpPr>
         <p:spPr>
           <a:xfrm>
-            <a:off x="6187616" y="3171329"/>
-            <a:ext cx="380560" cy="394654"/>
+            <a:off x="6046668" y="2735800"/>
+            <a:ext cx="422844" cy="394654"/>
           </a:xfrm>
           <a:prstGeom prst="rect">
             <a:avLst/>
@@ -38895,14 +38897,14 @@
       </p:sp>
       <p:sp>
         <p:nvSpPr>
-          <p:cNvPr id="18" name="ストーリー_想い"/>
+          <p:cNvPr id="21" name="項目_いま、なぜ福祉人材か"/>
           <p:cNvSpPr txBox="1"/>
           <p:nvPr/>
         </p:nvSpPr>
         <p:spPr>
           <a:xfrm>
-            <a:off x="6821882" y="3086761"/>
-            <a:ext cx="4749947" cy="1409480"/>
+            <a:off x="6666839" y="2542702"/>
+            <a:ext cx="3425036" cy="780852"/>
           </a:xfrm>
           <a:prstGeom prst="rect">
             <a:avLst/>
@@ -38910,48 +38912,24 @@
           <a:noFill/>
         </p:spPr>
         <p:txBody>
-          <a:bodyPr wrap="square" lIns="0" rIns="0" tIns="0" bIns="0" anchor="t">
+          <a:bodyPr wrap="square" lIns="0" rIns="0" tIns="0" bIns="0" anchor="ctr">
             <a:noAutofit/>
           </a:bodyPr>
           <a:lstStyle/>
           <a:p>
             <a:pPr algn="l">
               <a:lnSpc>
-                <a:spcPts val="1587"/>
+                <a:spcPts val="2236"/>
               </a:lnSpc>
               <a:spcBef>
                 <a:spcPts val="0"/>
               </a:spcBef>
               <a:spcAft>
-                <a:spcPts val="0"/>
+                <a:spcPts val="110"/>
               </a:spcAft>
             </a:pPr>
             <a:r>
-              <a:rPr sz="1220" b="1" spc="200">
-                <a:solidFill>
-                  <a:srgbClr val="3FB39D"/>
-                </a:solidFill>
-                <a:latin typeface="游ゴシック"/>
-                <a:ea typeface="游ゴシック"/>
-                <a:cs typeface="游ゴシック"/>
-              </a:rPr>
-              <a:t>想い</a:t>
-            </a:r>
-          </a:p>
-          <a:p>
-            <a:pPr algn="l">
-              <a:lnSpc>
-                <a:spcPts val="2547"/>
-              </a:lnSpc>
-              <a:spcBef>
-                <a:spcPts val="0"/>
-              </a:spcBef>
-              <a:spcAft>
-                <a:spcPts val="332"/>
-              </a:spcAft>
-            </a:pPr>
-            <a:r>
-              <a:rPr sz="1886" b="1">
+              <a:rPr sz="1720" b="1">
                 <a:solidFill>
                   <a:srgbClr val="26323A"/>
                 </a:solidFill>
@@ -38959,13 +38937,13 @@
                 <a:ea typeface="游ゴシック"/>
                 <a:cs typeface="游ゴシック"/>
               </a:rPr>
-              <a:t>生きがいを、みんなで持ち寄る。</a:t>
+              <a:t>いま、なぜ福祉人材か</a:t>
             </a:r>
           </a:p>
           <a:p>
             <a:pPr algn="l">
               <a:lnSpc>
-                <a:spcPts val="2042"/>
+                <a:spcPts val="1609"/>
               </a:lnSpc>
               <a:spcBef>
                 <a:spcPts val="0"/>
@@ -38975,7 +38953,7 @@
               </a:spcAft>
             </a:pPr>
             <a:r>
-              <a:rPr sz="1276" b="0">
+              <a:rPr sz="1109" b="0">
                 <a:solidFill>
                   <a:srgbClr val="5B6B73"/>
                 </a:solidFill>
@@ -38983,21 +38961,105 @@
                 <a:ea typeface="游ゴシック"/>
                 <a:cs typeface="游ゴシック"/>
               </a:rPr>
-              <a:t>子どもから高齢者まで、地域の人が集う場をつくります。</a:t>
+              <a:t>人口の変化と、介護の需要、福祉の価値</a:t>
             </a:r>
           </a:p>
-        </p:txBody>
-      </p:sp>
-      <p:sp>
-        <p:nvSpPr>
-          <p:cNvPr id="19" name="点"/>
+          <a:p>
+            <a:pPr algn="l">
+              <a:lnSpc>
+                <a:spcPts val="1298"/>
+              </a:lnSpc>
+              <a:spcBef>
+                <a:spcPts val="0"/>
+              </a:spcBef>
+              <a:spcAft>
+                <a:spcPts val="0"/>
+              </a:spcAft>
+            </a:pPr>
+            <a:r>
+              <a:rPr sz="998" b="1">
+                <a:solidFill>
+                  <a:srgbClr val="1F7D6C"/>
+                </a:solidFill>
+                <a:latin typeface="游ゴシック"/>
+                <a:ea typeface="游ゴシック"/>
+                <a:cs typeface="游ゴシック"/>
+              </a:rPr>
+              <a:t>P.5–7</a:t>
+            </a:r>
+          </a:p>
+        </p:txBody>
+      </p:sp>
+      <p:pic>
+        <p:nvPicPr>
+          <p:cNvPr id="22" name="イラスト_elder" descr="elder.png"/>
+          <p:cNvPicPr>
+            <a:picLocks noChangeAspect="1"/>
+          </p:cNvPicPr>
+          <p:nvPr/>
+        </p:nvPicPr>
+        <p:blipFill>
+          <a:blip r:embed="rId5"/>
+          <a:stretch>
+            <a:fillRect/>
+          </a:stretch>
+        </p:blipFill>
+        <p:spPr>
+          <a:xfrm>
+            <a:off x="10992485" y="2542702"/>
+            <a:ext cx="508870" cy="780852"/>
+          </a:xfrm>
+          <a:prstGeom prst="rect">
+            <a:avLst/>
+          </a:prstGeom>
+        </p:spPr>
+      </p:pic>
+      <p:cxnSp>
+        <p:nvCxnSpPr>
+          <p:cNvPr id="23" name="区切り"/>
+          <p:cNvCxnSpPr/>
+          <p:nvPr/>
+        </p:nvCxnSpPr>
+        <p:spPr>
+          <a:xfrm>
+            <a:off x="6046668" y="3422217"/>
+            <a:ext cx="5525161" cy="0"/>
+          </a:xfrm>
+          <a:prstGeom prst="line">
+            <a:avLst/>
+          </a:prstGeom>
+          <a:ln w="19050">
+            <a:solidFill>
+              <a:srgbClr val="E1EAE6"/>
+            </a:solidFill>
+          </a:ln>
+          <a:effectLst/>
+        </p:spPr>
+        <p:style>
+          <a:lnRef idx="2">
+            <a:schemeClr val="accent1"/>
+          </a:lnRef>
+          <a:fillRef idx="0">
+            <a:schemeClr val="accent1"/>
+          </a:fillRef>
+          <a:effectRef idx="0">
+            <a:schemeClr val="accent1"/>
+          </a:effectRef>
+          <a:fontRef idx="minor">
+            <a:schemeClr val="tx1"/>
+          </a:fontRef>
+        </p:style>
+      </p:cxnSp>
+      <p:sp>
+        <p:nvSpPr>
+          <p:cNvPr id="24" name="番号点"/>
           <p:cNvSpPr/>
           <p:nvPr/>
         </p:nvSpPr>
         <p:spPr>
           <a:xfrm>
-            <a:off x="6187616" y="4728805"/>
-            <a:ext cx="380560" cy="380560"/>
+            <a:off x="6060763" y="3713979"/>
+            <a:ext cx="394654" cy="394654"/>
           </a:xfrm>
           <a:prstGeom prst="ellipse">
             <a:avLst/>
@@ -39034,14 +39096,14 @@
       </p:sp>
       <p:sp>
         <p:nvSpPr>
-          <p:cNvPr id="20" name="番号"/>
+          <p:cNvPr id="25" name="番号3"/>
           <p:cNvSpPr txBox="1"/>
           <p:nvPr/>
         </p:nvSpPr>
         <p:spPr>
           <a:xfrm>
-            <a:off x="6187616" y="4721757"/>
-            <a:ext cx="380560" cy="394654"/>
+            <a:off x="6046668" y="3713979"/>
+            <a:ext cx="422844" cy="394654"/>
           </a:xfrm>
           <a:prstGeom prst="rect">
             <a:avLst/>
@@ -39081,14 +39143,14 @@
       </p:sp>
       <p:sp>
         <p:nvSpPr>
-          <p:cNvPr id="21" name="ストーリー_めざす姿"/>
+          <p:cNvPr id="26" name="項目_エフビー介護サービスを知る"/>
           <p:cNvSpPr txBox="1"/>
           <p:nvPr/>
         </p:nvSpPr>
         <p:spPr>
           <a:xfrm>
-            <a:off x="6821882" y="4637188"/>
-            <a:ext cx="4749947" cy="1409480"/>
+            <a:off x="6666839" y="3520880"/>
+            <a:ext cx="3425036" cy="780852"/>
           </a:xfrm>
           <a:prstGeom prst="rect">
             <a:avLst/>
@@ -39096,48 +39158,24 @@
           <a:noFill/>
         </p:spPr>
         <p:txBody>
-          <a:bodyPr wrap="square" lIns="0" rIns="0" tIns="0" bIns="0" anchor="t">
+          <a:bodyPr wrap="square" lIns="0" rIns="0" tIns="0" bIns="0" anchor="ctr">
             <a:noAutofit/>
           </a:bodyPr>
           <a:lstStyle/>
           <a:p>
             <a:pPr algn="l">
               <a:lnSpc>
-                <a:spcPts val="1587"/>
+                <a:spcPts val="2236"/>
               </a:lnSpc>
               <a:spcBef>
                 <a:spcPts val="0"/>
               </a:spcBef>
               <a:spcAft>
-                <a:spcPts val="0"/>
+                <a:spcPts val="110"/>
               </a:spcAft>
             </a:pPr>
             <a:r>
-              <a:rPr sz="1220" b="1" spc="200">
-                <a:solidFill>
-                  <a:srgbClr val="F28C3C"/>
-                </a:solidFill>
-                <a:latin typeface="游ゴシック"/>
-                <a:ea typeface="游ゴシック"/>
-                <a:cs typeface="游ゴシック"/>
-              </a:rPr>
-              <a:t>めざす姿</a:t>
-            </a:r>
-          </a:p>
-          <a:p>
-            <a:pPr algn="l">
-              <a:lnSpc>
-                <a:spcPts val="2547"/>
-              </a:lnSpc>
-              <a:spcBef>
-                <a:spcPts val="0"/>
-              </a:spcBef>
-              <a:spcAft>
-                <a:spcPts val="332"/>
-              </a:spcAft>
-            </a:pPr>
-            <a:r>
-              <a:rPr sz="1886" b="1">
+              <a:rPr sz="1720" b="1">
                 <a:solidFill>
                   <a:srgbClr val="26323A"/>
                 </a:solidFill>
@@ -39145,13 +39183,13 @@
                 <a:ea typeface="游ゴシック"/>
                 <a:cs typeface="游ゴシック"/>
               </a:rPr>
-              <a:t>介護を、身近なテーマに。</a:t>
+              <a:t>エフビー介護サービスを知る</a:t>
             </a:r>
           </a:p>
           <a:p>
             <a:pPr algn="l">
               <a:lnSpc>
-                <a:spcPts val="2042"/>
+                <a:spcPts val="1609"/>
               </a:lnSpc>
               <a:spcBef>
                 <a:spcPts val="0"/>
@@ -39161,7 +39199,7 @@
               </a:spcAft>
             </a:pPr>
             <a:r>
-              <a:rPr sz="1276" b="0">
+              <a:rPr sz="1109" b="0">
                 <a:solidFill>
                   <a:srgbClr val="5B6B73"/>
                 </a:solidFill>
@@ -39169,36 +39207,13 @@
                 <a:ea typeface="游ゴシック"/>
                 <a:cs typeface="游ゴシック"/>
               </a:rPr>
-              <a:t>特別なものではなく、地域みんなで考えるものへ。共育実習は、その入口です。</a:t>
+              <a:t>介護の考え方、沿革、事業の展開と成長</a:t>
             </a:r>
           </a:p>
-        </p:txBody>
-      </p:sp>
-      <p:sp>
-        <p:nvSpPr>
-          <p:cNvPr id="22" name="注記"/>
-          <p:cNvSpPr txBox="1"/>
-          <p:nvPr/>
-        </p:nvSpPr>
-        <p:spPr>
-          <a:xfrm>
-            <a:off x="620171" y="6539986"/>
-            <a:ext cx="9161618" cy="155043"/>
-          </a:xfrm>
-          <a:prstGeom prst="rect">
-            <a:avLst/>
-          </a:prstGeom>
-          <a:noFill/>
-        </p:spPr>
-        <p:txBody>
-          <a:bodyPr wrap="square" lIns="0" rIns="0" tIns="0" bIns="0" anchor="t">
-            <a:noAutofit/>
-          </a:bodyPr>
-          <a:lstStyle/>
           <a:p>
             <a:pPr algn="l">
               <a:lnSpc>
-                <a:spcPts val="1082"/>
+                <a:spcPts val="1298"/>
               </a:lnSpc>
               <a:spcBef>
                 <a:spcPts val="0"/>
@@ -39208,22 +39223,538 @@
               </a:spcAft>
             </a:pPr>
             <a:r>
-              <a:rPr sz="832" b="0">
+              <a:rPr sz="998" b="1">
                 <a:solidFill>
-                  <a:srgbClr val="8A9A96"/>
+                  <a:srgbClr val="C8651A"/>
                 </a:solidFill>
                 <a:latin typeface="游ゴシック"/>
                 <a:ea typeface="游ゴシック"/>
                 <a:cs typeface="游ゴシック"/>
               </a:rPr>
-              <a:t>※ 採用コンセプト「FUN LIFE! FUN LOCAL!」と、プロジェクトのミッションの言葉をもとにした叩き台です。</a:t>
+              <a:t>P.8–12</a:t>
             </a:r>
           </a:p>
         </p:txBody>
       </p:sp>
-      <p:sp>
-        <p:nvSpPr>
-          <p:cNvPr id="23" name="ページ番号"/>
+      <p:pic>
+        <p:nvPicPr>
+          <p:cNvPr id="27" name="イラスト_van" descr="van.png"/>
+          <p:cNvPicPr>
+            <a:picLocks noChangeAspect="1"/>
+          </p:cNvPicPr>
+          <p:nvPr/>
+        </p:nvPicPr>
+        <p:blipFill>
+          <a:blip r:embed="rId6"/>
+          <a:stretch>
+            <a:fillRect/>
+          </a:stretch>
+        </p:blipFill>
+        <p:spPr>
+          <a:xfrm>
+            <a:off x="10091875" y="3520880"/>
+            <a:ext cx="1409480" cy="677841"/>
+          </a:xfrm>
+          <a:prstGeom prst="rect">
+            <a:avLst/>
+          </a:prstGeom>
+        </p:spPr>
+      </p:pic>
+      <p:cxnSp>
+        <p:nvCxnSpPr>
+          <p:cNvPr id="28" name="区切り"/>
+          <p:cNvCxnSpPr/>
+          <p:nvPr/>
+        </p:nvCxnSpPr>
+        <p:spPr>
+          <a:xfrm>
+            <a:off x="6046668" y="4400396"/>
+            <a:ext cx="5525161" cy="0"/>
+          </a:xfrm>
+          <a:prstGeom prst="line">
+            <a:avLst/>
+          </a:prstGeom>
+          <a:ln w="19050">
+            <a:solidFill>
+              <a:srgbClr val="E1EAE6"/>
+            </a:solidFill>
+          </a:ln>
+          <a:effectLst/>
+        </p:spPr>
+        <p:style>
+          <a:lnRef idx="2">
+            <a:schemeClr val="accent1"/>
+          </a:lnRef>
+          <a:fillRef idx="0">
+            <a:schemeClr val="accent1"/>
+          </a:fillRef>
+          <a:effectRef idx="0">
+            <a:schemeClr val="accent1"/>
+          </a:effectRef>
+          <a:fontRef idx="minor">
+            <a:schemeClr val="tx1"/>
+          </a:fontRef>
+        </p:style>
+      </p:cxnSp>
+      <p:sp>
+        <p:nvSpPr>
+          <p:cNvPr id="29" name="番号点"/>
+          <p:cNvSpPr/>
+          <p:nvPr/>
+        </p:nvSpPr>
+        <p:spPr>
+          <a:xfrm>
+            <a:off x="6060763" y="4692158"/>
+            <a:ext cx="394654" cy="394654"/>
+          </a:xfrm>
+          <a:prstGeom prst="ellipse">
+            <a:avLst/>
+          </a:prstGeom>
+          <a:solidFill>
+            <a:srgbClr val="F28C3C"/>
+          </a:solidFill>
+          <a:ln>
+            <a:noFill/>
+          </a:ln>
+          <a:effectLst/>
+        </p:spPr>
+        <p:style>
+          <a:lnRef idx="1">
+            <a:schemeClr val="accent1"/>
+          </a:lnRef>
+          <a:fillRef idx="3">
+            <a:schemeClr val="accent1"/>
+          </a:fillRef>
+          <a:effectRef idx="0">
+            <a:schemeClr val="accent1"/>
+          </a:effectRef>
+          <a:fontRef idx="minor">
+            <a:schemeClr val="lt1"/>
+          </a:fontRef>
+        </p:style>
+        <p:txBody>
+          <a:bodyPr rtlCol="0" anchor="ctr"/>
+          <a:lstStyle/>
+          <a:p>
+            <a:pPr algn="ctr"/>
+          </a:p>
+        </p:txBody>
+      </p:sp>
+      <p:sp>
+        <p:nvSpPr>
+          <p:cNvPr id="30" name="番号4"/>
+          <p:cNvSpPr txBox="1"/>
+          <p:nvPr/>
+        </p:nvSpPr>
+        <p:spPr>
+          <a:xfrm>
+            <a:off x="6046668" y="4692158"/>
+            <a:ext cx="422844" cy="394654"/>
+          </a:xfrm>
+          <a:prstGeom prst="rect">
+            <a:avLst/>
+          </a:prstGeom>
+          <a:noFill/>
+        </p:spPr>
+        <p:txBody>
+          <a:bodyPr wrap="square" lIns="0" rIns="0" tIns="0" bIns="0" anchor="ctr">
+            <a:noAutofit/>
+          </a:bodyPr>
+          <a:lstStyle/>
+          <a:p>
+            <a:pPr algn="ctr">
+              <a:lnSpc>
+                <a:spcPts val="1587"/>
+              </a:lnSpc>
+              <a:spcBef>
+                <a:spcPts val="0"/>
+              </a:spcBef>
+              <a:spcAft>
+                <a:spcPts val="0"/>
+              </a:spcAft>
+            </a:pPr>
+            <a:r>
+              <a:rPr sz="1442" b="1">
+                <a:solidFill>
+                  <a:srgbClr val="FFFFFF"/>
+                </a:solidFill>
+                <a:latin typeface="游ゴシック"/>
+                <a:ea typeface="游ゴシック"/>
+                <a:cs typeface="游ゴシック"/>
+              </a:rPr>
+              <a:t>4</a:t>
+            </a:r>
+          </a:p>
+        </p:txBody>
+      </p:sp>
+      <p:sp>
+        <p:nvSpPr>
+          <p:cNvPr id="31" name="項目_実習で得られること"/>
+          <p:cNvSpPr txBox="1"/>
+          <p:nvPr/>
+        </p:nvSpPr>
+        <p:spPr>
+          <a:xfrm>
+            <a:off x="6666839" y="4499059"/>
+            <a:ext cx="3425036" cy="780852"/>
+          </a:xfrm>
+          <a:prstGeom prst="rect">
+            <a:avLst/>
+          </a:prstGeom>
+          <a:noFill/>
+        </p:spPr>
+        <p:txBody>
+          <a:bodyPr wrap="square" lIns="0" rIns="0" tIns="0" bIns="0" anchor="ctr">
+            <a:noAutofit/>
+          </a:bodyPr>
+          <a:lstStyle/>
+          <a:p>
+            <a:pPr algn="l">
+              <a:lnSpc>
+                <a:spcPts val="2236"/>
+              </a:lnSpc>
+              <a:spcBef>
+                <a:spcPts val="0"/>
+              </a:spcBef>
+              <a:spcAft>
+                <a:spcPts val="110"/>
+              </a:spcAft>
+            </a:pPr>
+            <a:r>
+              <a:rPr sz="1720" b="1">
+                <a:solidFill>
+                  <a:srgbClr val="26323A"/>
+                </a:solidFill>
+                <a:latin typeface="游ゴシック"/>
+                <a:ea typeface="游ゴシック"/>
+                <a:cs typeface="游ゴシック"/>
+              </a:rPr>
+              <a:t>実習で得られること</a:t>
+            </a:r>
+          </a:p>
+          <a:p>
+            <a:pPr algn="l">
+              <a:lnSpc>
+                <a:spcPts val="1609"/>
+              </a:lnSpc>
+              <a:spcBef>
+                <a:spcPts val="0"/>
+              </a:spcBef>
+              <a:spcAft>
+                <a:spcPts val="0"/>
+              </a:spcAft>
+            </a:pPr>
+            <a:r>
+              <a:rPr sz="1109" b="0">
+                <a:solidFill>
+                  <a:srgbClr val="5B6B73"/>
+                </a:solidFill>
+                <a:latin typeface="游ゴシック"/>
+                <a:ea typeface="游ゴシック"/>
+                <a:cs typeface="游ゴシック"/>
+              </a:rPr>
+              <a:t>他社との違い、プログラム、受け入れ体制</a:t>
+            </a:r>
+          </a:p>
+          <a:p>
+            <a:pPr algn="l">
+              <a:lnSpc>
+                <a:spcPts val="1298"/>
+              </a:lnSpc>
+              <a:spcBef>
+                <a:spcPts val="0"/>
+              </a:spcBef>
+              <a:spcAft>
+                <a:spcPts val="0"/>
+              </a:spcAft>
+            </a:pPr>
+            <a:r>
+              <a:rPr sz="998" b="1">
+                <a:solidFill>
+                  <a:srgbClr val="C8651A"/>
+                </a:solidFill>
+                <a:latin typeface="游ゴシック"/>
+                <a:ea typeface="游ゴシック"/>
+                <a:cs typeface="游ゴシック"/>
+              </a:rPr>
+              <a:t>P.13–16</a:t>
+            </a:r>
+          </a:p>
+        </p:txBody>
+      </p:sp>
+      <p:pic>
+        <p:nvPicPr>
+          <p:cNvPr id="32" name="イラスト_care" descr="care.png"/>
+          <p:cNvPicPr>
+            <a:picLocks noChangeAspect="1"/>
+          </p:cNvPicPr>
+          <p:nvPr/>
+        </p:nvPicPr>
+        <p:blipFill>
+          <a:blip r:embed="rId7"/>
+          <a:stretch>
+            <a:fillRect/>
+          </a:stretch>
+        </p:blipFill>
+        <p:spPr>
+          <a:xfrm>
+            <a:off x="10661198" y="4499059"/>
+            <a:ext cx="840157" cy="780852"/>
+          </a:xfrm>
+          <a:prstGeom prst="rect">
+            <a:avLst/>
+          </a:prstGeom>
+        </p:spPr>
+      </p:pic>
+      <p:cxnSp>
+        <p:nvCxnSpPr>
+          <p:cNvPr id="33" name="区切り"/>
+          <p:cNvCxnSpPr/>
+          <p:nvPr/>
+        </p:nvCxnSpPr>
+        <p:spPr>
+          <a:xfrm>
+            <a:off x="6046668" y="5378575"/>
+            <a:ext cx="5525161" cy="0"/>
+          </a:xfrm>
+          <a:prstGeom prst="line">
+            <a:avLst/>
+          </a:prstGeom>
+          <a:ln w="19050">
+            <a:solidFill>
+              <a:srgbClr val="E1EAE6"/>
+            </a:solidFill>
+          </a:ln>
+          <a:effectLst/>
+        </p:spPr>
+        <p:style>
+          <a:lnRef idx="2">
+            <a:schemeClr val="accent1"/>
+          </a:lnRef>
+          <a:fillRef idx="0">
+            <a:schemeClr val="accent1"/>
+          </a:fillRef>
+          <a:effectRef idx="0">
+            <a:schemeClr val="accent1"/>
+          </a:effectRef>
+          <a:fontRef idx="minor">
+            <a:schemeClr val="tx1"/>
+          </a:fontRef>
+        </p:style>
+      </p:cxnSp>
+      <p:sp>
+        <p:nvSpPr>
+          <p:cNvPr id="34" name="番号点"/>
+          <p:cNvSpPr/>
+          <p:nvPr/>
+        </p:nvSpPr>
+        <p:spPr>
+          <a:xfrm>
+            <a:off x="6060763" y="5670337"/>
+            <a:ext cx="394654" cy="394654"/>
+          </a:xfrm>
+          <a:prstGeom prst="ellipse">
+            <a:avLst/>
+          </a:prstGeom>
+          <a:solidFill>
+            <a:srgbClr val="3FB39D"/>
+          </a:solidFill>
+          <a:ln>
+            <a:noFill/>
+          </a:ln>
+          <a:effectLst/>
+        </p:spPr>
+        <p:style>
+          <a:lnRef idx="1">
+            <a:schemeClr val="accent1"/>
+          </a:lnRef>
+          <a:fillRef idx="3">
+            <a:schemeClr val="accent1"/>
+          </a:fillRef>
+          <a:effectRef idx="0">
+            <a:schemeClr val="accent1"/>
+          </a:effectRef>
+          <a:fontRef idx="minor">
+            <a:schemeClr val="lt1"/>
+          </a:fontRef>
+        </p:style>
+        <p:txBody>
+          <a:bodyPr rtlCol="0" anchor="ctr"/>
+          <a:lstStyle/>
+          <a:p>
+            <a:pPr algn="ctr"/>
+          </a:p>
+        </p:txBody>
+      </p:sp>
+      <p:sp>
+        <p:nvSpPr>
+          <p:cNvPr id="35" name="番号5"/>
+          <p:cNvSpPr txBox="1"/>
+          <p:nvPr/>
+        </p:nvSpPr>
+        <p:spPr>
+          <a:xfrm>
+            <a:off x="6046668" y="5670337"/>
+            <a:ext cx="422844" cy="394654"/>
+          </a:xfrm>
+          <a:prstGeom prst="rect">
+            <a:avLst/>
+          </a:prstGeom>
+          <a:noFill/>
+        </p:spPr>
+        <p:txBody>
+          <a:bodyPr wrap="square" lIns="0" rIns="0" tIns="0" bIns="0" anchor="ctr">
+            <a:noAutofit/>
+          </a:bodyPr>
+          <a:lstStyle/>
+          <a:p>
+            <a:pPr algn="ctr">
+              <a:lnSpc>
+                <a:spcPts val="1587"/>
+              </a:lnSpc>
+              <a:spcBef>
+                <a:spcPts val="0"/>
+              </a:spcBef>
+              <a:spcAft>
+                <a:spcPts val="0"/>
+              </a:spcAft>
+            </a:pPr>
+            <a:r>
+              <a:rPr sz="1442" b="1">
+                <a:solidFill>
+                  <a:srgbClr val="FFFFFF"/>
+                </a:solidFill>
+                <a:latin typeface="游ゴシック"/>
+                <a:ea typeface="游ゴシック"/>
+                <a:cs typeface="游ゴシック"/>
+              </a:rPr>
+              <a:t>5</a:t>
+            </a:r>
+          </a:p>
+        </p:txBody>
+      </p:sp>
+      <p:sp>
+        <p:nvSpPr>
+          <p:cNvPr id="36" name="項目_実習のひろがり"/>
+          <p:cNvSpPr txBox="1"/>
+          <p:nvPr/>
+        </p:nvSpPr>
+        <p:spPr>
+          <a:xfrm>
+            <a:off x="6666839" y="5477238"/>
+            <a:ext cx="3425036" cy="780852"/>
+          </a:xfrm>
+          <a:prstGeom prst="rect">
+            <a:avLst/>
+          </a:prstGeom>
+          <a:noFill/>
+        </p:spPr>
+        <p:txBody>
+          <a:bodyPr wrap="square" lIns="0" rIns="0" tIns="0" bIns="0" anchor="ctr">
+            <a:noAutofit/>
+          </a:bodyPr>
+          <a:lstStyle/>
+          <a:p>
+            <a:pPr algn="l">
+              <a:lnSpc>
+                <a:spcPts val="2236"/>
+              </a:lnSpc>
+              <a:spcBef>
+                <a:spcPts val="0"/>
+              </a:spcBef>
+              <a:spcAft>
+                <a:spcPts val="110"/>
+              </a:spcAft>
+            </a:pPr>
+            <a:r>
+              <a:rPr sz="1720" b="1">
+                <a:solidFill>
+                  <a:srgbClr val="26323A"/>
+                </a:solidFill>
+                <a:latin typeface="游ゴシック"/>
+                <a:ea typeface="游ゴシック"/>
+                <a:cs typeface="游ゴシック"/>
+              </a:rPr>
+              <a:t>実習のひろがり</a:t>
+            </a:r>
+          </a:p>
+          <a:p>
+            <a:pPr algn="l">
+              <a:lnSpc>
+                <a:spcPts val="1609"/>
+              </a:lnSpc>
+              <a:spcBef>
+                <a:spcPts val="0"/>
+              </a:spcBef>
+              <a:spcAft>
+                <a:spcPts val="0"/>
+              </a:spcAft>
+            </a:pPr>
+            <a:r>
+              <a:rPr sz="1109" b="0">
+                <a:solidFill>
+                  <a:srgbClr val="5B6B73"/>
+                </a:solidFill>
+                <a:latin typeface="游ゴシック"/>
+                <a:ea typeface="游ゴシック"/>
+                <a:cs typeface="游ゴシック"/>
+              </a:rPr>
+              <a:t>ブランドの育ち方と、応募までの流れ</a:t>
+            </a:r>
+          </a:p>
+          <a:p>
+            <a:pPr algn="l">
+              <a:lnSpc>
+                <a:spcPts val="1298"/>
+              </a:lnSpc>
+              <a:spcBef>
+                <a:spcPts val="0"/>
+              </a:spcBef>
+              <a:spcAft>
+                <a:spcPts val="0"/>
+              </a:spcAft>
+            </a:pPr>
+            <a:r>
+              <a:rPr sz="998" b="1">
+                <a:solidFill>
+                  <a:srgbClr val="1F7D6C"/>
+                </a:solidFill>
+                <a:latin typeface="游ゴシック"/>
+                <a:ea typeface="游ゴシック"/>
+                <a:cs typeface="游ゴシック"/>
+              </a:rPr>
+              <a:t>P.17–18</a:t>
+            </a:r>
+          </a:p>
+        </p:txBody>
+      </p:sp>
+      <p:pic>
+        <p:nvPicPr>
+          <p:cNvPr id="37" name="イラスト_boy" descr="boy.png"/>
+          <p:cNvPicPr>
+            <a:picLocks noChangeAspect="1"/>
+          </p:cNvPicPr>
+          <p:nvPr/>
+        </p:nvPicPr>
+        <p:blipFill>
+          <a:blip r:embed="rId8"/>
+          <a:stretch>
+            <a:fillRect/>
+          </a:stretch>
+        </p:blipFill>
+        <p:spPr>
+          <a:xfrm>
+            <a:off x="11076624" y="5477238"/>
+            <a:ext cx="424731" cy="780852"/>
+          </a:xfrm>
+          <a:prstGeom prst="rect">
+            <a:avLst/>
+          </a:prstGeom>
+        </p:spPr>
+      </p:pic>
+      <p:sp>
+        <p:nvSpPr>
+          <p:cNvPr id="38" name="ページ番号"/>
           <p:cNvSpPr txBox="1"/>
           <p:nvPr/>
         </p:nvSpPr>

</xml_diff>

<commit_message>
Playful cover: scattered illustration cast, sun, confetti dots
Co-Authored-By: Claude Sonnet 5.5 <noreply@anthropic.com>
Claude-Session: https://claude.ai/code/session_01MxdMxhi7qZAPC9aBAhtpWC
</commit_message>
<xml_diff>
--- a/kyoiku-jisshu/共育実習_図解.pptx
+++ b/kyoiku-jisshu/共育実習_図解.pptx
@@ -7027,9 +7027,405 @@
           </a:p>
         </p:txBody>
       </p:sp>
+      <p:sp>
+        <p:nvSpPr>
+          <p:cNvPr id="10" name="太陽"/>
+          <p:cNvSpPr/>
+          <p:nvPr/>
+        </p:nvSpPr>
+        <p:spPr>
+          <a:xfrm>
+            <a:off x="9408277" y="739977"/>
+            <a:ext cx="2325642" cy="2325642"/>
+          </a:xfrm>
+          <a:prstGeom prst="ellipse">
+            <a:avLst/>
+          </a:prstGeom>
+          <a:solidFill>
+            <a:srgbClr val="8ACFC0"/>
+          </a:solidFill>
+          <a:ln>
+            <a:noFill/>
+          </a:ln>
+          <a:effectLst/>
+        </p:spPr>
+        <p:style>
+          <a:lnRef idx="1">
+            <a:schemeClr val="accent1"/>
+          </a:lnRef>
+          <a:fillRef idx="3">
+            <a:schemeClr val="accent1"/>
+          </a:fillRef>
+          <a:effectRef idx="0">
+            <a:schemeClr val="accent1"/>
+          </a:effectRef>
+          <a:fontRef idx="minor">
+            <a:schemeClr val="lt1"/>
+          </a:fontRef>
+        </p:style>
+        <p:txBody>
+          <a:bodyPr rtlCol="0" anchor="ctr"/>
+          <a:lstStyle/>
+          <a:p>
+            <a:pPr algn="ctr"/>
+          </a:p>
+        </p:txBody>
+      </p:sp>
+      <p:sp>
+        <p:nvSpPr>
+          <p:cNvPr id="11" name="太陽中"/>
+          <p:cNvSpPr/>
+          <p:nvPr/>
+        </p:nvSpPr>
+        <p:spPr>
+          <a:xfrm>
+            <a:off x="9866358" y="1198058"/>
+            <a:ext cx="1409480" cy="1409480"/>
+          </a:xfrm>
+          <a:prstGeom prst="ellipse">
+            <a:avLst/>
+          </a:prstGeom>
+          <a:solidFill>
+            <a:srgbClr val="A6DDD1"/>
+          </a:solidFill>
+          <a:ln>
+            <a:noFill/>
+          </a:ln>
+          <a:effectLst/>
+        </p:spPr>
+        <p:style>
+          <a:lnRef idx="1">
+            <a:schemeClr val="accent1"/>
+          </a:lnRef>
+          <a:fillRef idx="3">
+            <a:schemeClr val="accent1"/>
+          </a:fillRef>
+          <a:effectRef idx="0">
+            <a:schemeClr val="accent1"/>
+          </a:effectRef>
+          <a:fontRef idx="minor">
+            <a:schemeClr val="lt1"/>
+          </a:fontRef>
+        </p:style>
+        <p:txBody>
+          <a:bodyPr rtlCol="0" anchor="ctr"/>
+          <a:lstStyle/>
+          <a:p>
+            <a:pPr algn="ctr"/>
+          </a:p>
+        </p:txBody>
+      </p:sp>
+      <p:sp>
+        <p:nvSpPr>
+          <p:cNvPr id="12" name="飾り"/>
+          <p:cNvSpPr/>
+          <p:nvPr/>
+        </p:nvSpPr>
+        <p:spPr>
+          <a:xfrm>
+            <a:off x="7730997" y="1670234"/>
+            <a:ext cx="183232" cy="183232"/>
+          </a:xfrm>
+          <a:prstGeom prst="ellipse">
+            <a:avLst/>
+          </a:prstGeom>
+          <a:solidFill>
+            <a:srgbClr val="FCE08E"/>
+          </a:solidFill>
+          <a:ln>
+            <a:noFill/>
+          </a:ln>
+          <a:effectLst/>
+        </p:spPr>
+        <p:style>
+          <a:lnRef idx="1">
+            <a:schemeClr val="accent1"/>
+          </a:lnRef>
+          <a:fillRef idx="3">
+            <a:schemeClr val="accent1"/>
+          </a:fillRef>
+          <a:effectRef idx="0">
+            <a:schemeClr val="accent1"/>
+          </a:effectRef>
+          <a:fontRef idx="minor">
+            <a:schemeClr val="lt1"/>
+          </a:fontRef>
+        </p:style>
+        <p:txBody>
+          <a:bodyPr rtlCol="0" anchor="ctr"/>
+          <a:lstStyle/>
+          <a:p>
+            <a:pPr algn="ctr"/>
+          </a:p>
+        </p:txBody>
+      </p:sp>
+      <p:sp>
+        <p:nvSpPr>
+          <p:cNvPr id="13" name="飾り"/>
+          <p:cNvSpPr/>
+          <p:nvPr/>
+        </p:nvSpPr>
+        <p:spPr>
+          <a:xfrm>
+            <a:off x="8752869" y="1141679"/>
+            <a:ext cx="112758" cy="112758"/>
+          </a:xfrm>
+          <a:prstGeom prst="ellipse">
+            <a:avLst/>
+          </a:prstGeom>
+          <a:solidFill>
+            <a:srgbClr val="FFFFFF"/>
+          </a:solidFill>
+          <a:ln>
+            <a:noFill/>
+          </a:ln>
+          <a:effectLst/>
+        </p:spPr>
+        <p:style>
+          <a:lnRef idx="1">
+            <a:schemeClr val="accent1"/>
+          </a:lnRef>
+          <a:fillRef idx="3">
+            <a:schemeClr val="accent1"/>
+          </a:fillRef>
+          <a:effectRef idx="0">
+            <a:schemeClr val="accent1"/>
+          </a:effectRef>
+          <a:fontRef idx="minor">
+            <a:schemeClr val="lt1"/>
+          </a:fontRef>
+        </p:style>
+        <p:txBody>
+          <a:bodyPr rtlCol="0" anchor="ctr"/>
+          <a:lstStyle/>
+          <a:p>
+            <a:pPr algn="ctr"/>
+          </a:p>
+        </p:txBody>
+      </p:sp>
+      <p:sp>
+        <p:nvSpPr>
+          <p:cNvPr id="14" name="飾り"/>
+          <p:cNvSpPr/>
+          <p:nvPr/>
+        </p:nvSpPr>
+        <p:spPr>
+          <a:xfrm>
+            <a:off x="11762109" y="3587126"/>
+            <a:ext cx="155043" cy="155043"/>
+          </a:xfrm>
+          <a:prstGeom prst="ellipse">
+            <a:avLst/>
+          </a:prstGeom>
+          <a:solidFill>
+            <a:srgbClr val="FCE08E"/>
+          </a:solidFill>
+          <a:ln>
+            <a:noFill/>
+          </a:ln>
+          <a:effectLst/>
+        </p:spPr>
+        <p:style>
+          <a:lnRef idx="1">
+            <a:schemeClr val="accent1"/>
+          </a:lnRef>
+          <a:fillRef idx="3">
+            <a:schemeClr val="accent1"/>
+          </a:fillRef>
+          <a:effectRef idx="0">
+            <a:schemeClr val="accent1"/>
+          </a:effectRef>
+          <a:fontRef idx="minor">
+            <a:schemeClr val="lt1"/>
+          </a:fontRef>
+        </p:style>
+        <p:txBody>
+          <a:bodyPr rtlCol="0" anchor="ctr"/>
+          <a:lstStyle/>
+          <a:p>
+            <a:pPr algn="ctr"/>
+          </a:p>
+        </p:txBody>
+      </p:sp>
+      <p:sp>
+        <p:nvSpPr>
+          <p:cNvPr id="15" name="飾り"/>
+          <p:cNvSpPr/>
+          <p:nvPr/>
+        </p:nvSpPr>
+        <p:spPr>
+          <a:xfrm>
+            <a:off x="6998067" y="3262946"/>
+            <a:ext cx="98664" cy="98664"/>
+          </a:xfrm>
+          <a:prstGeom prst="ellipse">
+            <a:avLst/>
+          </a:prstGeom>
+          <a:solidFill>
+            <a:srgbClr val="F7AB67"/>
+          </a:solidFill>
+          <a:ln>
+            <a:noFill/>
+          </a:ln>
+          <a:effectLst/>
+        </p:spPr>
+        <p:style>
+          <a:lnRef idx="1">
+            <a:schemeClr val="accent1"/>
+          </a:lnRef>
+          <a:fillRef idx="3">
+            <a:schemeClr val="accent1"/>
+          </a:fillRef>
+          <a:effectRef idx="0">
+            <a:schemeClr val="accent1"/>
+          </a:effectRef>
+          <a:fontRef idx="minor">
+            <a:schemeClr val="lt1"/>
+          </a:fontRef>
+        </p:style>
+        <p:txBody>
+          <a:bodyPr rtlCol="0" anchor="ctr"/>
+          <a:lstStyle/>
+          <a:p>
+            <a:pPr algn="ctr"/>
+          </a:p>
+        </p:txBody>
+      </p:sp>
+      <p:sp>
+        <p:nvSpPr>
+          <p:cNvPr id="16" name="飾り"/>
+          <p:cNvSpPr/>
+          <p:nvPr/>
+        </p:nvSpPr>
+        <p:spPr>
+          <a:xfrm>
+            <a:off x="11494308" y="1064157"/>
+            <a:ext cx="126853" cy="126853"/>
+          </a:xfrm>
+          <a:prstGeom prst="ellipse">
+            <a:avLst/>
+          </a:prstGeom>
+          <a:solidFill>
+            <a:srgbClr val="F7AB67"/>
+          </a:solidFill>
+          <a:ln>
+            <a:noFill/>
+          </a:ln>
+          <a:effectLst/>
+        </p:spPr>
+        <p:style>
+          <a:lnRef idx="1">
+            <a:schemeClr val="accent1"/>
+          </a:lnRef>
+          <a:fillRef idx="3">
+            <a:schemeClr val="accent1"/>
+          </a:fillRef>
+          <a:effectRef idx="0">
+            <a:schemeClr val="accent1"/>
+          </a:effectRef>
+          <a:fontRef idx="minor">
+            <a:schemeClr val="lt1"/>
+          </a:fontRef>
+        </p:style>
+        <p:txBody>
+          <a:bodyPr rtlCol="0" anchor="ctr"/>
+          <a:lstStyle/>
+          <a:p>
+            <a:pPr algn="ctr"/>
+          </a:p>
+        </p:txBody>
+      </p:sp>
+      <p:sp>
+        <p:nvSpPr>
+          <p:cNvPr id="17" name="飾り"/>
+          <p:cNvSpPr/>
+          <p:nvPr/>
+        </p:nvSpPr>
+        <p:spPr>
+          <a:xfrm>
+            <a:off x="9605605" y="3262946"/>
+            <a:ext cx="98664" cy="98664"/>
+          </a:xfrm>
+          <a:prstGeom prst="ellipse">
+            <a:avLst/>
+          </a:prstGeom>
+          <a:solidFill>
+            <a:srgbClr val="FFFFFF"/>
+          </a:solidFill>
+          <a:ln>
+            <a:noFill/>
+          </a:ln>
+          <a:effectLst/>
+        </p:spPr>
+        <p:style>
+          <a:lnRef idx="1">
+            <a:schemeClr val="accent1"/>
+          </a:lnRef>
+          <a:fillRef idx="3">
+            <a:schemeClr val="accent1"/>
+          </a:fillRef>
+          <a:effectRef idx="0">
+            <a:schemeClr val="accent1"/>
+          </a:effectRef>
+          <a:fontRef idx="minor">
+            <a:schemeClr val="lt1"/>
+          </a:fontRef>
+        </p:style>
+        <p:txBody>
+          <a:bodyPr rtlCol="0" anchor="ctr"/>
+          <a:lstStyle/>
+          <a:p>
+            <a:pPr algn="ctr"/>
+          </a:p>
+        </p:txBody>
+      </p:sp>
+      <p:sp>
+        <p:nvSpPr>
+          <p:cNvPr id="18" name="飾り"/>
+          <p:cNvSpPr/>
+          <p:nvPr/>
+        </p:nvSpPr>
+        <p:spPr>
+          <a:xfrm>
+            <a:off x="10951658" y="4186155"/>
+            <a:ext cx="84569" cy="84569"/>
+          </a:xfrm>
+          <a:prstGeom prst="ellipse">
+            <a:avLst/>
+          </a:prstGeom>
+          <a:solidFill>
+            <a:srgbClr val="FCE08E"/>
+          </a:solidFill>
+          <a:ln>
+            <a:noFill/>
+          </a:ln>
+          <a:effectLst/>
+        </p:spPr>
+        <p:style>
+          <a:lnRef idx="1">
+            <a:schemeClr val="accent1"/>
+          </a:lnRef>
+          <a:fillRef idx="3">
+            <a:schemeClr val="accent1"/>
+          </a:fillRef>
+          <a:effectRef idx="0">
+            <a:schemeClr val="accent1"/>
+          </a:effectRef>
+          <a:fontRef idx="minor">
+            <a:schemeClr val="lt1"/>
+          </a:fontRef>
+        </p:style>
+        <p:txBody>
+          <a:bodyPr rtlCol="0" anchor="ctr"/>
+          <a:lstStyle/>
+          <a:p>
+            <a:pPr algn="ctr"/>
+          </a:p>
+        </p:txBody>
+      </p:sp>
       <p:pic>
         <p:nvPicPr>
-          <p:cNvPr id="10" name="イラスト_selfie" descr="selfie.png"/>
+          <p:cNvPr id="19" name="イラスト_van" descr="van.png"/>
           <p:cNvPicPr>
             <a:picLocks noChangeAspect="1"/>
           </p:cNvPicPr>
@@ -7043,8 +7439,8 @@
         </p:blipFill>
         <p:spPr>
           <a:xfrm>
-            <a:off x="7329295" y="4616046"/>
-            <a:ext cx="1798052" cy="1761850"/>
+            <a:off x="7117873" y="2537064"/>
+            <a:ext cx="1761850" cy="847302"/>
           </a:xfrm>
           <a:prstGeom prst="rect">
             <a:avLst/>
@@ -7053,7 +7449,7 @@
       </p:pic>
       <p:pic>
         <p:nvPicPr>
-          <p:cNvPr id="11" name="イラスト_boy" descr="boy.png"/>
+          <p:cNvPr id="20" name="イラスト_picnic" descr="picnic.png"/>
           <p:cNvPicPr>
             <a:picLocks noChangeAspect="1"/>
           </p:cNvPicPr>
@@ -7067,8 +7463,8 @@
         </p:blipFill>
         <p:spPr>
           <a:xfrm>
-            <a:off x="9161618" y="4686520"/>
-            <a:ext cx="919995" cy="1691376"/>
+            <a:off x="8456879" y="3664647"/>
+            <a:ext cx="1620902" cy="1089728"/>
           </a:xfrm>
           <a:prstGeom prst="rect">
             <a:avLst/>
@@ -7077,7 +7473,7 @@
       </p:pic>
       <p:pic>
         <p:nvPicPr>
-          <p:cNvPr id="12" name="イラスト_elder" descr="elder.png"/>
+          <p:cNvPr id="21" name="イラスト_care" descr="care.png"/>
           <p:cNvPicPr>
             <a:picLocks noChangeAspect="1"/>
           </p:cNvPicPr>
@@ -7091,8 +7487,128 @@
         </p:blipFill>
         <p:spPr>
           <a:xfrm>
-            <a:off x="10148254" y="4263676"/>
-            <a:ext cx="1377806" cy="2114220"/>
+            <a:off x="10359676" y="3312277"/>
+            <a:ext cx="1137397" cy="1057110"/>
+          </a:xfrm>
+          <a:prstGeom prst="rect">
+            <a:avLst/>
+          </a:prstGeom>
+        </p:spPr>
+      </p:pic>
+      <p:pic>
+        <p:nvPicPr>
+          <p:cNvPr id="22" name="イラスト_runner" descr="runner.png"/>
+          <p:cNvPicPr>
+            <a:picLocks noChangeAspect="1"/>
+          </p:cNvPicPr>
+          <p:nvPr/>
+        </p:nvPicPr>
+        <p:blipFill>
+          <a:blip r:embed="rId5"/>
+          <a:stretch>
+            <a:fillRect/>
+          </a:stretch>
+        </p:blipFill>
+        <p:spPr>
+          <a:xfrm>
+            <a:off x="5426497" y="5038890"/>
+            <a:ext cx="1747817" cy="1339006"/>
+          </a:xfrm>
+          <a:prstGeom prst="rect">
+            <a:avLst/>
+          </a:prstGeom>
+        </p:spPr>
+      </p:pic>
+      <p:pic>
+        <p:nvPicPr>
+          <p:cNvPr id="23" name="イラスト_selfie" descr="selfie.png"/>
+          <p:cNvPicPr>
+            <a:picLocks noChangeAspect="1"/>
+          </p:cNvPicPr>
+          <p:nvPr/>
+        </p:nvPicPr>
+        <p:blipFill>
+          <a:blip r:embed="rId6"/>
+          <a:stretch>
+            <a:fillRect/>
+          </a:stretch>
+        </p:blipFill>
+        <p:spPr>
+          <a:xfrm>
+            <a:off x="7230694" y="4862705"/>
+            <a:ext cx="1546325" cy="1515191"/>
+          </a:xfrm>
+          <a:prstGeom prst="rect">
+            <a:avLst/>
+          </a:prstGeom>
+        </p:spPr>
+      </p:pic>
+      <p:pic>
+        <p:nvPicPr>
+          <p:cNvPr id="24" name="イラスト_boy" descr="boy.png"/>
+          <p:cNvPicPr>
+            <a:picLocks noChangeAspect="1"/>
+          </p:cNvPicPr>
+          <p:nvPr/>
+        </p:nvPicPr>
+        <p:blipFill>
+          <a:blip r:embed="rId7"/>
+          <a:stretch>
+            <a:fillRect/>
+          </a:stretch>
+        </p:blipFill>
+        <p:spPr>
+          <a:xfrm>
+            <a:off x="8833398" y="4933179"/>
+            <a:ext cx="785829" cy="1444717"/>
+          </a:xfrm>
+          <a:prstGeom prst="rect">
+            <a:avLst/>
+          </a:prstGeom>
+        </p:spPr>
+      </p:pic>
+      <p:pic>
+        <p:nvPicPr>
+          <p:cNvPr id="25" name="イラスト_elder" descr="elder.png"/>
+          <p:cNvPicPr>
+            <a:picLocks noChangeAspect="1"/>
+          </p:cNvPicPr>
+          <p:nvPr/>
+        </p:nvPicPr>
+        <p:blipFill>
+          <a:blip r:embed="rId8"/>
+          <a:stretch>
+            <a:fillRect/>
+          </a:stretch>
+        </p:blipFill>
+        <p:spPr>
+          <a:xfrm>
+            <a:off x="9675606" y="4721757"/>
+            <a:ext cx="1079281" cy="1656139"/>
+          </a:xfrm>
+          <a:prstGeom prst="rect">
+            <a:avLst/>
+          </a:prstGeom>
+        </p:spPr>
+      </p:pic>
+      <p:pic>
+        <p:nvPicPr>
+          <p:cNvPr id="26" name="イラスト_runners" descr="runners.png"/>
+          <p:cNvPicPr>
+            <a:picLocks noChangeAspect="1"/>
+          </p:cNvPicPr>
+          <p:nvPr/>
+        </p:nvPicPr>
+        <p:blipFill>
+          <a:blip r:embed="rId9"/>
+          <a:stretch>
+            <a:fillRect/>
+          </a:stretch>
+        </p:blipFill>
+        <p:spPr>
+          <a:xfrm>
+            <a:off x="10811267" y="5461734"/>
+            <a:ext cx="1252605" cy="916162"/>
           </a:xfrm>
           <a:prstGeom prst="rect">
             <a:avLst/>

</xml_diff>

<commit_message>
Cover: layered mountains and basin with the illustration cast gathered in the valley
Co-Authored-By: Claude Sonnet 5.5 <noreply@anthropic.com>
Claude-Session: https://claude.ai/code/session_01MxdMxhi7qZAPC9aBAhtpWC
</commit_message>
<xml_diff>
--- a/kyoiku-jisshu/共育実習_図解.pptx
+++ b/kyoiku-jisshu/共育実習_図解.pptx
@@ -6642,14 +6642,102 @@
       </p:sp>
       <p:sp>
         <p:nvSpPr>
-          <p:cNvPr id="3" name="山1"/>
+          <p:cNvPr id="3" name="太陽"/>
           <p:cNvSpPr/>
           <p:nvPr/>
         </p:nvSpPr>
         <p:spPr>
           <a:xfrm>
-            <a:off x="0" y="4228439"/>
-            <a:ext cx="6342659" cy="2628680"/>
+            <a:off x="8668301" y="1268532"/>
+            <a:ext cx="2114220" cy="2114220"/>
+          </a:xfrm>
+          <a:prstGeom prst="ellipse">
+            <a:avLst/>
+          </a:prstGeom>
+          <a:solidFill>
+            <a:srgbClr val="8ACFC0"/>
+          </a:solidFill>
+          <a:ln>
+            <a:noFill/>
+          </a:ln>
+          <a:effectLst/>
+        </p:spPr>
+        <p:style>
+          <a:lnRef idx="1">
+            <a:schemeClr val="accent1"/>
+          </a:lnRef>
+          <a:fillRef idx="3">
+            <a:schemeClr val="accent1"/>
+          </a:fillRef>
+          <a:effectRef idx="0">
+            <a:schemeClr val="accent1"/>
+          </a:effectRef>
+          <a:fontRef idx="minor">
+            <a:schemeClr val="lt1"/>
+          </a:fontRef>
+        </p:style>
+        <p:txBody>
+          <a:bodyPr rtlCol="0" anchor="ctr"/>
+          <a:lstStyle/>
+          <a:p>
+            <a:pPr algn="ctr"/>
+          </a:p>
+        </p:txBody>
+      </p:sp>
+      <p:sp>
+        <p:nvSpPr>
+          <p:cNvPr id="4" name="太陽中"/>
+          <p:cNvSpPr/>
+          <p:nvPr/>
+        </p:nvSpPr>
+        <p:spPr>
+          <a:xfrm>
+            <a:off x="9091145" y="1691376"/>
+            <a:ext cx="1268532" cy="1268532"/>
+          </a:xfrm>
+          <a:prstGeom prst="ellipse">
+            <a:avLst/>
+          </a:prstGeom>
+          <a:solidFill>
+            <a:srgbClr val="A6DDD1"/>
+          </a:solidFill>
+          <a:ln>
+            <a:noFill/>
+          </a:ln>
+          <a:effectLst/>
+        </p:spPr>
+        <p:style>
+          <a:lnRef idx="1">
+            <a:schemeClr val="accent1"/>
+          </a:lnRef>
+          <a:fillRef idx="3">
+            <a:schemeClr val="accent1"/>
+          </a:fillRef>
+          <a:effectRef idx="0">
+            <a:schemeClr val="accent1"/>
+          </a:effectRef>
+          <a:fontRef idx="minor">
+            <a:schemeClr val="lt1"/>
+          </a:fontRef>
+        </p:style>
+        <p:txBody>
+          <a:bodyPr rtlCol="0" anchor="ctr"/>
+          <a:lstStyle/>
+          <a:p>
+            <a:pPr algn="ctr"/>
+          </a:p>
+        </p:txBody>
+      </p:sp>
+      <p:sp>
+        <p:nvSpPr>
+          <p:cNvPr id="5" name="遠い山"/>
+          <p:cNvSpPr/>
+          <p:nvPr/>
+        </p:nvSpPr>
+        <p:spPr>
+          <a:xfrm>
+            <a:off x="0" y="3030382"/>
+            <a:ext cx="12192000" cy="3826737"/>
           </a:xfrm>
           <a:custGeom>
             <a:avLst/>
@@ -6658,24 +6746,339 @@
             <a:cxnLst/>
             <a:rect l="l" t="t" r="r" b="b"/>
             <a:pathLst>
-              <a:path w="6342659" h="2628680">
+              <a:path w="12192000" h="3826737">
                 <a:moveTo>
-                  <a:pt x="0" y="2628680"/>
+                  <a:pt x="0" y="3826737"/>
                 </a:moveTo>
                 <a:lnTo>
-                  <a:pt x="0" y="1127584"/>
-                </a:lnTo>
-                <a:lnTo>
-                  <a:pt x="1832324" y="281896"/>
-                </a:lnTo>
-                <a:lnTo>
-                  <a:pt x="3030382" y="986636"/>
-                </a:lnTo>
-                <a:lnTo>
-                  <a:pt x="4510335" y="0"/>
-                </a:lnTo>
-                <a:lnTo>
-                  <a:pt x="6342659" y="2628680"/>
+                  <a:pt x="0" y="1479953"/>
+                </a:lnTo>
+                <a:lnTo>
+                  <a:pt x="99838" y="1467947"/>
+                </a:lnTo>
+                <a:lnTo>
+                  <a:pt x="199676" y="1432745"/>
+                </a:lnTo>
+                <a:lnTo>
+                  <a:pt x="299514" y="1376746"/>
+                </a:lnTo>
+                <a:lnTo>
+                  <a:pt x="399353" y="1303768"/>
+                </a:lnTo>
+                <a:lnTo>
+                  <a:pt x="499191" y="1218783"/>
+                </a:lnTo>
+                <a:lnTo>
+                  <a:pt x="599029" y="1127583"/>
+                </a:lnTo>
+                <a:lnTo>
+                  <a:pt x="698867" y="1036383"/>
+                </a:lnTo>
+                <a:lnTo>
+                  <a:pt x="798705" y="951398"/>
+                </a:lnTo>
+                <a:lnTo>
+                  <a:pt x="898543" y="878420"/>
+                </a:lnTo>
+                <a:lnTo>
+                  <a:pt x="998382" y="822422"/>
+                </a:lnTo>
+                <a:lnTo>
+                  <a:pt x="1098220" y="787220"/>
+                </a:lnTo>
+                <a:lnTo>
+                  <a:pt x="1198058" y="775213"/>
+                </a:lnTo>
+                <a:lnTo>
+                  <a:pt x="1292023" y="766809"/>
+                </a:lnTo>
+                <a:lnTo>
+                  <a:pt x="1385988" y="742167"/>
+                </a:lnTo>
+                <a:lnTo>
+                  <a:pt x="1479954" y="702969"/>
+                </a:lnTo>
+                <a:lnTo>
+                  <a:pt x="1573919" y="651884"/>
+                </a:lnTo>
+                <a:lnTo>
+                  <a:pt x="1667884" y="592394"/>
+                </a:lnTo>
+                <a:lnTo>
+                  <a:pt x="1761850" y="528554"/>
+                </a:lnTo>
+                <a:lnTo>
+                  <a:pt x="1855815" y="464714"/>
+                </a:lnTo>
+                <a:lnTo>
+                  <a:pt x="1949780" y="405225"/>
+                </a:lnTo>
+                <a:lnTo>
+                  <a:pt x="2043746" y="354140"/>
+                </a:lnTo>
+                <a:lnTo>
+                  <a:pt x="2137711" y="314941"/>
+                </a:lnTo>
+                <a:lnTo>
+                  <a:pt x="2231676" y="290300"/>
+                </a:lnTo>
+                <a:lnTo>
+                  <a:pt x="2325642" y="281895"/>
+                </a:lnTo>
+                <a:lnTo>
+                  <a:pt x="2437225" y="296304"/>
+                </a:lnTo>
+                <a:lnTo>
+                  <a:pt x="2548809" y="338546"/>
+                </a:lnTo>
+                <a:lnTo>
+                  <a:pt x="2660393" y="405744"/>
+                </a:lnTo>
+                <a:lnTo>
+                  <a:pt x="2771977" y="493317"/>
+                </a:lnTo>
+                <a:lnTo>
+                  <a:pt x="2883561" y="595299"/>
+                </a:lnTo>
+                <a:lnTo>
+                  <a:pt x="2995145" y="704739"/>
+                </a:lnTo>
+                <a:lnTo>
+                  <a:pt x="3106728" y="814179"/>
+                </a:lnTo>
+                <a:lnTo>
+                  <a:pt x="3218312" y="916161"/>
+                </a:lnTo>
+                <a:lnTo>
+                  <a:pt x="3329896" y="1003735"/>
+                </a:lnTo>
+                <a:lnTo>
+                  <a:pt x="3441480" y="1070933"/>
+                </a:lnTo>
+                <a:lnTo>
+                  <a:pt x="3553064" y="1113175"/>
+                </a:lnTo>
+                <a:lnTo>
+                  <a:pt x="3664647" y="1127583"/>
+                </a:lnTo>
+                <a:lnTo>
+                  <a:pt x="3805595" y="1140791"/>
+                </a:lnTo>
+                <a:lnTo>
+                  <a:pt x="3946543" y="1179513"/>
+                </a:lnTo>
+                <a:lnTo>
+                  <a:pt x="4087491" y="1241111"/>
+                </a:lnTo>
+                <a:lnTo>
+                  <a:pt x="4228439" y="1321387"/>
+                </a:lnTo>
+                <a:lnTo>
+                  <a:pt x="4369387" y="1414870"/>
+                </a:lnTo>
+                <a:lnTo>
+                  <a:pt x="4510335" y="1515190"/>
+                </a:lnTo>
+                <a:lnTo>
+                  <a:pt x="4651283" y="1615510"/>
+                </a:lnTo>
+                <a:lnTo>
+                  <a:pt x="4792231" y="1708994"/>
+                </a:lnTo>
+                <a:lnTo>
+                  <a:pt x="4933179" y="1789270"/>
+                </a:lnTo>
+                <a:lnTo>
+                  <a:pt x="5074127" y="1850868"/>
+                </a:lnTo>
+                <a:lnTo>
+                  <a:pt x="5215075" y="1889590"/>
+                </a:lnTo>
+                <a:lnTo>
+                  <a:pt x="5356023" y="1902797"/>
+                </a:lnTo>
+                <a:lnTo>
+                  <a:pt x="5485225" y="1908200"/>
+                </a:lnTo>
+                <a:lnTo>
+                  <a:pt x="5614428" y="1924041"/>
+                </a:lnTo>
+                <a:lnTo>
+                  <a:pt x="5743630" y="1949240"/>
+                </a:lnTo>
+                <a:lnTo>
+                  <a:pt x="5872832" y="1982080"/>
+                </a:lnTo>
+                <a:lnTo>
+                  <a:pt x="6002035" y="2020324"/>
+                </a:lnTo>
+                <a:lnTo>
+                  <a:pt x="6131237" y="2061364"/>
+                </a:lnTo>
+                <a:lnTo>
+                  <a:pt x="6260439" y="2102404"/>
+                </a:lnTo>
+                <a:lnTo>
+                  <a:pt x="6389642" y="2140647"/>
+                </a:lnTo>
+                <a:lnTo>
+                  <a:pt x="6518844" y="2173487"/>
+                </a:lnTo>
+                <a:lnTo>
+                  <a:pt x="6648046" y="2198686"/>
+                </a:lnTo>
+                <a:lnTo>
+                  <a:pt x="6777249" y="2214527"/>
+                </a:lnTo>
+                <a:lnTo>
+                  <a:pt x="6906451" y="2219930"/>
+                </a:lnTo>
+                <a:lnTo>
+                  <a:pt x="7035653" y="2210925"/>
+                </a:lnTo>
+                <a:lnTo>
+                  <a:pt x="7164855" y="2184524"/>
+                </a:lnTo>
+                <a:lnTo>
+                  <a:pt x="7294058" y="2142525"/>
+                </a:lnTo>
+                <a:lnTo>
+                  <a:pt x="7423260" y="2087791"/>
+                </a:lnTo>
+                <a:lnTo>
+                  <a:pt x="7552462" y="2024053"/>
+                </a:lnTo>
+                <a:lnTo>
+                  <a:pt x="7681665" y="1955653"/>
+                </a:lnTo>
+                <a:lnTo>
+                  <a:pt x="7810867" y="1887253"/>
+                </a:lnTo>
+                <a:lnTo>
+                  <a:pt x="7940069" y="1823514"/>
+                </a:lnTo>
+                <a:lnTo>
+                  <a:pt x="8069272" y="1768780"/>
+                </a:lnTo>
+                <a:lnTo>
+                  <a:pt x="8198474" y="1726782"/>
+                </a:lnTo>
+                <a:lnTo>
+                  <a:pt x="8327676" y="1700380"/>
+                </a:lnTo>
+                <a:lnTo>
+                  <a:pt x="8456879" y="1691375"/>
+                </a:lnTo>
+                <a:lnTo>
+                  <a:pt x="8574335" y="1673365"/>
+                </a:lnTo>
+                <a:lnTo>
+                  <a:pt x="8691792" y="1620562"/>
+                </a:lnTo>
+                <a:lnTo>
+                  <a:pt x="8809249" y="1536565"/>
+                </a:lnTo>
+                <a:lnTo>
+                  <a:pt x="8926705" y="1427098"/>
+                </a:lnTo>
+                <a:lnTo>
+                  <a:pt x="9044162" y="1299620"/>
+                </a:lnTo>
+                <a:lnTo>
+                  <a:pt x="9161618" y="1162820"/>
+                </a:lnTo>
+                <a:lnTo>
+                  <a:pt x="9279075" y="1026020"/>
+                </a:lnTo>
+                <a:lnTo>
+                  <a:pt x="9396532" y="898543"/>
+                </a:lnTo>
+                <a:lnTo>
+                  <a:pt x="9513988" y="789076"/>
+                </a:lnTo>
+                <a:lnTo>
+                  <a:pt x="9631445" y="705078"/>
+                </a:lnTo>
+                <a:lnTo>
+                  <a:pt x="9748902" y="652275"/>
+                </a:lnTo>
+                <a:lnTo>
+                  <a:pt x="9866358" y="634265"/>
+                </a:lnTo>
+                <a:lnTo>
+                  <a:pt x="9972069" y="623459"/>
+                </a:lnTo>
+                <a:lnTo>
+                  <a:pt x="10077780" y="591778"/>
+                </a:lnTo>
+                <a:lnTo>
+                  <a:pt x="10183491" y="541379"/>
+                </a:lnTo>
+                <a:lnTo>
+                  <a:pt x="10289202" y="475699"/>
+                </a:lnTo>
+                <a:lnTo>
+                  <a:pt x="10394913" y="399212"/>
+                </a:lnTo>
+                <a:lnTo>
+                  <a:pt x="10500624" y="317132"/>
+                </a:lnTo>
+                <a:lnTo>
+                  <a:pt x="10606335" y="235052"/>
+                </a:lnTo>
+                <a:lnTo>
+                  <a:pt x="10712046" y="158566"/>
+                </a:lnTo>
+                <a:lnTo>
+                  <a:pt x="10817757" y="92886"/>
+                </a:lnTo>
+                <a:lnTo>
+                  <a:pt x="10923468" y="42487"/>
+                </a:lnTo>
+                <a:lnTo>
+                  <a:pt x="11029179" y="10806"/>
+                </a:lnTo>
+                <a:lnTo>
+                  <a:pt x="11134890" y="0"/>
+                </a:lnTo>
+                <a:lnTo>
+                  <a:pt x="11222983" y="13207"/>
+                </a:lnTo>
+                <a:lnTo>
+                  <a:pt x="11311075" y="51929"/>
+                </a:lnTo>
+                <a:lnTo>
+                  <a:pt x="11399168" y="113527"/>
+                </a:lnTo>
+                <a:lnTo>
+                  <a:pt x="11487260" y="193803"/>
+                </a:lnTo>
+                <a:lnTo>
+                  <a:pt x="11575353" y="287286"/>
+                </a:lnTo>
+                <a:lnTo>
+                  <a:pt x="11663445" y="387606"/>
+                </a:lnTo>
+                <a:lnTo>
+                  <a:pt x="11751538" y="487926"/>
+                </a:lnTo>
+                <a:lnTo>
+                  <a:pt x="11839630" y="581410"/>
+                </a:lnTo>
+                <a:lnTo>
+                  <a:pt x="11927723" y="661686"/>
+                </a:lnTo>
+                <a:lnTo>
+                  <a:pt x="12015815" y="723284"/>
+                </a:lnTo>
+                <a:lnTo>
+                  <a:pt x="12103908" y="762006"/>
+                </a:lnTo>
+                <a:lnTo>
+                  <a:pt x="12192000" y="775213"/>
+                </a:lnTo>
+                <a:lnTo>
+                  <a:pt x="12192000" y="3826737"/>
                 </a:lnTo>
                 <a:close/>
               </a:path>
@@ -6713,14 +7116,14 @@
       </p:sp>
       <p:sp>
         <p:nvSpPr>
-          <p:cNvPr id="4" name="山2"/>
+          <p:cNvPr id="6" name="手前の山"/>
           <p:cNvSpPr/>
           <p:nvPr/>
         </p:nvSpPr>
         <p:spPr>
           <a:xfrm>
-            <a:off x="7399769" y="5356023"/>
-            <a:ext cx="4792231" cy="1501096"/>
+            <a:off x="0" y="4862705"/>
+            <a:ext cx="12192000" cy="1994414"/>
           </a:xfrm>
           <a:custGeom>
             <a:avLst/>
@@ -6729,28 +7132,274 @@
             <a:cxnLst/>
             <a:rect l="l" t="t" r="r" b="b"/>
             <a:pathLst>
-              <a:path w="4792231" h="1501096">
+              <a:path w="12192000" h="1994414">
                 <a:moveTo>
-                  <a:pt x="0" y="1501096"/>
+                  <a:pt x="0" y="1994414"/>
                 </a:moveTo>
                 <a:lnTo>
-                  <a:pt x="1973271" y="422844"/>
-                </a:lnTo>
-                <a:lnTo>
-                  <a:pt x="3030381" y="845688"/>
-                </a:lnTo>
-                <a:lnTo>
-                  <a:pt x="4792231" y="0"/>
-                </a:lnTo>
-                <a:lnTo>
-                  <a:pt x="4792231" y="1501096"/>
+                  <a:pt x="0" y="634266"/>
+                </a:lnTo>
+                <a:lnTo>
+                  <a:pt x="117457" y="623460"/>
+                </a:lnTo>
+                <a:lnTo>
+                  <a:pt x="234913" y="591778"/>
+                </a:lnTo>
+                <a:lnTo>
+                  <a:pt x="352370" y="541380"/>
+                </a:lnTo>
+                <a:lnTo>
+                  <a:pt x="469827" y="475700"/>
+                </a:lnTo>
+                <a:lnTo>
+                  <a:pt x="587283" y="399213"/>
+                </a:lnTo>
+                <a:lnTo>
+                  <a:pt x="704740" y="317133"/>
+                </a:lnTo>
+                <a:lnTo>
+                  <a:pt x="822197" y="235053"/>
+                </a:lnTo>
+                <a:lnTo>
+                  <a:pt x="939653" y="158567"/>
+                </a:lnTo>
+                <a:lnTo>
+                  <a:pt x="1057110" y="92886"/>
+                </a:lnTo>
+                <a:lnTo>
+                  <a:pt x="1174566" y="42488"/>
+                </a:lnTo>
+                <a:lnTo>
+                  <a:pt x="1292023" y="10806"/>
+                </a:lnTo>
+                <a:lnTo>
+                  <a:pt x="1409480" y="0"/>
+                </a:lnTo>
+                <a:lnTo>
+                  <a:pt x="1544555" y="6604"/>
+                </a:lnTo>
+                <a:lnTo>
+                  <a:pt x="1679630" y="25965"/>
+                </a:lnTo>
+                <a:lnTo>
+                  <a:pt x="1814705" y="56764"/>
+                </a:lnTo>
+                <a:lnTo>
+                  <a:pt x="1949780" y="96902"/>
+                </a:lnTo>
+                <a:lnTo>
+                  <a:pt x="2084855" y="143644"/>
+                </a:lnTo>
+                <a:lnTo>
+                  <a:pt x="2219931" y="193804"/>
+                </a:lnTo>
+                <a:lnTo>
+                  <a:pt x="2355006" y="243964"/>
+                </a:lnTo>
+                <a:lnTo>
+                  <a:pt x="2490081" y="290705"/>
+                </a:lnTo>
+                <a:lnTo>
+                  <a:pt x="2625156" y="330843"/>
+                </a:lnTo>
+                <a:lnTo>
+                  <a:pt x="2760231" y="361642"/>
+                </a:lnTo>
+                <a:lnTo>
+                  <a:pt x="2895306" y="381003"/>
+                </a:lnTo>
+                <a:lnTo>
+                  <a:pt x="3030382" y="387607"/>
+                </a:lnTo>
+                <a:lnTo>
+                  <a:pt x="3200694" y="396012"/>
+                </a:lnTo>
+                <a:lnTo>
+                  <a:pt x="3371006" y="420653"/>
+                </a:lnTo>
+                <a:lnTo>
+                  <a:pt x="3541318" y="459852"/>
+                </a:lnTo>
+                <a:lnTo>
+                  <a:pt x="3711630" y="510937"/>
+                </a:lnTo>
+                <a:lnTo>
+                  <a:pt x="3881942" y="570426"/>
+                </a:lnTo>
+                <a:lnTo>
+                  <a:pt x="4052254" y="634266"/>
+                </a:lnTo>
+                <a:lnTo>
+                  <a:pt x="4222566" y="698106"/>
+                </a:lnTo>
+                <a:lnTo>
+                  <a:pt x="4392879" y="757596"/>
+                </a:lnTo>
+                <a:lnTo>
+                  <a:pt x="4563191" y="808680"/>
+                </a:lnTo>
+                <a:lnTo>
+                  <a:pt x="4733503" y="847879"/>
+                </a:lnTo>
+                <a:lnTo>
+                  <a:pt x="4903815" y="872520"/>
+                </a:lnTo>
+                <a:lnTo>
+                  <a:pt x="5074127" y="880925"/>
+                </a:lnTo>
+                <a:lnTo>
+                  <a:pt x="5238566" y="885127"/>
+                </a:lnTo>
+                <a:lnTo>
+                  <a:pt x="5403006" y="897448"/>
+                </a:lnTo>
+                <a:lnTo>
+                  <a:pt x="5567445" y="917047"/>
+                </a:lnTo>
+                <a:lnTo>
+                  <a:pt x="5731884" y="942590"/>
+                </a:lnTo>
+                <a:lnTo>
+                  <a:pt x="5896324" y="972335"/>
+                </a:lnTo>
+                <a:lnTo>
+                  <a:pt x="6060763" y="1004255"/>
+                </a:lnTo>
+                <a:lnTo>
+                  <a:pt x="6225202" y="1036175"/>
+                </a:lnTo>
+                <a:lnTo>
+                  <a:pt x="6389642" y="1065919"/>
+                </a:lnTo>
+                <a:lnTo>
+                  <a:pt x="6554081" y="1091462"/>
+                </a:lnTo>
+                <a:lnTo>
+                  <a:pt x="6718520" y="1111061"/>
+                </a:lnTo>
+                <a:lnTo>
+                  <a:pt x="6882960" y="1123382"/>
+                </a:lnTo>
+                <a:lnTo>
+                  <a:pt x="7047399" y="1127584"/>
+                </a:lnTo>
+                <a:lnTo>
+                  <a:pt x="7223584" y="1121581"/>
+                </a:lnTo>
+                <a:lnTo>
+                  <a:pt x="7399769" y="1103980"/>
+                </a:lnTo>
+                <a:lnTo>
+                  <a:pt x="7575954" y="1075981"/>
+                </a:lnTo>
+                <a:lnTo>
+                  <a:pt x="7752139" y="1039492"/>
+                </a:lnTo>
+                <a:lnTo>
+                  <a:pt x="7928324" y="996999"/>
+                </a:lnTo>
+                <a:lnTo>
+                  <a:pt x="8104509" y="951399"/>
+                </a:lnTo>
+                <a:lnTo>
+                  <a:pt x="8280694" y="905799"/>
+                </a:lnTo>
+                <a:lnTo>
+                  <a:pt x="8456879" y="863307"/>
+                </a:lnTo>
+                <a:lnTo>
+                  <a:pt x="8633064" y="826817"/>
+                </a:lnTo>
+                <a:lnTo>
+                  <a:pt x="8809249" y="798818"/>
+                </a:lnTo>
+                <a:lnTo>
+                  <a:pt x="8985434" y="781217"/>
+                </a:lnTo>
+                <a:lnTo>
+                  <a:pt x="9161618" y="775214"/>
+                </a:lnTo>
+                <a:lnTo>
+                  <a:pt x="9279075" y="762007"/>
+                </a:lnTo>
+                <a:lnTo>
+                  <a:pt x="9396532" y="723285"/>
+                </a:lnTo>
+                <a:lnTo>
+                  <a:pt x="9513988" y="661687"/>
+                </a:lnTo>
+                <a:lnTo>
+                  <a:pt x="9631445" y="581411"/>
+                </a:lnTo>
+                <a:lnTo>
+                  <a:pt x="9748902" y="487927"/>
+                </a:lnTo>
+                <a:lnTo>
+                  <a:pt x="9866358" y="387607"/>
+                </a:lnTo>
+                <a:lnTo>
+                  <a:pt x="9983815" y="287287"/>
+                </a:lnTo>
+                <a:lnTo>
+                  <a:pt x="10101272" y="193804"/>
+                </a:lnTo>
+                <a:lnTo>
+                  <a:pt x="10218728" y="113528"/>
+                </a:lnTo>
+                <a:lnTo>
+                  <a:pt x="10336185" y="51930"/>
+                </a:lnTo>
+                <a:lnTo>
+                  <a:pt x="10453642" y="13208"/>
+                </a:lnTo>
+                <a:lnTo>
+                  <a:pt x="10571098" y="0"/>
+                </a:lnTo>
+                <a:lnTo>
+                  <a:pt x="10706173" y="4803"/>
+                </a:lnTo>
+                <a:lnTo>
+                  <a:pt x="10841249" y="18884"/>
+                </a:lnTo>
+                <a:lnTo>
+                  <a:pt x="10976324" y="41283"/>
+                </a:lnTo>
+                <a:lnTo>
+                  <a:pt x="11111399" y="70474"/>
+                </a:lnTo>
+                <a:lnTo>
+                  <a:pt x="11246474" y="104468"/>
+                </a:lnTo>
+                <a:lnTo>
+                  <a:pt x="11381549" y="140948"/>
+                </a:lnTo>
+                <a:lnTo>
+                  <a:pt x="11516624" y="177428"/>
+                </a:lnTo>
+                <a:lnTo>
+                  <a:pt x="11651699" y="211422"/>
+                </a:lnTo>
+                <a:lnTo>
+                  <a:pt x="11786775" y="240613"/>
+                </a:lnTo>
+                <a:lnTo>
+                  <a:pt x="11921850" y="263013"/>
+                </a:lnTo>
+                <a:lnTo>
+                  <a:pt x="12056925" y="277093"/>
+                </a:lnTo>
+                <a:lnTo>
+                  <a:pt x="12192000" y="281896"/>
+                </a:lnTo>
+                <a:lnTo>
+                  <a:pt x="12192000" y="1994414"/>
                 </a:lnTo>
                 <a:close/>
               </a:path>
             </a:pathLst>
           </a:custGeom>
           <a:solidFill>
-            <a:srgbClr val="8ACFC0"/>
+            <a:srgbClr val="64B3A1"/>
           </a:solidFill>
           <a:ln>
             <a:noFill/>
@@ -6781,7 +7430,213 @@
       </p:sp>
       <p:sp>
         <p:nvSpPr>
-          <p:cNvPr id="5" name="小見出し"/>
+          <p:cNvPr id="7" name="盆地の底"/>
+          <p:cNvSpPr/>
+          <p:nvPr/>
+        </p:nvSpPr>
+        <p:spPr>
+          <a:xfrm>
+            <a:off x="0" y="5884578"/>
+            <a:ext cx="12192000" cy="972541"/>
+          </a:xfrm>
+          <a:custGeom>
+            <a:avLst/>
+            <a:gdLst/>
+            <a:ahLst/>
+            <a:cxnLst/>
+            <a:rect l="l" t="t" r="r" b="b"/>
+            <a:pathLst>
+              <a:path w="12192000" h="972541">
+                <a:moveTo>
+                  <a:pt x="0" y="972541"/>
+                </a:moveTo>
+                <a:lnTo>
+                  <a:pt x="0" y="493318"/>
+                </a:lnTo>
+                <a:lnTo>
+                  <a:pt x="293642" y="490917"/>
+                </a:lnTo>
+                <a:lnTo>
+                  <a:pt x="587283" y="483876"/>
+                </a:lnTo>
+                <a:lnTo>
+                  <a:pt x="880925" y="472677"/>
+                </a:lnTo>
+                <a:lnTo>
+                  <a:pt x="1174566" y="458081"/>
+                </a:lnTo>
+                <a:lnTo>
+                  <a:pt x="1468208" y="441084"/>
+                </a:lnTo>
+                <a:lnTo>
+                  <a:pt x="1761850" y="422844"/>
+                </a:lnTo>
+                <a:lnTo>
+                  <a:pt x="2055491" y="404604"/>
+                </a:lnTo>
+                <a:lnTo>
+                  <a:pt x="2349133" y="387607"/>
+                </a:lnTo>
+                <a:lnTo>
+                  <a:pt x="2642775" y="373011"/>
+                </a:lnTo>
+                <a:lnTo>
+                  <a:pt x="2936416" y="361812"/>
+                </a:lnTo>
+                <a:lnTo>
+                  <a:pt x="3230058" y="354771"/>
+                </a:lnTo>
+                <a:lnTo>
+                  <a:pt x="3523699" y="352370"/>
+                </a:lnTo>
+                <a:lnTo>
+                  <a:pt x="3758613" y="349608"/>
+                </a:lnTo>
+                <a:lnTo>
+                  <a:pt x="3993526" y="341512"/>
+                </a:lnTo>
+                <a:lnTo>
+                  <a:pt x="4228439" y="328632"/>
+                </a:lnTo>
+                <a:lnTo>
+                  <a:pt x="4463353" y="311847"/>
+                </a:lnTo>
+                <a:lnTo>
+                  <a:pt x="4698266" y="292301"/>
+                </a:lnTo>
+                <a:lnTo>
+                  <a:pt x="4933179" y="271325"/>
+                </a:lnTo>
+                <a:lnTo>
+                  <a:pt x="5168092" y="250349"/>
+                </a:lnTo>
+                <a:lnTo>
+                  <a:pt x="5403006" y="230802"/>
+                </a:lnTo>
+                <a:lnTo>
+                  <a:pt x="5637919" y="214017"/>
+                </a:lnTo>
+                <a:lnTo>
+                  <a:pt x="5872832" y="201138"/>
+                </a:lnTo>
+                <a:lnTo>
+                  <a:pt x="6107746" y="193041"/>
+                </a:lnTo>
+                <a:lnTo>
+                  <a:pt x="6342659" y="190280"/>
+                </a:lnTo>
+                <a:lnTo>
+                  <a:pt x="6577572" y="191240"/>
+                </a:lnTo>
+                <a:lnTo>
+                  <a:pt x="6812486" y="194056"/>
+                </a:lnTo>
+                <a:lnTo>
+                  <a:pt x="7047399" y="198536"/>
+                </a:lnTo>
+                <a:lnTo>
+                  <a:pt x="7282312" y="204375"/>
+                </a:lnTo>
+                <a:lnTo>
+                  <a:pt x="7517225" y="211173"/>
+                </a:lnTo>
+                <a:lnTo>
+                  <a:pt x="7752139" y="218469"/>
+                </a:lnTo>
+                <a:lnTo>
+                  <a:pt x="7987052" y="225765"/>
+                </a:lnTo>
+                <a:lnTo>
+                  <a:pt x="8221965" y="232564"/>
+                </a:lnTo>
+                <a:lnTo>
+                  <a:pt x="8456879" y="238402"/>
+                </a:lnTo>
+                <a:lnTo>
+                  <a:pt x="8691792" y="242882"/>
+                </a:lnTo>
+                <a:lnTo>
+                  <a:pt x="8926705" y="245698"/>
+                </a:lnTo>
+                <a:lnTo>
+                  <a:pt x="9161618" y="246659"/>
+                </a:lnTo>
+                <a:lnTo>
+                  <a:pt x="9414150" y="242457"/>
+                </a:lnTo>
+                <a:lnTo>
+                  <a:pt x="9666682" y="230136"/>
+                </a:lnTo>
+                <a:lnTo>
+                  <a:pt x="9919214" y="210537"/>
+                </a:lnTo>
+                <a:lnTo>
+                  <a:pt x="10171746" y="184994"/>
+                </a:lnTo>
+                <a:lnTo>
+                  <a:pt x="10424277" y="155250"/>
+                </a:lnTo>
+                <a:lnTo>
+                  <a:pt x="10676809" y="123330"/>
+                </a:lnTo>
+                <a:lnTo>
+                  <a:pt x="10929341" y="91409"/>
+                </a:lnTo>
+                <a:lnTo>
+                  <a:pt x="11181873" y="61665"/>
+                </a:lnTo>
+                <a:lnTo>
+                  <a:pt x="11434405" y="36122"/>
+                </a:lnTo>
+                <a:lnTo>
+                  <a:pt x="11686936" y="16523"/>
+                </a:lnTo>
+                <a:lnTo>
+                  <a:pt x="11939468" y="4202"/>
+                </a:lnTo>
+                <a:lnTo>
+                  <a:pt x="12192000" y="0"/>
+                </a:lnTo>
+                <a:lnTo>
+                  <a:pt x="12192000" y="972541"/>
+                </a:lnTo>
+                <a:close/>
+              </a:path>
+            </a:pathLst>
+          </a:custGeom>
+          <a:solidFill>
+            <a:srgbClr val="E3F4F0"/>
+          </a:solidFill>
+          <a:ln>
+            <a:noFill/>
+          </a:ln>
+          <a:effectLst/>
+        </p:spPr>
+        <p:style>
+          <a:lnRef idx="1">
+            <a:schemeClr val="accent1"/>
+          </a:lnRef>
+          <a:fillRef idx="3">
+            <a:schemeClr val="accent1"/>
+          </a:fillRef>
+          <a:effectRef idx="0">
+            <a:schemeClr val="accent1"/>
+          </a:effectRef>
+          <a:fontRef idx="minor">
+            <a:schemeClr val="lt1"/>
+          </a:fontRef>
+        </p:style>
+        <p:txBody>
+          <a:bodyPr rtlCol="0" anchor="ctr"/>
+          <a:lstStyle/>
+          <a:p>
+            <a:pPr algn="ctr"/>
+          </a:p>
+        </p:txBody>
+      </p:sp>
+      <p:sp>
+        <p:nvSpPr>
+          <p:cNvPr id="8" name="小見出し"/>
           <p:cNvSpPr txBox="1"/>
           <p:nvPr/>
         </p:nvSpPr>
@@ -6828,7 +7683,7 @@
       </p:sp>
       <p:sp>
         <p:nvSpPr>
-          <p:cNvPr id="6" name="タイトル"/>
+          <p:cNvPr id="9" name="タイトル"/>
           <p:cNvSpPr txBox="1"/>
           <p:nvPr/>
         </p:nvSpPr>
@@ -6875,7 +7730,7 @@
       </p:sp>
       <p:cxnSp>
         <p:nvCxnSpPr>
-          <p:cNvPr id="7" name="ライン"/>
+          <p:cNvPr id="10" name="ライン"/>
           <p:cNvCxnSpPr/>
           <p:nvPr/>
         </p:nvCxnSpPr>
@@ -6911,7 +7766,7 @@
       </p:cxnSp>
       <p:sp>
         <p:nvSpPr>
-          <p:cNvPr id="8" name="キャッチ"/>
+          <p:cNvPr id="11" name="キャッチ"/>
           <p:cNvSpPr txBox="1"/>
           <p:nvPr/>
         </p:nvSpPr>
@@ -6982,7 +7837,7 @@
       </p:sp>
       <p:sp>
         <p:nvSpPr>
-          <p:cNvPr id="9" name="宛名"/>
+          <p:cNvPr id="12" name="宛名"/>
           <p:cNvSpPr txBox="1"/>
           <p:nvPr/>
         </p:nvSpPr>
@@ -7029,95 +7884,7 @@
       </p:sp>
       <p:sp>
         <p:nvSpPr>
-          <p:cNvPr id="10" name="太陽"/>
-          <p:cNvSpPr/>
-          <p:nvPr/>
-        </p:nvSpPr>
-        <p:spPr>
-          <a:xfrm>
-            <a:off x="9408277" y="739977"/>
-            <a:ext cx="2325642" cy="2325642"/>
-          </a:xfrm>
-          <a:prstGeom prst="ellipse">
-            <a:avLst/>
-          </a:prstGeom>
-          <a:solidFill>
-            <a:srgbClr val="8ACFC0"/>
-          </a:solidFill>
-          <a:ln>
-            <a:noFill/>
-          </a:ln>
-          <a:effectLst/>
-        </p:spPr>
-        <p:style>
-          <a:lnRef idx="1">
-            <a:schemeClr val="accent1"/>
-          </a:lnRef>
-          <a:fillRef idx="3">
-            <a:schemeClr val="accent1"/>
-          </a:fillRef>
-          <a:effectRef idx="0">
-            <a:schemeClr val="accent1"/>
-          </a:effectRef>
-          <a:fontRef idx="minor">
-            <a:schemeClr val="lt1"/>
-          </a:fontRef>
-        </p:style>
-        <p:txBody>
-          <a:bodyPr rtlCol="0" anchor="ctr"/>
-          <a:lstStyle/>
-          <a:p>
-            <a:pPr algn="ctr"/>
-          </a:p>
-        </p:txBody>
-      </p:sp>
-      <p:sp>
-        <p:nvSpPr>
-          <p:cNvPr id="11" name="太陽中"/>
-          <p:cNvSpPr/>
-          <p:nvPr/>
-        </p:nvSpPr>
-        <p:spPr>
-          <a:xfrm>
-            <a:off x="9866358" y="1198058"/>
-            <a:ext cx="1409480" cy="1409480"/>
-          </a:xfrm>
-          <a:prstGeom prst="ellipse">
-            <a:avLst/>
-          </a:prstGeom>
-          <a:solidFill>
-            <a:srgbClr val="A6DDD1"/>
-          </a:solidFill>
-          <a:ln>
-            <a:noFill/>
-          </a:ln>
-          <a:effectLst/>
-        </p:spPr>
-        <p:style>
-          <a:lnRef idx="1">
-            <a:schemeClr val="accent1"/>
-          </a:lnRef>
-          <a:fillRef idx="3">
-            <a:schemeClr val="accent1"/>
-          </a:fillRef>
-          <a:effectRef idx="0">
-            <a:schemeClr val="accent1"/>
-          </a:effectRef>
-          <a:fontRef idx="minor">
-            <a:schemeClr val="lt1"/>
-          </a:fontRef>
-        </p:style>
-        <p:txBody>
-          <a:bodyPr rtlCol="0" anchor="ctr"/>
-          <a:lstStyle/>
-          <a:p>
-            <a:pPr algn="ctr"/>
-          </a:p>
-        </p:txBody>
-      </p:sp>
-      <p:sp>
-        <p:nvSpPr>
-          <p:cNvPr id="12" name="飾り"/>
+          <p:cNvPr id="13" name="飾り"/>
           <p:cNvSpPr/>
           <p:nvPr/>
         </p:nvSpPr>
@@ -7161,7 +7928,7 @@
       </p:sp>
       <p:sp>
         <p:nvSpPr>
-          <p:cNvPr id="13" name="飾り"/>
+          <p:cNvPr id="14" name="飾り"/>
           <p:cNvSpPr/>
           <p:nvPr/>
         </p:nvSpPr>
@@ -7205,7 +7972,7 @@
       </p:sp>
       <p:sp>
         <p:nvSpPr>
-          <p:cNvPr id="14" name="飾り"/>
+          <p:cNvPr id="15" name="飾り"/>
           <p:cNvSpPr/>
           <p:nvPr/>
         </p:nvSpPr>
@@ -7249,7 +8016,7 @@
       </p:sp>
       <p:sp>
         <p:nvSpPr>
-          <p:cNvPr id="15" name="飾り"/>
+          <p:cNvPr id="16" name="飾り"/>
           <p:cNvSpPr/>
           <p:nvPr/>
         </p:nvSpPr>
@@ -7293,7 +8060,7 @@
       </p:sp>
       <p:sp>
         <p:nvSpPr>
-          <p:cNvPr id="16" name="飾り"/>
+          <p:cNvPr id="17" name="飾り"/>
           <p:cNvSpPr/>
           <p:nvPr/>
         </p:nvSpPr>
@@ -7337,57 +8104,13 @@
       </p:sp>
       <p:sp>
         <p:nvSpPr>
-          <p:cNvPr id="17" name="飾り"/>
-          <p:cNvSpPr/>
-          <p:nvPr/>
-        </p:nvSpPr>
-        <p:spPr>
-          <a:xfrm>
-            <a:off x="9605605" y="3262946"/>
-            <a:ext cx="98664" cy="98664"/>
-          </a:xfrm>
-          <a:prstGeom prst="ellipse">
-            <a:avLst/>
-          </a:prstGeom>
-          <a:solidFill>
-            <a:srgbClr val="FFFFFF"/>
-          </a:solidFill>
-          <a:ln>
-            <a:noFill/>
-          </a:ln>
-          <a:effectLst/>
-        </p:spPr>
-        <p:style>
-          <a:lnRef idx="1">
-            <a:schemeClr val="accent1"/>
-          </a:lnRef>
-          <a:fillRef idx="3">
-            <a:schemeClr val="accent1"/>
-          </a:fillRef>
-          <a:effectRef idx="0">
-            <a:schemeClr val="accent1"/>
-          </a:effectRef>
-          <a:fontRef idx="minor">
-            <a:schemeClr val="lt1"/>
-          </a:fontRef>
-        </p:style>
-        <p:txBody>
-          <a:bodyPr rtlCol="0" anchor="ctr"/>
-          <a:lstStyle/>
-          <a:p>
-            <a:pPr algn="ctr"/>
-          </a:p>
-        </p:txBody>
-      </p:sp>
-      <p:sp>
-        <p:nvSpPr>
           <p:cNvPr id="18" name="飾り"/>
           <p:cNvSpPr/>
           <p:nvPr/>
         </p:nvSpPr>
         <p:spPr>
           <a:xfrm>
-            <a:off x="10951658" y="4186155"/>
+            <a:off x="10951658" y="4468051"/>
             <a:ext cx="84569" cy="84569"/>
           </a:xfrm>
           <a:prstGeom prst="ellipse">
@@ -7439,8 +8162,8 @@
         </p:blipFill>
         <p:spPr>
           <a:xfrm>
-            <a:off x="7117873" y="2537064"/>
-            <a:ext cx="1761850" cy="847302"/>
+            <a:off x="9020671" y="3911306"/>
+            <a:ext cx="1339006" cy="643949"/>
           </a:xfrm>
           <a:prstGeom prst="rect">
             <a:avLst/>
@@ -7463,8 +8186,8 @@
         </p:blipFill>
         <p:spPr>
           <a:xfrm>
-            <a:off x="8456879" y="3664647"/>
-            <a:ext cx="1620902" cy="1089728"/>
+            <a:off x="10359676" y="4510335"/>
+            <a:ext cx="1268532" cy="852830"/>
           </a:xfrm>
           <a:prstGeom prst="rect">
             <a:avLst/>
@@ -7487,8 +8210,8 @@
         </p:blipFill>
         <p:spPr>
           <a:xfrm>
-            <a:off x="10359676" y="3312277"/>
-            <a:ext cx="1137397" cy="1057110"/>
+            <a:off x="7117873" y="4157965"/>
+            <a:ext cx="947831" cy="880925"/>
           </a:xfrm>
           <a:prstGeom prst="rect">
             <a:avLst/>
@@ -7511,8 +8234,8 @@
         </p:blipFill>
         <p:spPr>
           <a:xfrm>
-            <a:off x="5426497" y="5038890"/>
-            <a:ext cx="1747817" cy="1339006"/>
+            <a:off x="5356023" y="5250312"/>
+            <a:ext cx="1655827" cy="1268532"/>
           </a:xfrm>
           <a:prstGeom prst="rect">
             <a:avLst/>
@@ -7535,8 +8258,8 @@
         </p:blipFill>
         <p:spPr>
           <a:xfrm>
-            <a:off x="7230694" y="4862705"/>
-            <a:ext cx="1546325" cy="1515191"/>
+            <a:off x="7054134" y="5038890"/>
+            <a:ext cx="1510364" cy="1479954"/>
           </a:xfrm>
           <a:prstGeom prst="rect">
             <a:avLst/>
@@ -7559,8 +8282,8 @@
         </p:blipFill>
         <p:spPr>
           <a:xfrm>
-            <a:off x="8833398" y="4933179"/>
-            <a:ext cx="785829" cy="1444717"/>
+            <a:off x="8606783" y="5144601"/>
+            <a:ext cx="747496" cy="1374243"/>
           </a:xfrm>
           <a:prstGeom prst="rect">
             <a:avLst/>
@@ -7583,8 +8306,8 @@
         </p:blipFill>
         <p:spPr>
           <a:xfrm>
-            <a:off x="9675606" y="4721757"/>
-            <a:ext cx="1079281" cy="1656139"/>
+            <a:off x="9396563" y="4933179"/>
+            <a:ext cx="1033355" cy="1585665"/>
           </a:xfrm>
           <a:prstGeom prst="rect">
             <a:avLst/>
@@ -7607,8 +8330,8 @@
         </p:blipFill>
         <p:spPr>
           <a:xfrm>
-            <a:off x="10811267" y="5461734"/>
-            <a:ext cx="1252605" cy="916162"/>
+            <a:off x="10472202" y="5687251"/>
+            <a:ext cx="1136980" cy="831593"/>
           </a:xfrm>
           <a:prstGeom prst="rect">
             <a:avLst/>
@@ -54238,7 +54961,7 @@
         </p:nvSpPr>
         <p:spPr>
           <a:xfrm>
-            <a:off x="4009970" y="3988828"/>
+            <a:off x="3953591" y="3988828"/>
             <a:ext cx="902067" cy="310086"/>
           </a:xfrm>
           <a:prstGeom prst="roundRect">
@@ -54284,7 +55007,7 @@
         </p:nvSpPr>
         <p:spPr>
           <a:xfrm>
-            <a:off x="4009970" y="3988828"/>
+            <a:off x="3953591" y="3988828"/>
             <a:ext cx="902067" cy="310086"/>
           </a:xfrm>
           <a:prstGeom prst="rect">
@@ -54471,7 +55194,7 @@
         </p:nvSpPr>
         <p:spPr>
           <a:xfrm>
-            <a:off x="2678012" y="4411672"/>
+            <a:off x="2621632" y="4411672"/>
             <a:ext cx="902067" cy="310086"/>
           </a:xfrm>
           <a:prstGeom prst="roundRect">
@@ -54517,7 +55240,7 @@
         </p:nvSpPr>
         <p:spPr>
           <a:xfrm>
-            <a:off x="2678012" y="4411672"/>
+            <a:off x="2621632" y="4411672"/>
             <a:ext cx="902067" cy="310086"/>
           </a:xfrm>
           <a:prstGeom prst="rect">
@@ -54564,7 +55287,7 @@
         </p:nvSpPr>
         <p:spPr>
           <a:xfrm>
-            <a:off x="3678742" y="4411672"/>
+            <a:off x="3565984" y="4411672"/>
             <a:ext cx="902067" cy="310086"/>
           </a:xfrm>
           <a:prstGeom prst="roundRect">
@@ -54610,7 +55333,7 @@
         </p:nvSpPr>
         <p:spPr>
           <a:xfrm>
-            <a:off x="3678742" y="4411672"/>
+            <a:off x="3565984" y="4411672"/>
             <a:ext cx="902067" cy="310086"/>
           </a:xfrm>
           <a:prstGeom prst="rect">

</xml_diff>